<commit_message>
major chages to 34
</commit_message>
<xml_diff>
--- a/Lecture_Slides/PH 123 Lecture 34.pptx
+++ b/Lecture_Slides/PH 123 Lecture 34.pptx
@@ -5,7 +5,7 @@
     <p:sldMasterId id="2147483648" r:id="rId1"/>
   </p:sldMasterIdLst>
   <p:notesMasterIdLst>
-    <p:notesMasterId r:id="rId40"/>
+    <p:notesMasterId r:id="rId41"/>
   </p:notesMasterIdLst>
   <p:sldIdLst>
     <p:sldId id="271" r:id="rId2"/>
@@ -18,34 +18,35 @@
     <p:sldId id="284" r:id="rId9"/>
     <p:sldId id="285" r:id="rId10"/>
     <p:sldId id="257" r:id="rId11"/>
-    <p:sldId id="279" r:id="rId12"/>
-    <p:sldId id="280" r:id="rId13"/>
-    <p:sldId id="281" r:id="rId14"/>
-    <p:sldId id="282" r:id="rId15"/>
-    <p:sldId id="283" r:id="rId16"/>
-    <p:sldId id="268" r:id="rId17"/>
-    <p:sldId id="286" r:id="rId18"/>
-    <p:sldId id="287" r:id="rId19"/>
-    <p:sldId id="288" r:id="rId20"/>
-    <p:sldId id="289" r:id="rId21"/>
-    <p:sldId id="290" r:id="rId22"/>
-    <p:sldId id="291" r:id="rId23"/>
-    <p:sldId id="292" r:id="rId24"/>
-    <p:sldId id="293" r:id="rId25"/>
-    <p:sldId id="294" r:id="rId26"/>
-    <p:sldId id="272" r:id="rId27"/>
-    <p:sldId id="256" r:id="rId28"/>
-    <p:sldId id="258" r:id="rId29"/>
-    <p:sldId id="261" r:id="rId30"/>
-    <p:sldId id="266" r:id="rId31"/>
-    <p:sldId id="263" r:id="rId32"/>
-    <p:sldId id="269" r:id="rId33"/>
-    <p:sldId id="262" r:id="rId34"/>
-    <p:sldId id="260" r:id="rId35"/>
-    <p:sldId id="259" r:id="rId36"/>
-    <p:sldId id="265" r:id="rId37"/>
-    <p:sldId id="267" r:id="rId38"/>
-    <p:sldId id="270" r:id="rId39"/>
+    <p:sldId id="295" r:id="rId12"/>
+    <p:sldId id="279" r:id="rId13"/>
+    <p:sldId id="280" r:id="rId14"/>
+    <p:sldId id="281" r:id="rId15"/>
+    <p:sldId id="282" r:id="rId16"/>
+    <p:sldId id="283" r:id="rId17"/>
+    <p:sldId id="268" r:id="rId18"/>
+    <p:sldId id="286" r:id="rId19"/>
+    <p:sldId id="287" r:id="rId20"/>
+    <p:sldId id="288" r:id="rId21"/>
+    <p:sldId id="289" r:id="rId22"/>
+    <p:sldId id="290" r:id="rId23"/>
+    <p:sldId id="291" r:id="rId24"/>
+    <p:sldId id="292" r:id="rId25"/>
+    <p:sldId id="293" r:id="rId26"/>
+    <p:sldId id="294" r:id="rId27"/>
+    <p:sldId id="272" r:id="rId28"/>
+    <p:sldId id="256" r:id="rId29"/>
+    <p:sldId id="258" r:id="rId30"/>
+    <p:sldId id="261" r:id="rId31"/>
+    <p:sldId id="266" r:id="rId32"/>
+    <p:sldId id="263" r:id="rId33"/>
+    <p:sldId id="269" r:id="rId34"/>
+    <p:sldId id="262" r:id="rId35"/>
+    <p:sldId id="260" r:id="rId36"/>
+    <p:sldId id="259" r:id="rId37"/>
+    <p:sldId id="265" r:id="rId38"/>
+    <p:sldId id="267" r:id="rId39"/>
+    <p:sldId id="270" r:id="rId40"/>
   </p:sldIdLst>
   <p:sldSz cx="9144000" cy="6858000" type="screen4x3"/>
   <p:notesSz cx="6858000" cy="9144000"/>
@@ -166,7 +167,7 @@
 <file path=ppt/revisionInfo.xml><?xml version="1.0" encoding="utf-8"?>
 <p1510:revInfo xmlns:a="http://schemas.openxmlformats.org/drawingml/2006/main" xmlns:r="http://schemas.openxmlformats.org/officeDocument/2006/relationships" xmlns:p1510="http://schemas.microsoft.com/office/powerpoint/2015/10/main">
   <p1510:revLst>
-    <p1510:client id="{EB4EA074-9182-46B1-B159-B90F3618D25B}" v="72" dt="2025-07-03T19:53:42.136"/>
+    <p1510:client id="{EB4EA074-9182-46B1-B159-B90F3618D25B}" v="75" dt="2025-07-07T15:39:46.207"/>
   </p1510:revLst>
 </p1510:revInfo>
 </file>
@@ -176,18 +177,26 @@
   <pc:docChgLst>
     <pc:chgData name="Lines, Todd" userId="afaf7c3a-e8aa-4568-882a-02ad8f9e19b0" providerId="ADAL" clId="{EB4EA074-9182-46B1-B159-B90F3618D25B}"/>
     <pc:docChg chg="undo custSel addSld modSld sldOrd">
-      <pc:chgData name="Lines, Todd" userId="afaf7c3a-e8aa-4568-882a-02ad8f9e19b0" providerId="ADAL" clId="{EB4EA074-9182-46B1-B159-B90F3618D25B}" dt="2025-07-03T19:53:46.159" v="213" actId="21"/>
+      <pc:chgData name="Lines, Todd" userId="afaf7c3a-e8aa-4568-882a-02ad8f9e19b0" providerId="ADAL" clId="{EB4EA074-9182-46B1-B159-B90F3618D25B}" dt="2025-07-07T15:39:52.166" v="233" actId="21"/>
       <pc:docMkLst>
         <pc:docMk/>
       </pc:docMkLst>
-      <pc:sldChg chg="delSp modSp add mod">
-        <pc:chgData name="Lines, Todd" userId="afaf7c3a-e8aa-4568-882a-02ad8f9e19b0" providerId="ADAL" clId="{EB4EA074-9182-46B1-B159-B90F3618D25B}" dt="2025-07-03T18:13:09.341" v="24" actId="21"/>
+      <pc:sldChg chg="addSp delSp modSp add mod">
+        <pc:chgData name="Lines, Todd" userId="afaf7c3a-e8aa-4568-882a-02ad8f9e19b0" providerId="ADAL" clId="{EB4EA074-9182-46B1-B159-B90F3618D25B}" dt="2025-07-07T15:39:08.561" v="227" actId="22"/>
         <pc:sldMkLst>
           <pc:docMk/>
           <pc:sldMk cId="0" sldId="257"/>
         </pc:sldMkLst>
+        <pc:spChg chg="add del">
+          <ac:chgData name="Lines, Todd" userId="afaf7c3a-e8aa-4568-882a-02ad8f9e19b0" providerId="ADAL" clId="{EB4EA074-9182-46B1-B159-B90F3618D25B}" dt="2025-07-07T15:39:08.561" v="227" actId="22"/>
+          <ac:spMkLst>
+            <pc:docMk/>
+            <pc:sldMk cId="0" sldId="257"/>
+            <ac:spMk id="4" creationId="{175BD6A8-FDA8-F5A9-3172-315A56AF31CC}"/>
+          </ac:spMkLst>
+        </pc:spChg>
         <pc:spChg chg="mod">
-          <ac:chgData name="Lines, Todd" userId="afaf7c3a-e8aa-4568-882a-02ad8f9e19b0" providerId="ADAL" clId="{EB4EA074-9182-46B1-B159-B90F3618D25B}" dt="2025-07-03T18:12:48.839" v="19" actId="20577"/>
+          <ac:chgData name="Lines, Todd" userId="afaf7c3a-e8aa-4568-882a-02ad8f9e19b0" providerId="ADAL" clId="{EB4EA074-9182-46B1-B159-B90F3618D25B}" dt="2025-07-07T15:33:17.699" v="221" actId="20577"/>
           <ac:spMkLst>
             <pc:docMk/>
             <pc:sldMk cId="0" sldId="257"/>
@@ -195,7 +204,7 @@
           </ac:spMkLst>
         </pc:spChg>
         <pc:spChg chg="mod">
-          <ac:chgData name="Lines, Todd" userId="afaf7c3a-e8aa-4568-882a-02ad8f9e19b0" providerId="ADAL" clId="{EB4EA074-9182-46B1-B159-B90F3618D25B}" dt="2025-07-03T18:12:54.614" v="22" actId="20577"/>
+          <ac:chgData name="Lines, Todd" userId="afaf7c3a-e8aa-4568-882a-02ad8f9e19b0" providerId="ADAL" clId="{EB4EA074-9182-46B1-B159-B90F3618D25B}" dt="2025-07-07T15:33:23.826" v="223" actId="20577"/>
           <ac:spMkLst>
             <pc:docMk/>
             <pc:sldMk cId="0" sldId="257"/>
@@ -203,11 +212,11 @@
           </ac:spMkLst>
         </pc:spChg>
         <pc:picChg chg="del mod">
-          <ac:chgData name="Lines, Todd" userId="afaf7c3a-e8aa-4568-882a-02ad8f9e19b0" providerId="ADAL" clId="{EB4EA074-9182-46B1-B159-B90F3618D25B}" dt="2025-07-03T18:13:09.341" v="24" actId="21"/>
+          <ac:chgData name="Lines, Todd" userId="afaf7c3a-e8aa-4568-882a-02ad8f9e19b0" providerId="ADAL" clId="{EB4EA074-9182-46B1-B159-B90F3618D25B}" dt="2025-07-07T15:33:35.951" v="225" actId="21"/>
           <ac:picMkLst>
             <pc:docMk/>
             <pc:sldMk cId="0" sldId="257"/>
-            <ac:picMk id="2" creationId="{F7B7D251-505B-9A3F-D108-9773C3E7AF8D}"/>
+            <ac:picMk id="2" creationId="{9E7908BE-DFB3-A5AA-F5C5-7ADD549554DA}"/>
           </ac:picMkLst>
         </pc:picChg>
       </pc:sldChg>
@@ -239,22 +248,6 @@
           <pc:docMk/>
           <pc:sldMk cId="684432333" sldId="272"/>
         </pc:sldMkLst>
-        <pc:spChg chg="del mod ord">
-          <ac:chgData name="Lines, Todd" userId="afaf7c3a-e8aa-4568-882a-02ad8f9e19b0" providerId="ADAL" clId="{EB4EA074-9182-46B1-B159-B90F3618D25B}" dt="2025-07-03T17:36:59.879" v="12" actId="700"/>
-          <ac:spMkLst>
-            <pc:docMk/>
-            <pc:sldMk cId="684432333" sldId="272"/>
-            <ac:spMk id="2" creationId="{812C50CA-FF04-55CF-805C-E08D146CC100}"/>
-          </ac:spMkLst>
-        </pc:spChg>
-        <pc:spChg chg="del mod ord">
-          <ac:chgData name="Lines, Todd" userId="afaf7c3a-e8aa-4568-882a-02ad8f9e19b0" providerId="ADAL" clId="{EB4EA074-9182-46B1-B159-B90F3618D25B}" dt="2025-07-03T17:36:59.879" v="12" actId="700"/>
-          <ac:spMkLst>
-            <pc:docMk/>
-            <pc:sldMk cId="684432333" sldId="272"/>
-            <ac:spMk id="3" creationId="{4069CEEB-8E5C-E725-F121-BE292B3B8E05}"/>
-          </ac:spMkLst>
-        </pc:spChg>
         <pc:spChg chg="add mod ord">
           <ac:chgData name="Lines, Todd" userId="afaf7c3a-e8aa-4568-882a-02ad8f9e19b0" providerId="ADAL" clId="{EB4EA074-9182-46B1-B159-B90F3618D25B}" dt="2025-07-03T17:37:01.762" v="15" actId="20577"/>
           <ac:spMkLst>
@@ -272,12 +265,20 @@
           </ac:spMkLst>
         </pc:spChg>
       </pc:sldChg>
-      <pc:sldChg chg="add">
-        <pc:chgData name="Lines, Todd" userId="afaf7c3a-e8aa-4568-882a-02ad8f9e19b0" providerId="ADAL" clId="{EB4EA074-9182-46B1-B159-B90F3618D25B}" dt="2025-07-03T18:12:05.648" v="16"/>
+      <pc:sldChg chg="modSp add mod">
+        <pc:chgData name="Lines, Todd" userId="afaf7c3a-e8aa-4568-882a-02ad8f9e19b0" providerId="ADAL" clId="{EB4EA074-9182-46B1-B159-B90F3618D25B}" dt="2025-07-07T15:14:56.119" v="214" actId="20577"/>
         <pc:sldMkLst>
           <pc:docMk/>
           <pc:sldMk cId="3199979828" sldId="273"/>
         </pc:sldMkLst>
+        <pc:spChg chg="mod">
+          <ac:chgData name="Lines, Todd" userId="afaf7c3a-e8aa-4568-882a-02ad8f9e19b0" providerId="ADAL" clId="{EB4EA074-9182-46B1-B159-B90F3618D25B}" dt="2025-07-07T15:14:56.119" v="214" actId="20577"/>
+          <ac:spMkLst>
+            <pc:docMk/>
+            <pc:sldMk cId="3199979828" sldId="273"/>
+            <ac:spMk id="3" creationId="{00000000-0000-0000-0000-000000000000}"/>
+          </ac:spMkLst>
+        </pc:spChg>
       </pc:sldChg>
       <pc:sldChg chg="add">
         <pc:chgData name="Lines, Todd" userId="afaf7c3a-e8aa-4568-882a-02ad8f9e19b0" providerId="ADAL" clId="{EB4EA074-9182-46B1-B159-B90F3618D25B}" dt="2025-07-03T18:12:05.648" v="16"/>
@@ -286,12 +287,20 @@
           <pc:sldMk cId="3821452460" sldId="274"/>
         </pc:sldMkLst>
       </pc:sldChg>
-      <pc:sldChg chg="add">
-        <pc:chgData name="Lines, Todd" userId="afaf7c3a-e8aa-4568-882a-02ad8f9e19b0" providerId="ADAL" clId="{EB4EA074-9182-46B1-B159-B90F3618D25B}" dt="2025-07-03T18:12:05.648" v="16"/>
+      <pc:sldChg chg="modSp add mod">
+        <pc:chgData name="Lines, Todd" userId="afaf7c3a-e8aa-4568-882a-02ad8f9e19b0" providerId="ADAL" clId="{EB4EA074-9182-46B1-B159-B90F3618D25B}" dt="2025-07-07T15:16:57.497" v="215" actId="20577"/>
         <pc:sldMkLst>
           <pc:docMk/>
           <pc:sldMk cId="3566709877" sldId="275"/>
         </pc:sldMkLst>
+        <pc:spChg chg="mod">
+          <ac:chgData name="Lines, Todd" userId="afaf7c3a-e8aa-4568-882a-02ad8f9e19b0" providerId="ADAL" clId="{EB4EA074-9182-46B1-B159-B90F3618D25B}" dt="2025-07-07T15:16:57.497" v="215" actId="20577"/>
+          <ac:spMkLst>
+            <pc:docMk/>
+            <pc:sldMk cId="3566709877" sldId="275"/>
+            <ac:spMk id="3" creationId="{00000000-0000-0000-0000-000000000000}"/>
+          </ac:spMkLst>
+        </pc:spChg>
       </pc:sldChg>
       <pc:sldChg chg="add">
         <pc:chgData name="Lines, Todd" userId="afaf7c3a-e8aa-4568-882a-02ad8f9e19b0" providerId="ADAL" clId="{EB4EA074-9182-46B1-B159-B90F3618D25B}" dt="2025-07-03T18:12:05.648" v="16"/>
@@ -369,22 +378,6 @@
           <pc:docMk/>
           <pc:sldMk cId="3648711558" sldId="286"/>
         </pc:sldMkLst>
-        <pc:spChg chg="del">
-          <ac:chgData name="Lines, Todd" userId="afaf7c3a-e8aa-4568-882a-02ad8f9e19b0" providerId="ADAL" clId="{EB4EA074-9182-46B1-B159-B90F3618D25B}" dt="2025-07-03T19:34:57.425" v="28" actId="478"/>
-          <ac:spMkLst>
-            <pc:docMk/>
-            <pc:sldMk cId="3648711558" sldId="286"/>
-            <ac:spMk id="2" creationId="{098714DA-6A74-DDD9-D387-2186148AFE4E}"/>
-          </ac:spMkLst>
-        </pc:spChg>
-        <pc:spChg chg="del">
-          <ac:chgData name="Lines, Todd" userId="afaf7c3a-e8aa-4568-882a-02ad8f9e19b0" providerId="ADAL" clId="{EB4EA074-9182-46B1-B159-B90F3618D25B}" dt="2025-07-03T19:34:57.425" v="28" actId="478"/>
-          <ac:spMkLst>
-            <pc:docMk/>
-            <pc:sldMk cId="3648711558" sldId="286"/>
-            <ac:spMk id="3" creationId="{90E88B3E-12BE-3824-9F59-6C0788207F8F}"/>
-          </ac:spMkLst>
-        </pc:spChg>
         <pc:spChg chg="add mod">
           <ac:chgData name="Lines, Todd" userId="afaf7c3a-e8aa-4568-882a-02ad8f9e19b0" providerId="ADAL" clId="{EB4EA074-9182-46B1-B159-B90F3618D25B}" dt="2025-07-03T19:36:13.473" v="47" actId="1076"/>
           <ac:spMkLst>
@@ -408,22 +401,6 @@
           <pc:docMk/>
           <pc:sldMk cId="3821176378" sldId="287"/>
         </pc:sldMkLst>
-        <pc:spChg chg="del">
-          <ac:chgData name="Lines, Todd" userId="afaf7c3a-e8aa-4568-882a-02ad8f9e19b0" providerId="ADAL" clId="{EB4EA074-9182-46B1-B159-B90F3618D25B}" dt="2025-07-03T19:35:38.799" v="34" actId="478"/>
-          <ac:spMkLst>
-            <pc:docMk/>
-            <pc:sldMk cId="3821176378" sldId="287"/>
-            <ac:spMk id="2" creationId="{1F0BC490-E757-E1E8-0A7B-C54C8C10C60D}"/>
-          </ac:spMkLst>
-        </pc:spChg>
-        <pc:spChg chg="del">
-          <ac:chgData name="Lines, Todd" userId="afaf7c3a-e8aa-4568-882a-02ad8f9e19b0" providerId="ADAL" clId="{EB4EA074-9182-46B1-B159-B90F3618D25B}" dt="2025-07-03T19:35:38.799" v="34" actId="478"/>
-          <ac:spMkLst>
-            <pc:docMk/>
-            <pc:sldMk cId="3821176378" sldId="287"/>
-            <ac:spMk id="3" creationId="{59AC036A-0BC6-3ACC-1E43-F41BA7E9E046}"/>
-          </ac:spMkLst>
-        </pc:spChg>
         <pc:spChg chg="add mod">
           <ac:chgData name="Lines, Todd" userId="afaf7c3a-e8aa-4568-882a-02ad8f9e19b0" providerId="ADAL" clId="{EB4EA074-9182-46B1-B159-B90F3618D25B}" dt="2025-07-03T19:36:23.732" v="49"/>
           <ac:spMkLst>
@@ -447,30 +424,6 @@
           <pc:docMk/>
           <pc:sldMk cId="1799581950" sldId="288"/>
         </pc:sldMkLst>
-        <pc:spChg chg="del">
-          <ac:chgData name="Lines, Todd" userId="afaf7c3a-e8aa-4568-882a-02ad8f9e19b0" providerId="ADAL" clId="{EB4EA074-9182-46B1-B159-B90F3618D25B}" dt="2025-07-03T19:36:38.032" v="51" actId="478"/>
-          <ac:spMkLst>
-            <pc:docMk/>
-            <pc:sldMk cId="1799581950" sldId="288"/>
-            <ac:spMk id="2" creationId="{1A9B30EC-30F0-785A-F2D0-419A48D3D12C}"/>
-          </ac:spMkLst>
-        </pc:spChg>
-        <pc:spChg chg="del">
-          <ac:chgData name="Lines, Todd" userId="afaf7c3a-e8aa-4568-882a-02ad8f9e19b0" providerId="ADAL" clId="{EB4EA074-9182-46B1-B159-B90F3618D25B}" dt="2025-07-03T19:36:38.032" v="51" actId="478"/>
-          <ac:spMkLst>
-            <pc:docMk/>
-            <pc:sldMk cId="1799581950" sldId="288"/>
-            <ac:spMk id="3" creationId="{E0AB031D-1992-1677-4AF1-C4D97B72698B}"/>
-          </ac:spMkLst>
-        </pc:spChg>
-        <pc:spChg chg="add del">
-          <ac:chgData name="Lines, Todd" userId="afaf7c3a-e8aa-4568-882a-02ad8f9e19b0" providerId="ADAL" clId="{EB4EA074-9182-46B1-B159-B90F3618D25B}" dt="2025-07-03T19:36:50.745" v="57" actId="22"/>
-          <ac:spMkLst>
-            <pc:docMk/>
-            <pc:sldMk cId="1799581950" sldId="288"/>
-            <ac:spMk id="7" creationId="{D21F5FAF-59E0-B3B7-2BD7-94A894CC5909}"/>
-          </ac:spMkLst>
-        </pc:spChg>
         <pc:spChg chg="add mod">
           <ac:chgData name="Lines, Todd" userId="afaf7c3a-e8aa-4568-882a-02ad8f9e19b0" providerId="ADAL" clId="{EB4EA074-9182-46B1-B159-B90F3618D25B}" dt="2025-07-03T19:36:59.370" v="59" actId="1076"/>
           <ac:spMkLst>
@@ -518,36 +471,12 @@
             <ac:spMk id="3" creationId="{D328EF3A-FE6A-8E4A-FCC8-7914B7F8AC4E}"/>
           </ac:spMkLst>
         </pc:spChg>
-        <pc:spChg chg="add del mod">
-          <ac:chgData name="Lines, Todd" userId="afaf7c3a-e8aa-4568-882a-02ad8f9e19b0" providerId="ADAL" clId="{EB4EA074-9182-46B1-B159-B90F3618D25B}" dt="2025-07-03T19:38:27.872" v="76" actId="478"/>
-          <ac:spMkLst>
-            <pc:docMk/>
-            <pc:sldMk cId="2472156754" sldId="289"/>
-            <ac:spMk id="4" creationId="{25EAE1B6-4BCB-7E9C-B527-45FFF66B2386}"/>
-          </ac:spMkLst>
-        </pc:spChg>
         <pc:spChg chg="add mod">
           <ac:chgData name="Lines, Todd" userId="afaf7c3a-e8aa-4568-882a-02ad8f9e19b0" providerId="ADAL" clId="{EB4EA074-9182-46B1-B159-B90F3618D25B}" dt="2025-07-03T19:39:48.675" v="98" actId="1076"/>
           <ac:spMkLst>
             <pc:docMk/>
             <pc:sldMk cId="2472156754" sldId="289"/>
             <ac:spMk id="6" creationId="{23E5B7E2-7FBD-C035-1803-A9D4D01E2E94}"/>
-          </ac:spMkLst>
-        </pc:spChg>
-        <pc:spChg chg="del">
-          <ac:chgData name="Lines, Todd" userId="afaf7c3a-e8aa-4568-882a-02ad8f9e19b0" providerId="ADAL" clId="{EB4EA074-9182-46B1-B159-B90F3618D25B}" dt="2025-07-03T19:37:31.729" v="65" actId="478"/>
-          <ac:spMkLst>
-            <pc:docMk/>
-            <pc:sldMk cId="2472156754" sldId="289"/>
-            <ac:spMk id="8" creationId="{F96FDCD0-E35F-3D4B-D3BB-DC819A5DB8CC}"/>
-          </ac:spMkLst>
-        </pc:spChg>
-        <pc:spChg chg="del">
-          <ac:chgData name="Lines, Todd" userId="afaf7c3a-e8aa-4568-882a-02ad8f9e19b0" providerId="ADAL" clId="{EB4EA074-9182-46B1-B159-B90F3618D25B}" dt="2025-07-03T19:37:29.904" v="64" actId="478"/>
-          <ac:spMkLst>
-            <pc:docMk/>
-            <pc:sldMk cId="2472156754" sldId="289"/>
-            <ac:spMk id="9" creationId="{F133ECB8-8D41-1A9B-76D3-4B0FF5EA1F35}"/>
           </ac:spMkLst>
         </pc:spChg>
         <pc:spChg chg="add mod">
@@ -566,22 +495,6 @@
             <ac:spMk id="15" creationId="{85DFF3C5-691F-03D3-6CEB-238652E848C5}"/>
           </ac:spMkLst>
         </pc:spChg>
-        <pc:picChg chg="del mod">
-          <ac:chgData name="Lines, Todd" userId="afaf7c3a-e8aa-4568-882a-02ad8f9e19b0" providerId="ADAL" clId="{EB4EA074-9182-46B1-B159-B90F3618D25B}" dt="2025-07-03T19:43:16.442" v="139" actId="21"/>
-          <ac:picMkLst>
-            <pc:docMk/>
-            <pc:sldMk cId="2472156754" sldId="289"/>
-            <ac:picMk id="13" creationId="{26E49AB5-A7F8-A7E5-9822-E53424C03B7A}"/>
-          </ac:picMkLst>
-        </pc:picChg>
-        <pc:picChg chg="del mod">
-          <ac:chgData name="Lines, Todd" userId="afaf7c3a-e8aa-4568-882a-02ad8f9e19b0" providerId="ADAL" clId="{EB4EA074-9182-46B1-B159-B90F3618D25B}" dt="2025-07-03T19:46:44.153" v="164" actId="21"/>
-          <ac:picMkLst>
-            <pc:docMk/>
-            <pc:sldMk cId="2472156754" sldId="289"/>
-            <ac:picMk id="16" creationId="{432ED067-A664-5413-E74F-15585913C2C3}"/>
-          </ac:picMkLst>
-        </pc:picChg>
         <pc:cxnChg chg="add mod ord">
           <ac:chgData name="Lines, Todd" userId="afaf7c3a-e8aa-4568-882a-02ad8f9e19b0" providerId="ADAL" clId="{EB4EA074-9182-46B1-B159-B90F3618D25B}" dt="2025-07-03T19:39:42.863" v="97"/>
           <ac:cxnSpMkLst>
@@ -597,14 +510,6 @@
           <pc:docMk/>
           <pc:sldMk cId="1645867229" sldId="290"/>
         </pc:sldMkLst>
-        <pc:spChg chg="add del mod">
-          <ac:chgData name="Lines, Todd" userId="afaf7c3a-e8aa-4568-882a-02ad8f9e19b0" providerId="ADAL" clId="{EB4EA074-9182-46B1-B159-B90F3618D25B}" dt="2025-07-03T19:40:10.672" v="101" actId="478"/>
-          <ac:spMkLst>
-            <pc:docMk/>
-            <pc:sldMk cId="1645867229" sldId="290"/>
-            <ac:spMk id="4" creationId="{5293506F-431F-89B5-7439-C75A26C7B973}"/>
-          </ac:spMkLst>
-        </pc:spChg>
         <pc:spChg chg="add mod">
           <ac:chgData name="Lines, Todd" userId="afaf7c3a-e8aa-4568-882a-02ad8f9e19b0" providerId="ADAL" clId="{EB4EA074-9182-46B1-B159-B90F3618D25B}" dt="2025-07-03T19:46:16.965" v="159"/>
           <ac:spMkLst>
@@ -621,14 +526,6 @@
             <ac:spMk id="12" creationId="{2399D201-65B1-A8FF-828E-D3D52BFCB45A}"/>
           </ac:spMkLst>
         </pc:spChg>
-        <pc:picChg chg="del mod">
-          <ac:chgData name="Lines, Todd" userId="afaf7c3a-e8aa-4568-882a-02ad8f9e19b0" providerId="ADAL" clId="{EB4EA074-9182-46B1-B159-B90F3618D25B}" dt="2025-07-03T19:47:15.942" v="166" actId="21"/>
-          <ac:picMkLst>
-            <pc:docMk/>
-            <pc:sldMk cId="1645867229" sldId="290"/>
-            <ac:picMk id="13" creationId="{310AAB7E-1525-DE5C-D295-AEE162CDF1CF}"/>
-          </ac:picMkLst>
-        </pc:picChg>
         <pc:cxnChg chg="add mod">
           <ac:chgData name="Lines, Todd" userId="afaf7c3a-e8aa-4568-882a-02ad8f9e19b0" providerId="ADAL" clId="{EB4EA074-9182-46B1-B159-B90F3618D25B}" dt="2025-07-03T19:40:19.048" v="104" actId="14100"/>
           <ac:cxnSpMkLst>
@@ -684,14 +581,6 @@
             <ac:spMk id="14" creationId="{7D2AA761-C573-4B5C-C0DF-2A43F74F9F9B}"/>
           </ac:spMkLst>
         </pc:spChg>
-        <pc:picChg chg="del mod">
-          <ac:chgData name="Lines, Todd" userId="afaf7c3a-e8aa-4568-882a-02ad8f9e19b0" providerId="ADAL" clId="{EB4EA074-9182-46B1-B159-B90F3618D25B}" dt="2025-07-03T19:47:39.427" v="168" actId="21"/>
-          <ac:picMkLst>
-            <pc:docMk/>
-            <pc:sldMk cId="284872288" sldId="291"/>
-            <ac:picMk id="15" creationId="{5C4828FA-C14D-3331-0424-D3973EFAF205}"/>
-          </ac:picMkLst>
-        </pc:picChg>
         <pc:cxnChg chg="add mod">
           <ac:chgData name="Lines, Todd" userId="afaf7c3a-e8aa-4568-882a-02ad8f9e19b0" providerId="ADAL" clId="{EB4EA074-9182-46B1-B159-B90F3618D25B}" dt="2025-07-03T19:40:53.984" v="116" actId="1037"/>
           <ac:cxnSpMkLst>
@@ -739,30 +628,6 @@
             <ac:spMk id="11" creationId="{27B9FA19-579F-83CF-0AF8-713C2E0EC404}"/>
           </ac:spMkLst>
         </pc:spChg>
-        <pc:cxnChg chg="del">
-          <ac:chgData name="Lines, Todd" userId="afaf7c3a-e8aa-4568-882a-02ad8f9e19b0" providerId="ADAL" clId="{EB4EA074-9182-46B1-B159-B90F3618D25B}" dt="2025-07-03T19:41:47.888" v="123" actId="478"/>
-          <ac:cxnSpMkLst>
-            <pc:docMk/>
-            <pc:sldMk cId="1705925922" sldId="292"/>
-            <ac:cxnSpMk id="7" creationId="{D3E44DBE-D651-638F-87FB-FE83F298682A}"/>
-          </ac:cxnSpMkLst>
-        </pc:cxnChg>
-        <pc:cxnChg chg="del">
-          <ac:chgData name="Lines, Todd" userId="afaf7c3a-e8aa-4568-882a-02ad8f9e19b0" providerId="ADAL" clId="{EB4EA074-9182-46B1-B159-B90F3618D25B}" dt="2025-07-03T19:41:50.142" v="125" actId="478"/>
-          <ac:cxnSpMkLst>
-            <pc:docMk/>
-            <pc:sldMk cId="1705925922" sldId="292"/>
-            <ac:cxnSpMk id="8" creationId="{BECB3D67-1EC3-C85F-B181-BCEE0EAE66F1}"/>
-          </ac:cxnSpMkLst>
-        </pc:cxnChg>
-        <pc:cxnChg chg="del">
-          <ac:chgData name="Lines, Todd" userId="afaf7c3a-e8aa-4568-882a-02ad8f9e19b0" providerId="ADAL" clId="{EB4EA074-9182-46B1-B159-B90F3618D25B}" dt="2025-07-03T19:41:49.135" v="124" actId="478"/>
-          <ac:cxnSpMkLst>
-            <pc:docMk/>
-            <pc:sldMk cId="1705925922" sldId="292"/>
-            <ac:cxnSpMk id="10" creationId="{4BF663A6-7C19-858A-9DAD-7026D2B04856}"/>
-          </ac:cxnSpMkLst>
-        </pc:cxnChg>
       </pc:sldChg>
       <pc:sldChg chg="addSp delSp modSp add mod">
         <pc:chgData name="Lines, Todd" userId="afaf7c3a-e8aa-4568-882a-02ad8f9e19b0" providerId="ADAL" clId="{EB4EA074-9182-46B1-B159-B90F3618D25B}" dt="2025-07-03T19:49:38.389" v="170" actId="21"/>
@@ -794,14 +659,6 @@
             <ac:spMk id="14" creationId="{56336D20-025E-6FF1-E86D-937DD6199AFC}"/>
           </ac:spMkLst>
         </pc:spChg>
-        <pc:picChg chg="del mod">
-          <ac:chgData name="Lines, Todd" userId="afaf7c3a-e8aa-4568-882a-02ad8f9e19b0" providerId="ADAL" clId="{EB4EA074-9182-46B1-B159-B90F3618D25B}" dt="2025-07-03T19:49:38.389" v="170" actId="21"/>
-          <ac:picMkLst>
-            <pc:docMk/>
-            <pc:sldMk cId="2040375679" sldId="293"/>
-            <ac:picMk id="15" creationId="{C72C4D79-74FC-F9C8-4270-A368064060FA}"/>
-          </ac:picMkLst>
-        </pc:picChg>
         <pc:cxnChg chg="add mod">
           <ac:chgData name="Lines, Todd" userId="afaf7c3a-e8aa-4568-882a-02ad8f9e19b0" providerId="ADAL" clId="{EB4EA074-9182-46B1-B159-B90F3618D25B}" dt="2025-07-03T19:42:03.179" v="127"/>
           <ac:cxnSpMkLst>
@@ -889,22 +746,6 @@
             <ac:spMk id="15" creationId="{E6517585-B125-EF8F-B6B5-A93839F8AAFB}"/>
           </ac:spMkLst>
         </pc:spChg>
-        <pc:picChg chg="del mod">
-          <ac:chgData name="Lines, Todd" userId="afaf7c3a-e8aa-4568-882a-02ad8f9e19b0" providerId="ADAL" clId="{EB4EA074-9182-46B1-B159-B90F3618D25B}" dt="2025-07-03T19:52:41.508" v="196" actId="21"/>
-          <ac:picMkLst>
-            <pc:docMk/>
-            <pc:sldMk cId="2092431121" sldId="294"/>
-            <ac:picMk id="7" creationId="{D11CE2EB-BB42-26B5-5525-8570AB8CCCD5}"/>
-          </ac:picMkLst>
-        </pc:picChg>
-        <pc:picChg chg="del mod">
-          <ac:chgData name="Lines, Todd" userId="afaf7c3a-e8aa-4568-882a-02ad8f9e19b0" providerId="ADAL" clId="{EB4EA074-9182-46B1-B159-B90F3618D25B}" dt="2025-07-03T19:53:46.159" v="213" actId="21"/>
-          <ac:picMkLst>
-            <pc:docMk/>
-            <pc:sldMk cId="2092431121" sldId="294"/>
-            <ac:picMk id="8" creationId="{9CA6BD9C-CC7F-22B7-AE90-7105E3CEE4D6}"/>
-          </ac:picMkLst>
-        </pc:picChg>
         <pc:cxnChg chg="mod">
           <ac:chgData name="Lines, Todd" userId="afaf7c3a-e8aa-4568-882a-02ad8f9e19b0" providerId="ADAL" clId="{EB4EA074-9182-46B1-B159-B90F3618D25B}" dt="2025-07-03T19:52:20.489" v="192" actId="1037"/>
           <ac:cxnSpMkLst>
@@ -913,6 +754,141 @@
             <ac:cxnSpMk id="10" creationId="{26CA28EE-423A-8DC8-BF3F-111B0263F55A}"/>
           </ac:cxnSpMkLst>
         </pc:cxnChg>
+      </pc:sldChg>
+      <pc:sldChg chg="delSp modSp add mod">
+        <pc:chgData name="Lines, Todd" userId="afaf7c3a-e8aa-4568-882a-02ad8f9e19b0" providerId="ADAL" clId="{EB4EA074-9182-46B1-B159-B90F3618D25B}" dt="2025-07-07T15:39:52.166" v="233" actId="21"/>
+        <pc:sldMkLst>
+          <pc:docMk/>
+          <pc:sldMk cId="4146382728" sldId="295"/>
+        </pc:sldMkLst>
+        <pc:spChg chg="mod">
+          <ac:chgData name="Lines, Todd" userId="afaf7c3a-e8aa-4568-882a-02ad8f9e19b0" providerId="ADAL" clId="{EB4EA074-9182-46B1-B159-B90F3618D25B}" dt="2025-07-07T15:39:38.871" v="231" actId="1076"/>
+          <ac:spMkLst>
+            <pc:docMk/>
+            <pc:sldMk cId="4146382728" sldId="295"/>
+            <ac:spMk id="11" creationId="{CEEE9BB2-6514-ED20-7A99-D7A676F08B6B}"/>
+          </ac:spMkLst>
+        </pc:spChg>
+        <pc:spChg chg="mod">
+          <ac:chgData name="Lines, Todd" userId="afaf7c3a-e8aa-4568-882a-02ad8f9e19b0" providerId="ADAL" clId="{EB4EA074-9182-46B1-B159-B90F3618D25B}" dt="2025-07-07T15:39:38.871" v="231" actId="1076"/>
+          <ac:spMkLst>
+            <pc:docMk/>
+            <pc:sldMk cId="4146382728" sldId="295"/>
+            <ac:spMk id="12" creationId="{CCE44CF1-1253-190C-D04A-EF5F8AE586AB}"/>
+          </ac:spMkLst>
+        </pc:spChg>
+        <pc:spChg chg="mod">
+          <ac:chgData name="Lines, Todd" userId="afaf7c3a-e8aa-4568-882a-02ad8f9e19b0" providerId="ADAL" clId="{EB4EA074-9182-46B1-B159-B90F3618D25B}" dt="2025-07-07T15:39:38.871" v="231" actId="1076"/>
+          <ac:spMkLst>
+            <pc:docMk/>
+            <pc:sldMk cId="4146382728" sldId="295"/>
+            <ac:spMk id="13" creationId="{62504A5C-568D-E313-EFC1-AD1E2D431189}"/>
+          </ac:spMkLst>
+        </pc:spChg>
+        <pc:spChg chg="mod">
+          <ac:chgData name="Lines, Todd" userId="afaf7c3a-e8aa-4568-882a-02ad8f9e19b0" providerId="ADAL" clId="{EB4EA074-9182-46B1-B159-B90F3618D25B}" dt="2025-07-07T15:39:38.871" v="231" actId="1076"/>
+          <ac:spMkLst>
+            <pc:docMk/>
+            <pc:sldMk cId="4146382728" sldId="295"/>
+            <ac:spMk id="14" creationId="{0B47C765-5177-A185-6B6D-27C6FBD72524}"/>
+          </ac:spMkLst>
+        </pc:spChg>
+        <pc:spChg chg="mod">
+          <ac:chgData name="Lines, Todd" userId="afaf7c3a-e8aa-4568-882a-02ad8f9e19b0" providerId="ADAL" clId="{EB4EA074-9182-46B1-B159-B90F3618D25B}" dt="2025-07-07T15:39:38.871" v="231" actId="1076"/>
+          <ac:spMkLst>
+            <pc:docMk/>
+            <pc:sldMk cId="4146382728" sldId="295"/>
+            <ac:spMk id="17" creationId="{CC9EA29F-A45E-4208-F168-4FF7120CC102}"/>
+          </ac:spMkLst>
+        </pc:spChg>
+        <pc:spChg chg="mod">
+          <ac:chgData name="Lines, Todd" userId="afaf7c3a-e8aa-4568-882a-02ad8f9e19b0" providerId="ADAL" clId="{EB4EA074-9182-46B1-B159-B90F3618D25B}" dt="2025-07-07T15:39:38.871" v="231" actId="1076"/>
+          <ac:spMkLst>
+            <pc:docMk/>
+            <pc:sldMk cId="4146382728" sldId="295"/>
+            <ac:spMk id="18" creationId="{8333EC89-B948-CFF3-533B-CE6791D8672F}"/>
+          </ac:spMkLst>
+        </pc:spChg>
+        <pc:spChg chg="mod">
+          <ac:chgData name="Lines, Todd" userId="afaf7c3a-e8aa-4568-882a-02ad8f9e19b0" providerId="ADAL" clId="{EB4EA074-9182-46B1-B159-B90F3618D25B}" dt="2025-07-07T15:39:38.871" v="231" actId="1076"/>
+          <ac:spMkLst>
+            <pc:docMk/>
+            <pc:sldMk cId="4146382728" sldId="295"/>
+            <ac:spMk id="22" creationId="{4D395F34-47F3-D1DB-D43C-32FC5FE20D3B}"/>
+          </ac:spMkLst>
+        </pc:spChg>
+        <pc:spChg chg="mod">
+          <ac:chgData name="Lines, Todd" userId="afaf7c3a-e8aa-4568-882a-02ad8f9e19b0" providerId="ADAL" clId="{EB4EA074-9182-46B1-B159-B90F3618D25B}" dt="2025-07-07T15:39:38.871" v="231" actId="1076"/>
+          <ac:spMkLst>
+            <pc:docMk/>
+            <pc:sldMk cId="4146382728" sldId="295"/>
+            <ac:spMk id="25" creationId="{243FFC3A-0B5D-7ADE-4ACD-7231E39F403E}"/>
+          </ac:spMkLst>
+        </pc:spChg>
+        <pc:spChg chg="mod">
+          <ac:chgData name="Lines, Todd" userId="afaf7c3a-e8aa-4568-882a-02ad8f9e19b0" providerId="ADAL" clId="{EB4EA074-9182-46B1-B159-B90F3618D25B}" dt="2025-07-07T15:39:38.871" v="231" actId="1076"/>
+          <ac:spMkLst>
+            <pc:docMk/>
+            <pc:sldMk cId="4146382728" sldId="295"/>
+            <ac:spMk id="28" creationId="{AC98FFE5-4161-9776-2984-D5FFEDCC11B1}"/>
+          </ac:spMkLst>
+        </pc:spChg>
+        <pc:spChg chg="mod">
+          <ac:chgData name="Lines, Todd" userId="afaf7c3a-e8aa-4568-882a-02ad8f9e19b0" providerId="ADAL" clId="{EB4EA074-9182-46B1-B159-B90F3618D25B}" dt="2025-07-07T15:39:28.265" v="230" actId="1076"/>
+          <ac:spMkLst>
+            <pc:docMk/>
+            <pc:sldMk cId="4146382728" sldId="295"/>
+            <ac:spMk id="29" creationId="{CFD7752F-5AD7-EDCD-307F-AEFEAEE7A794}"/>
+          </ac:spMkLst>
+        </pc:spChg>
+        <pc:spChg chg="mod">
+          <ac:chgData name="Lines, Todd" userId="afaf7c3a-e8aa-4568-882a-02ad8f9e19b0" providerId="ADAL" clId="{EB4EA074-9182-46B1-B159-B90F3618D25B}" dt="2025-07-07T15:39:28.265" v="230" actId="1076"/>
+          <ac:spMkLst>
+            <pc:docMk/>
+            <pc:sldMk cId="4146382728" sldId="295"/>
+            <ac:spMk id="30" creationId="{A4122155-8F10-7D41-48B3-4D8FA7702BCA}"/>
+          </ac:spMkLst>
+        </pc:spChg>
+        <pc:spChg chg="mod">
+          <ac:chgData name="Lines, Todd" userId="afaf7c3a-e8aa-4568-882a-02ad8f9e19b0" providerId="ADAL" clId="{EB4EA074-9182-46B1-B159-B90F3618D25B}" dt="2025-07-07T15:39:28.265" v="230" actId="1076"/>
+          <ac:spMkLst>
+            <pc:docMk/>
+            <pc:sldMk cId="4146382728" sldId="295"/>
+            <ac:spMk id="31" creationId="{D7AAE4DA-961B-8FAB-301E-39E54ADE69DC}"/>
+          </ac:spMkLst>
+        </pc:spChg>
+        <pc:spChg chg="mod">
+          <ac:chgData name="Lines, Todd" userId="afaf7c3a-e8aa-4568-882a-02ad8f9e19b0" providerId="ADAL" clId="{EB4EA074-9182-46B1-B159-B90F3618D25B}" dt="2025-07-07T15:39:28.265" v="230" actId="1076"/>
+          <ac:spMkLst>
+            <pc:docMk/>
+            <pc:sldMk cId="4146382728" sldId="295"/>
+            <ac:spMk id="32" creationId="{A1F323C0-A915-F6E2-B652-B17952D13E5A}"/>
+          </ac:spMkLst>
+        </pc:spChg>
+        <pc:spChg chg="mod">
+          <ac:chgData name="Lines, Todd" userId="afaf7c3a-e8aa-4568-882a-02ad8f9e19b0" providerId="ADAL" clId="{EB4EA074-9182-46B1-B159-B90F3618D25B}" dt="2025-07-07T15:39:28.265" v="230" actId="1076"/>
+          <ac:spMkLst>
+            <pc:docMk/>
+            <pc:sldMk cId="4146382728" sldId="295"/>
+            <ac:spMk id="33" creationId="{889D2C21-4BD0-22C0-2FA4-05D1EA94E02C}"/>
+          </ac:spMkLst>
+        </pc:spChg>
+        <pc:grpChg chg="mod">
+          <ac:chgData name="Lines, Todd" userId="afaf7c3a-e8aa-4568-882a-02ad8f9e19b0" providerId="ADAL" clId="{EB4EA074-9182-46B1-B159-B90F3618D25B}" dt="2025-07-07T15:39:28.265" v="230" actId="1076"/>
+          <ac:grpSpMkLst>
+            <pc:docMk/>
+            <pc:sldMk cId="4146382728" sldId="295"/>
+            <ac:grpSpMk id="9" creationId="{A4CC7E75-AE3E-A284-3421-3F780509A1D9}"/>
+          </ac:grpSpMkLst>
+        </pc:grpChg>
+        <pc:picChg chg="del mod">
+          <ac:chgData name="Lines, Todd" userId="afaf7c3a-e8aa-4568-882a-02ad8f9e19b0" providerId="ADAL" clId="{EB4EA074-9182-46B1-B159-B90F3618D25B}" dt="2025-07-07T15:39:52.166" v="233" actId="21"/>
+          <ac:picMkLst>
+            <pc:docMk/>
+            <pc:sldMk cId="4146382728" sldId="295"/>
+            <ac:picMk id="2" creationId="{0DAEAE5E-0ECF-4036-0466-F387C5B20AEC}"/>
+          </ac:picMkLst>
+        </pc:picChg>
       </pc:sldChg>
     </pc:docChg>
   </pc:docChgLst>
@@ -1032,7 +1008,7 @@
           <a:p>
             <a:fld id="{A3DEF62A-1412-4CF8-867F-5D706F932E44}" type="datetimeFigureOut">
               <a:rPr lang="en-US" smtClean="0"/>
-              <a:t>7/3/2025</a:t>
+              <a:t>7/7/2025</a:t>
             </a:fld>
             <a:endParaRPr lang="en-US"/>
           </a:p>
@@ -1381,6 +1357,117 @@
 </p:notes>
 </file>
 
+<file path=ppt/notesSlides/notesSlide2.xml><?xml version="1.0" encoding="utf-8"?>
+<p:notes xmlns:a="http://schemas.openxmlformats.org/drawingml/2006/main" xmlns:r="http://schemas.openxmlformats.org/officeDocument/2006/relationships" xmlns:p="http://schemas.openxmlformats.org/presentationml/2006/main">
+  <p:cSld>
+    <p:spTree>
+      <p:nvGrpSpPr>
+        <p:cNvPr id="1" name="">
+          <a:extLst>
+            <a:ext uri="{FF2B5EF4-FFF2-40B4-BE49-F238E27FC236}">
+              <a16:creationId xmlns:a16="http://schemas.microsoft.com/office/drawing/2014/main" id="{0FB0B6E3-67B5-C676-CB21-BEBA8A216061}"/>
+            </a:ext>
+          </a:extLst>
+        </p:cNvPr>
+        <p:cNvGrpSpPr/>
+        <p:nvPr/>
+      </p:nvGrpSpPr>
+      <p:grpSpPr>
+        <a:xfrm>
+          <a:off x="0" y="0"/>
+          <a:ext cx="0" cy="0"/>
+          <a:chOff x="0" y="0"/>
+          <a:chExt cx="0" cy="0"/>
+        </a:xfrm>
+      </p:grpSpPr>
+      <p:sp>
+        <p:nvSpPr>
+          <p:cNvPr id="2" name="Slide Image Placeholder 1">
+            <a:extLst>
+              <a:ext uri="{FF2B5EF4-FFF2-40B4-BE49-F238E27FC236}">
+                <a16:creationId xmlns:a16="http://schemas.microsoft.com/office/drawing/2014/main" id="{5D40A684-3573-7313-1BF8-33B9C51CE15F}"/>
+              </a:ext>
+            </a:extLst>
+          </p:cNvPr>
+          <p:cNvSpPr>
+            <a:spLocks noGrp="1" noRot="1" noChangeAspect="1"/>
+          </p:cNvSpPr>
+          <p:nvPr>
+            <p:ph type="sldImg"/>
+          </p:nvPr>
+        </p:nvSpPr>
+        <p:spPr/>
+      </p:sp>
+      <p:sp>
+        <p:nvSpPr>
+          <p:cNvPr id="3" name="Notes Placeholder 2">
+            <a:extLst>
+              <a:ext uri="{FF2B5EF4-FFF2-40B4-BE49-F238E27FC236}">
+                <a16:creationId xmlns:a16="http://schemas.microsoft.com/office/drawing/2014/main" id="{F809DE20-3656-E402-A5CA-82BB6B615024}"/>
+              </a:ext>
+            </a:extLst>
+          </p:cNvPr>
+          <p:cNvSpPr>
+            <a:spLocks noGrp="1"/>
+          </p:cNvSpPr>
+          <p:nvPr>
+            <p:ph type="body" idx="1"/>
+          </p:nvPr>
+        </p:nvSpPr>
+        <p:spPr/>
+        <p:txBody>
+          <a:bodyPr>
+            <a:normAutofit/>
+          </a:bodyPr>
+          <a:lstStyle/>
+          <a:p>
+            <a:endParaRPr lang="en-US" dirty="0"/>
+          </a:p>
+        </p:txBody>
+      </p:sp>
+      <p:sp>
+        <p:nvSpPr>
+          <p:cNvPr id="4" name="Slide Number Placeholder 3">
+            <a:extLst>
+              <a:ext uri="{FF2B5EF4-FFF2-40B4-BE49-F238E27FC236}">
+                <a16:creationId xmlns:a16="http://schemas.microsoft.com/office/drawing/2014/main" id="{DFD5C5B5-961C-BB20-F7F9-D8D9D0744B59}"/>
+              </a:ext>
+            </a:extLst>
+          </p:cNvPr>
+          <p:cNvSpPr>
+            <a:spLocks noGrp="1"/>
+          </p:cNvSpPr>
+          <p:nvPr>
+            <p:ph type="sldNum" sz="quarter" idx="10"/>
+          </p:nvPr>
+        </p:nvSpPr>
+        <p:spPr/>
+        <p:txBody>
+          <a:bodyPr/>
+          <a:lstStyle/>
+          <a:p>
+            <a:fld id="{18B0B758-799E-42E9-B874-C52F55C25494}" type="slidenum">
+              <a:rPr lang="en-US" smtClean="0"/>
+              <a:pPr/>
+              <a:t>11</a:t>
+            </a:fld>
+            <a:endParaRPr lang="en-US"/>
+          </a:p>
+        </p:txBody>
+      </p:sp>
+    </p:spTree>
+    <p:extLst>
+      <p:ext uri="{BB962C8B-B14F-4D97-AF65-F5344CB8AC3E}">
+        <p14:creationId xmlns:p14="http://schemas.microsoft.com/office/powerpoint/2010/main" val="139148076"/>
+      </p:ext>
+    </p:extLst>
+  </p:cSld>
+  <p:clrMapOvr>
+    <a:masterClrMapping/>
+  </p:clrMapOvr>
+</p:notes>
+</file>
+
 <file path=ppt/slideLayouts/slideLayout1.xml><?xml version="1.0" encoding="utf-8"?>
 <p:sldLayout xmlns:a="http://schemas.openxmlformats.org/drawingml/2006/main" xmlns:r="http://schemas.openxmlformats.org/officeDocument/2006/relationships" xmlns:p="http://schemas.openxmlformats.org/presentationml/2006/main" type="title" preserve="1">
   <p:cSld name="Title Slide">
@@ -1561,7 +1648,7 @@
             <a:fld id="{84F61AEA-5DA7-4883-91E9-49E96185C8F3}" type="datetimeFigureOut">
               <a:rPr lang="en-US" smtClean="0"/>
               <a:pPr/>
-              <a:t>7/3/2025</a:t>
+              <a:t>7/7/2025</a:t>
             </a:fld>
             <a:endParaRPr lang="en-US"/>
           </a:p>
@@ -1726,7 +1813,7 @@
             <a:fld id="{84F61AEA-5DA7-4883-91E9-49E96185C8F3}" type="datetimeFigureOut">
               <a:rPr lang="en-US" smtClean="0"/>
               <a:pPr/>
-              <a:t>7/3/2025</a:t>
+              <a:t>7/7/2025</a:t>
             </a:fld>
             <a:endParaRPr lang="en-US"/>
           </a:p>
@@ -1901,7 +1988,7 @@
             <a:fld id="{84F61AEA-5DA7-4883-91E9-49E96185C8F3}" type="datetimeFigureOut">
               <a:rPr lang="en-US" smtClean="0"/>
               <a:pPr/>
-              <a:t>7/3/2025</a:t>
+              <a:t>7/7/2025</a:t>
             </a:fld>
             <a:endParaRPr lang="en-US"/>
           </a:p>
@@ -2066,7 +2153,7 @@
             <a:fld id="{84F61AEA-5DA7-4883-91E9-49E96185C8F3}" type="datetimeFigureOut">
               <a:rPr lang="en-US" smtClean="0"/>
               <a:pPr/>
-              <a:t>7/3/2025</a:t>
+              <a:t>7/7/2025</a:t>
             </a:fld>
             <a:endParaRPr lang="en-US"/>
           </a:p>
@@ -2308,7 +2395,7 @@
             <a:fld id="{84F61AEA-5DA7-4883-91E9-49E96185C8F3}" type="datetimeFigureOut">
               <a:rPr lang="en-US" smtClean="0"/>
               <a:pPr/>
-              <a:t>7/3/2025</a:t>
+              <a:t>7/7/2025</a:t>
             </a:fld>
             <a:endParaRPr lang="en-US"/>
           </a:p>
@@ -2590,7 +2677,7 @@
             <a:fld id="{84F61AEA-5DA7-4883-91E9-49E96185C8F3}" type="datetimeFigureOut">
               <a:rPr lang="en-US" smtClean="0"/>
               <a:pPr/>
-              <a:t>7/3/2025</a:t>
+              <a:t>7/7/2025</a:t>
             </a:fld>
             <a:endParaRPr lang="en-US"/>
           </a:p>
@@ -3006,7 +3093,7 @@
             <a:fld id="{84F61AEA-5DA7-4883-91E9-49E96185C8F3}" type="datetimeFigureOut">
               <a:rPr lang="en-US" smtClean="0"/>
               <a:pPr/>
-              <a:t>7/3/2025</a:t>
+              <a:t>7/7/2025</a:t>
             </a:fld>
             <a:endParaRPr lang="en-US"/>
           </a:p>
@@ -3120,7 +3207,7 @@
             <a:fld id="{84F61AEA-5DA7-4883-91E9-49E96185C8F3}" type="datetimeFigureOut">
               <a:rPr lang="en-US" smtClean="0"/>
               <a:pPr/>
-              <a:t>7/3/2025</a:t>
+              <a:t>7/7/2025</a:t>
             </a:fld>
             <a:endParaRPr lang="en-US"/>
           </a:p>
@@ -3212,7 +3299,7 @@
             <a:fld id="{84F61AEA-5DA7-4883-91E9-49E96185C8F3}" type="datetimeFigureOut">
               <a:rPr lang="en-US" smtClean="0"/>
               <a:pPr/>
-              <a:t>7/3/2025</a:t>
+              <a:t>7/7/2025</a:t>
             </a:fld>
             <a:endParaRPr lang="en-US"/>
           </a:p>
@@ -3484,7 +3571,7 @@
             <a:fld id="{84F61AEA-5DA7-4883-91E9-49E96185C8F3}" type="datetimeFigureOut">
               <a:rPr lang="en-US" smtClean="0"/>
               <a:pPr/>
-              <a:t>7/3/2025</a:t>
+              <a:t>7/7/2025</a:t>
             </a:fld>
             <a:endParaRPr lang="en-US"/>
           </a:p>
@@ -3733,7 +3820,7 @@
             <a:fld id="{84F61AEA-5DA7-4883-91E9-49E96185C8F3}" type="datetimeFigureOut">
               <a:rPr lang="en-US" smtClean="0"/>
               <a:pPr/>
-              <a:t>7/3/2025</a:t>
+              <a:t>7/7/2025</a:t>
             </a:fld>
             <a:endParaRPr lang="en-US"/>
           </a:p>
@@ -3941,7 +4028,7 @@
             <a:fld id="{84F61AEA-5DA7-4883-91E9-49E96185C8F3}" type="datetimeFigureOut">
               <a:rPr lang="en-US" smtClean="0"/>
               <a:pPr/>
-              <a:t>7/3/2025</a:t>
+              <a:t>7/7/2025</a:t>
             </a:fld>
             <a:endParaRPr lang="en-US"/>
           </a:p>
@@ -5222,7 +5309,7 @@
                   <a:srgbClr val="FF0000"/>
                 </a:solidFill>
               </a:rPr>
-              <a:t>gp</a:t>
+              <a:t>pg</a:t>
             </a:r>
             <a:endParaRPr lang="en-US" sz="3600" baseline="-25000" dirty="0">
               <a:solidFill>
@@ -5409,7 +5496,7 @@
                   <a:srgbClr val="FF0000"/>
                 </a:solidFill>
               </a:rPr>
-              <a:t>gp</a:t>
+              <a:t>pg</a:t>
             </a:r>
             <a:endParaRPr lang="en-US" sz="3600" baseline="-25000" dirty="0">
               <a:solidFill>
@@ -5428,6 +5515,1210 @@
 </file>
 
 <file path=ppt/slides/slide11.xml><?xml version="1.0" encoding="utf-8"?>
+<p:sld xmlns:a="http://schemas.openxmlformats.org/drawingml/2006/main" xmlns:r="http://schemas.openxmlformats.org/officeDocument/2006/relationships" xmlns:p="http://schemas.openxmlformats.org/presentationml/2006/main">
+  <p:cSld>
+    <p:spTree>
+      <p:nvGrpSpPr>
+        <p:cNvPr id="1" name="">
+          <a:extLst>
+            <a:ext uri="{FF2B5EF4-FFF2-40B4-BE49-F238E27FC236}">
+              <a16:creationId xmlns:a16="http://schemas.microsoft.com/office/drawing/2014/main" id="{956BF7A6-0FDB-A15D-7F3E-093C9F7A34A1}"/>
+            </a:ext>
+          </a:extLst>
+        </p:cNvPr>
+        <p:cNvGrpSpPr/>
+        <p:nvPr/>
+      </p:nvGrpSpPr>
+      <p:grpSpPr>
+        <a:xfrm>
+          <a:off x="0" y="0"/>
+          <a:ext cx="0" cy="0"/>
+          <a:chOff x="0" y="0"/>
+          <a:chExt cx="0" cy="0"/>
+        </a:xfrm>
+      </p:grpSpPr>
+      <p:grpSp>
+        <p:nvGrpSpPr>
+          <p:cNvPr id="9" name="Group 8">
+            <a:extLst>
+              <a:ext uri="{FF2B5EF4-FFF2-40B4-BE49-F238E27FC236}">
+                <a16:creationId xmlns:a16="http://schemas.microsoft.com/office/drawing/2014/main" id="{A4CC7E75-AE3E-A284-3421-3F780509A1D9}"/>
+              </a:ext>
+            </a:extLst>
+          </p:cNvPr>
+          <p:cNvGrpSpPr/>
+          <p:nvPr/>
+        </p:nvGrpSpPr>
+        <p:grpSpPr>
+          <a:xfrm>
+            <a:off x="2008486" y="944880"/>
+            <a:ext cx="4953000" cy="1981200"/>
+            <a:chOff x="2057400" y="1371600"/>
+            <a:chExt cx="4953000" cy="2971800"/>
+          </a:xfrm>
+        </p:grpSpPr>
+        <p:sp>
+          <p:nvSpPr>
+            <p:cNvPr id="5" name="Rectangle 4">
+              <a:extLst>
+                <a:ext uri="{FF2B5EF4-FFF2-40B4-BE49-F238E27FC236}">
+                  <a16:creationId xmlns:a16="http://schemas.microsoft.com/office/drawing/2014/main" id="{3348340A-A596-38A4-72E2-E3A6BA784FCD}"/>
+                </a:ext>
+              </a:extLst>
+            </p:cNvPr>
+            <p:cNvSpPr/>
+            <p:nvPr/>
+          </p:nvSpPr>
+          <p:spPr>
+            <a:xfrm>
+              <a:off x="2057400" y="1371600"/>
+              <a:ext cx="4953000" cy="2971800"/>
+            </a:xfrm>
+            <a:prstGeom prst="rect">
+              <a:avLst/>
+            </a:prstGeom>
+            <a:solidFill>
+              <a:schemeClr val="bg1">
+                <a:lumMod val="65000"/>
+              </a:schemeClr>
+            </a:solidFill>
+            <a:ln>
+              <a:noFill/>
+            </a:ln>
+          </p:spPr>
+          <p:style>
+            <a:lnRef idx="2">
+              <a:schemeClr val="accent1">
+                <a:shade val="50000"/>
+              </a:schemeClr>
+            </a:lnRef>
+            <a:fillRef idx="1">
+              <a:schemeClr val="accent1"/>
+            </a:fillRef>
+            <a:effectRef idx="0">
+              <a:schemeClr val="accent1"/>
+            </a:effectRef>
+            <a:fontRef idx="minor">
+              <a:schemeClr val="lt1"/>
+            </a:fontRef>
+          </p:style>
+          <p:txBody>
+            <a:bodyPr rtlCol="0" anchor="ctr"/>
+            <a:lstStyle/>
+            <a:p>
+              <a:pPr algn="ctr"/>
+              <a:endParaRPr lang="en-US"/>
+            </a:p>
+          </p:txBody>
+        </p:sp>
+        <p:sp>
+          <p:nvSpPr>
+            <p:cNvPr id="6" name="Rectangle 5">
+              <a:extLst>
+                <a:ext uri="{FF2B5EF4-FFF2-40B4-BE49-F238E27FC236}">
+                  <a16:creationId xmlns:a16="http://schemas.microsoft.com/office/drawing/2014/main" id="{799B1EBC-7C7C-ED35-7974-E9460E6216C0}"/>
+                </a:ext>
+              </a:extLst>
+            </p:cNvPr>
+            <p:cNvSpPr/>
+            <p:nvPr/>
+          </p:nvSpPr>
+          <p:spPr>
+            <a:xfrm>
+              <a:off x="2514600" y="1790700"/>
+              <a:ext cx="4495800" cy="2133600"/>
+            </a:xfrm>
+            <a:prstGeom prst="rect">
+              <a:avLst/>
+            </a:prstGeom>
+            <a:solidFill>
+              <a:schemeClr val="bg1"/>
+            </a:solidFill>
+            <a:ln>
+              <a:noFill/>
+            </a:ln>
+          </p:spPr>
+          <p:style>
+            <a:lnRef idx="2">
+              <a:schemeClr val="accent1">
+                <a:shade val="50000"/>
+              </a:schemeClr>
+            </a:lnRef>
+            <a:fillRef idx="1">
+              <a:schemeClr val="accent1"/>
+            </a:fillRef>
+            <a:effectRef idx="0">
+              <a:schemeClr val="accent1"/>
+            </a:effectRef>
+            <a:fontRef idx="minor">
+              <a:schemeClr val="lt1"/>
+            </a:fontRef>
+          </p:style>
+          <p:txBody>
+            <a:bodyPr rtlCol="0" anchor="ctr"/>
+            <a:lstStyle/>
+            <a:p>
+              <a:pPr algn="ctr"/>
+              <a:endParaRPr lang="en-US"/>
+            </a:p>
+          </p:txBody>
+        </p:sp>
+        <p:sp>
+          <p:nvSpPr>
+            <p:cNvPr id="7" name="Rectangle 6">
+              <a:extLst>
+                <a:ext uri="{FF2B5EF4-FFF2-40B4-BE49-F238E27FC236}">
+                  <a16:creationId xmlns:a16="http://schemas.microsoft.com/office/drawing/2014/main" id="{3E09D3A4-DB36-04C0-5275-88FD21EF93C1}"/>
+                </a:ext>
+              </a:extLst>
+            </p:cNvPr>
+            <p:cNvSpPr/>
+            <p:nvPr/>
+          </p:nvSpPr>
+          <p:spPr>
+            <a:xfrm>
+              <a:off x="4876800" y="1790700"/>
+              <a:ext cx="457200" cy="2133600"/>
+            </a:xfrm>
+            <a:prstGeom prst="rect">
+              <a:avLst/>
+            </a:prstGeom>
+            <a:solidFill>
+              <a:srgbClr val="C00000"/>
+            </a:solidFill>
+            <a:ln>
+              <a:noFill/>
+            </a:ln>
+          </p:spPr>
+          <p:style>
+            <a:lnRef idx="2">
+              <a:schemeClr val="accent1">
+                <a:shade val="50000"/>
+              </a:schemeClr>
+            </a:lnRef>
+            <a:fillRef idx="1">
+              <a:schemeClr val="accent1"/>
+            </a:fillRef>
+            <a:effectRef idx="0">
+              <a:schemeClr val="accent1"/>
+            </a:effectRef>
+            <a:fontRef idx="minor">
+              <a:schemeClr val="lt1"/>
+            </a:fontRef>
+          </p:style>
+          <p:txBody>
+            <a:bodyPr rtlCol="0" anchor="ctr"/>
+            <a:lstStyle/>
+            <a:p>
+              <a:pPr algn="ctr"/>
+              <a:endParaRPr lang="en-US"/>
+            </a:p>
+          </p:txBody>
+        </p:sp>
+        <p:sp>
+          <p:nvSpPr>
+            <p:cNvPr id="8" name="Rectangle 7">
+              <a:extLst>
+                <a:ext uri="{FF2B5EF4-FFF2-40B4-BE49-F238E27FC236}">
+                  <a16:creationId xmlns:a16="http://schemas.microsoft.com/office/drawing/2014/main" id="{A6A80A2E-48EC-EDB8-9909-A5DEA64FC671}"/>
+                </a:ext>
+              </a:extLst>
+            </p:cNvPr>
+            <p:cNvSpPr/>
+            <p:nvPr/>
+          </p:nvSpPr>
+          <p:spPr>
+            <a:xfrm>
+              <a:off x="2520315" y="1790699"/>
+              <a:ext cx="2404110" cy="2138363"/>
+            </a:xfrm>
+            <a:prstGeom prst="rect">
+              <a:avLst/>
+            </a:prstGeom>
+            <a:solidFill>
+              <a:srgbClr val="FFFF99"/>
+            </a:solidFill>
+            <a:ln>
+              <a:noFill/>
+            </a:ln>
+          </p:spPr>
+          <p:style>
+            <a:lnRef idx="2">
+              <a:schemeClr val="accent1">
+                <a:shade val="50000"/>
+              </a:schemeClr>
+            </a:lnRef>
+            <a:fillRef idx="1">
+              <a:schemeClr val="accent1"/>
+            </a:fillRef>
+            <a:effectRef idx="0">
+              <a:schemeClr val="accent1"/>
+            </a:effectRef>
+            <a:fontRef idx="minor">
+              <a:schemeClr val="lt1"/>
+            </a:fontRef>
+          </p:style>
+          <p:txBody>
+            <a:bodyPr rtlCol="0" anchor="ctr"/>
+            <a:lstStyle/>
+            <a:p>
+              <a:pPr algn="ctr"/>
+              <a:endParaRPr lang="en-US"/>
+            </a:p>
+          </p:txBody>
+        </p:sp>
+      </p:grpSp>
+      <p:sp>
+        <p:nvSpPr>
+          <p:cNvPr id="11" name="Rectangle 10">
+            <a:extLst>
+              <a:ext uri="{FF2B5EF4-FFF2-40B4-BE49-F238E27FC236}">
+                <a16:creationId xmlns:a16="http://schemas.microsoft.com/office/drawing/2014/main" id="{CEEE9BB2-6514-ED20-7A99-D7A676F08B6B}"/>
+              </a:ext>
+            </a:extLst>
+          </p:cNvPr>
+          <p:cNvSpPr/>
+          <p:nvPr/>
+        </p:nvSpPr>
+        <p:spPr>
+          <a:xfrm>
+            <a:off x="2008486" y="3901441"/>
+            <a:ext cx="4953000" cy="1981200"/>
+          </a:xfrm>
+          <a:prstGeom prst="rect">
+            <a:avLst/>
+          </a:prstGeom>
+          <a:solidFill>
+            <a:schemeClr val="bg1">
+              <a:lumMod val="65000"/>
+            </a:schemeClr>
+          </a:solidFill>
+          <a:ln>
+            <a:noFill/>
+          </a:ln>
+        </p:spPr>
+        <p:style>
+          <a:lnRef idx="2">
+            <a:schemeClr val="accent1">
+              <a:shade val="50000"/>
+            </a:schemeClr>
+          </a:lnRef>
+          <a:fillRef idx="1">
+            <a:schemeClr val="accent1"/>
+          </a:fillRef>
+          <a:effectRef idx="0">
+            <a:schemeClr val="accent1"/>
+          </a:effectRef>
+          <a:fontRef idx="minor">
+            <a:schemeClr val="lt1"/>
+          </a:fontRef>
+        </p:style>
+        <p:txBody>
+          <a:bodyPr rtlCol="0" anchor="ctr"/>
+          <a:lstStyle/>
+          <a:p>
+            <a:pPr algn="ctr"/>
+            <a:endParaRPr lang="en-US"/>
+          </a:p>
+        </p:txBody>
+      </p:sp>
+      <p:sp>
+        <p:nvSpPr>
+          <p:cNvPr id="12" name="Rectangle 11">
+            <a:extLst>
+              <a:ext uri="{FF2B5EF4-FFF2-40B4-BE49-F238E27FC236}">
+                <a16:creationId xmlns:a16="http://schemas.microsoft.com/office/drawing/2014/main" id="{CCE44CF1-1253-190C-D04A-EF5F8AE586AB}"/>
+              </a:ext>
+            </a:extLst>
+          </p:cNvPr>
+          <p:cNvSpPr/>
+          <p:nvPr/>
+        </p:nvSpPr>
+        <p:spPr>
+          <a:xfrm>
+            <a:off x="2465686" y="4180841"/>
+            <a:ext cx="4495800" cy="1422400"/>
+          </a:xfrm>
+          <a:prstGeom prst="rect">
+            <a:avLst/>
+          </a:prstGeom>
+          <a:solidFill>
+            <a:schemeClr val="bg1"/>
+          </a:solidFill>
+          <a:ln>
+            <a:noFill/>
+          </a:ln>
+        </p:spPr>
+        <p:style>
+          <a:lnRef idx="2">
+            <a:schemeClr val="accent1">
+              <a:shade val="50000"/>
+            </a:schemeClr>
+          </a:lnRef>
+          <a:fillRef idx="1">
+            <a:schemeClr val="accent1"/>
+          </a:fillRef>
+          <a:effectRef idx="0">
+            <a:schemeClr val="accent1"/>
+          </a:effectRef>
+          <a:fontRef idx="minor">
+            <a:schemeClr val="lt1"/>
+          </a:fontRef>
+        </p:style>
+        <p:txBody>
+          <a:bodyPr rtlCol="0" anchor="ctr"/>
+          <a:lstStyle/>
+          <a:p>
+            <a:pPr algn="ctr"/>
+            <a:endParaRPr lang="en-US"/>
+          </a:p>
+        </p:txBody>
+      </p:sp>
+      <p:sp>
+        <p:nvSpPr>
+          <p:cNvPr id="13" name="Rectangle 12">
+            <a:extLst>
+              <a:ext uri="{FF2B5EF4-FFF2-40B4-BE49-F238E27FC236}">
+                <a16:creationId xmlns:a16="http://schemas.microsoft.com/office/drawing/2014/main" id="{62504A5C-568D-E313-EFC1-AD1E2D431189}"/>
+              </a:ext>
+            </a:extLst>
+          </p:cNvPr>
+          <p:cNvSpPr/>
+          <p:nvPr/>
+        </p:nvSpPr>
+        <p:spPr>
+          <a:xfrm>
+            <a:off x="3822046" y="4180841"/>
+            <a:ext cx="457200" cy="1422400"/>
+          </a:xfrm>
+          <a:prstGeom prst="rect">
+            <a:avLst/>
+          </a:prstGeom>
+          <a:solidFill>
+            <a:srgbClr val="C00000"/>
+          </a:solidFill>
+          <a:ln>
+            <a:noFill/>
+          </a:ln>
+        </p:spPr>
+        <p:style>
+          <a:lnRef idx="2">
+            <a:schemeClr val="accent1">
+              <a:shade val="50000"/>
+            </a:schemeClr>
+          </a:lnRef>
+          <a:fillRef idx="1">
+            <a:schemeClr val="accent1"/>
+          </a:fillRef>
+          <a:effectRef idx="0">
+            <a:schemeClr val="accent1"/>
+          </a:effectRef>
+          <a:fontRef idx="minor">
+            <a:schemeClr val="lt1"/>
+          </a:fontRef>
+        </p:style>
+        <p:txBody>
+          <a:bodyPr rtlCol="0" anchor="ctr"/>
+          <a:lstStyle/>
+          <a:p>
+            <a:pPr algn="ctr"/>
+            <a:endParaRPr lang="en-US"/>
+          </a:p>
+        </p:txBody>
+      </p:sp>
+      <p:sp>
+        <p:nvSpPr>
+          <p:cNvPr id="14" name="Rectangle 13">
+            <a:extLst>
+              <a:ext uri="{FF2B5EF4-FFF2-40B4-BE49-F238E27FC236}">
+                <a16:creationId xmlns:a16="http://schemas.microsoft.com/office/drawing/2014/main" id="{0B47C765-5177-A185-6B6D-27C6FBD72524}"/>
+              </a:ext>
+            </a:extLst>
+          </p:cNvPr>
+          <p:cNvSpPr/>
+          <p:nvPr/>
+        </p:nvSpPr>
+        <p:spPr>
+          <a:xfrm>
+            <a:off x="2471401" y="4180840"/>
+            <a:ext cx="1365885" cy="1425575"/>
+          </a:xfrm>
+          <a:prstGeom prst="rect">
+            <a:avLst/>
+          </a:prstGeom>
+          <a:solidFill>
+            <a:srgbClr val="FFFF99"/>
+          </a:solidFill>
+          <a:ln>
+            <a:noFill/>
+          </a:ln>
+        </p:spPr>
+        <p:style>
+          <a:lnRef idx="2">
+            <a:schemeClr val="accent1">
+              <a:shade val="50000"/>
+            </a:schemeClr>
+          </a:lnRef>
+          <a:fillRef idx="1">
+            <a:schemeClr val="accent1"/>
+          </a:fillRef>
+          <a:effectRef idx="0">
+            <a:schemeClr val="accent1"/>
+          </a:effectRef>
+          <a:fontRef idx="minor">
+            <a:schemeClr val="lt1"/>
+          </a:fontRef>
+        </p:style>
+        <p:txBody>
+          <a:bodyPr rtlCol="0" anchor="ctr"/>
+          <a:lstStyle/>
+          <a:p>
+            <a:pPr algn="ctr"/>
+            <a:endParaRPr lang="en-US"/>
+          </a:p>
+        </p:txBody>
+      </p:sp>
+      <p:sp>
+        <p:nvSpPr>
+          <p:cNvPr id="17" name="Left Arrow 16">
+            <a:extLst>
+              <a:ext uri="{FF2B5EF4-FFF2-40B4-BE49-F238E27FC236}">
+                <a16:creationId xmlns:a16="http://schemas.microsoft.com/office/drawing/2014/main" id="{CC9EA29F-A45E-4208-F168-4FF7120CC102}"/>
+              </a:ext>
+            </a:extLst>
+          </p:cNvPr>
+          <p:cNvSpPr/>
+          <p:nvPr/>
+        </p:nvSpPr>
+        <p:spPr>
+          <a:xfrm>
+            <a:off x="4260289" y="4761944"/>
+            <a:ext cx="1158240" cy="335280"/>
+          </a:xfrm>
+          <a:prstGeom prst="leftArrow">
+            <a:avLst/>
+          </a:prstGeom>
+          <a:solidFill>
+            <a:srgbClr val="FF0000"/>
+          </a:solidFill>
+          <a:ln>
+            <a:noFill/>
+          </a:ln>
+        </p:spPr>
+        <p:style>
+          <a:lnRef idx="2">
+            <a:schemeClr val="accent1">
+              <a:shade val="50000"/>
+            </a:schemeClr>
+          </a:lnRef>
+          <a:fillRef idx="1">
+            <a:schemeClr val="accent1"/>
+          </a:fillRef>
+          <a:effectRef idx="0">
+            <a:schemeClr val="accent1"/>
+          </a:effectRef>
+          <a:fontRef idx="minor">
+            <a:schemeClr val="lt1"/>
+          </a:fontRef>
+        </p:style>
+        <p:txBody>
+          <a:bodyPr rtlCol="0" anchor="ctr"/>
+          <a:lstStyle/>
+          <a:p>
+            <a:pPr algn="ctr"/>
+            <a:endParaRPr lang="en-US"/>
+          </a:p>
+        </p:txBody>
+      </p:sp>
+      <p:sp>
+        <p:nvSpPr>
+          <p:cNvPr id="18" name="TextBox 17">
+            <a:extLst>
+              <a:ext uri="{FF2B5EF4-FFF2-40B4-BE49-F238E27FC236}">
+                <a16:creationId xmlns:a16="http://schemas.microsoft.com/office/drawing/2014/main" id="{8333EC89-B948-CFF3-533B-CE6791D8672F}"/>
+              </a:ext>
+            </a:extLst>
+          </p:cNvPr>
+          <p:cNvSpPr txBox="1"/>
+          <p:nvPr/>
+        </p:nvSpPr>
+        <p:spPr>
+          <a:xfrm>
+            <a:off x="5490640" y="4525166"/>
+            <a:ext cx="781432" cy="769441"/>
+          </a:xfrm>
+          <a:prstGeom prst="rect">
+            <a:avLst/>
+          </a:prstGeom>
+          <a:noFill/>
+        </p:spPr>
+        <p:txBody>
+          <a:bodyPr wrap="none" rtlCol="0">
+            <a:spAutoFit/>
+          </a:bodyPr>
+          <a:lstStyle/>
+          <a:p>
+            <a:r>
+              <a:rPr lang="en-US" sz="4400" dirty="0" err="1">
+                <a:solidFill>
+                  <a:srgbClr val="FF0000"/>
+                </a:solidFill>
+              </a:rPr>
+              <a:t>F</a:t>
+            </a:r>
+            <a:r>
+              <a:rPr lang="en-US" sz="4400" baseline="-25000" dirty="0" err="1">
+                <a:solidFill>
+                  <a:srgbClr val="FF0000"/>
+                </a:solidFill>
+              </a:rPr>
+              <a:t>ex</a:t>
+            </a:r>
+            <a:endParaRPr lang="en-US" sz="4400" baseline="-25000" dirty="0">
+              <a:solidFill>
+                <a:srgbClr val="FF0000"/>
+              </a:solidFill>
+            </a:endParaRPr>
+          </a:p>
+        </p:txBody>
+      </p:sp>
+      <p:cxnSp>
+        <p:nvCxnSpPr>
+          <p:cNvPr id="20" name="Straight Connector 19">
+            <a:extLst>
+              <a:ext uri="{FF2B5EF4-FFF2-40B4-BE49-F238E27FC236}">
+                <a16:creationId xmlns:a16="http://schemas.microsoft.com/office/drawing/2014/main" id="{636881A9-F0BA-808A-8B87-70223A109189}"/>
+              </a:ext>
+            </a:extLst>
+          </p:cNvPr>
+          <p:cNvCxnSpPr/>
+          <p:nvPr/>
+        </p:nvCxnSpPr>
+        <p:spPr>
+          <a:xfrm flipV="1">
+            <a:off x="3912190" y="2956560"/>
+            <a:ext cx="0" cy="792480"/>
+          </a:xfrm>
+          <a:prstGeom prst="line">
+            <a:avLst/>
+          </a:prstGeom>
+          <a:ln>
+            <a:solidFill>
+              <a:schemeClr val="tx1"/>
+            </a:solidFill>
+            <a:prstDash val="lgDash"/>
+          </a:ln>
+        </p:spPr>
+        <p:style>
+          <a:lnRef idx="1">
+            <a:schemeClr val="accent1"/>
+          </a:lnRef>
+          <a:fillRef idx="0">
+            <a:schemeClr val="accent1"/>
+          </a:fillRef>
+          <a:effectRef idx="0">
+            <a:schemeClr val="accent1"/>
+          </a:effectRef>
+          <a:fontRef idx="minor">
+            <a:schemeClr val="tx1"/>
+          </a:fontRef>
+        </p:style>
+      </p:cxnSp>
+      <p:cxnSp>
+        <p:nvCxnSpPr>
+          <p:cNvPr id="23" name="Straight Connector 22">
+            <a:extLst>
+              <a:ext uri="{FF2B5EF4-FFF2-40B4-BE49-F238E27FC236}">
+                <a16:creationId xmlns:a16="http://schemas.microsoft.com/office/drawing/2014/main" id="{28D4C2A7-DF40-1A72-EDB6-0C047AD7250D}"/>
+              </a:ext>
+            </a:extLst>
+          </p:cNvPr>
+          <p:cNvCxnSpPr/>
+          <p:nvPr/>
+        </p:nvCxnSpPr>
+        <p:spPr>
+          <a:xfrm flipV="1">
+            <a:off x="4892040" y="2956560"/>
+            <a:ext cx="0" cy="792480"/>
+          </a:xfrm>
+          <a:prstGeom prst="line">
+            <a:avLst/>
+          </a:prstGeom>
+          <a:ln>
+            <a:solidFill>
+              <a:schemeClr val="tx1"/>
+            </a:solidFill>
+            <a:prstDash val="lgDash"/>
+          </a:ln>
+        </p:spPr>
+        <p:style>
+          <a:lnRef idx="1">
+            <a:schemeClr val="accent1"/>
+          </a:lnRef>
+          <a:fillRef idx="0">
+            <a:schemeClr val="accent1"/>
+          </a:fillRef>
+          <a:effectRef idx="0">
+            <a:schemeClr val="accent1"/>
+          </a:effectRef>
+          <a:fontRef idx="minor">
+            <a:schemeClr val="tx1"/>
+          </a:fontRef>
+        </p:style>
+      </p:cxnSp>
+      <p:sp>
+        <p:nvSpPr>
+          <p:cNvPr id="24" name="TextBox 23">
+            <a:extLst>
+              <a:ext uri="{FF2B5EF4-FFF2-40B4-BE49-F238E27FC236}">
+                <a16:creationId xmlns:a16="http://schemas.microsoft.com/office/drawing/2014/main" id="{5C9C9F08-923B-9D53-0477-CFCA4F7FDE0A}"/>
+              </a:ext>
+            </a:extLst>
+          </p:cNvPr>
+          <p:cNvSpPr txBox="1"/>
+          <p:nvPr/>
+        </p:nvSpPr>
+        <p:spPr>
+          <a:xfrm>
+            <a:off x="4071835" y="3107711"/>
+            <a:ext cx="614271" cy="594360"/>
+          </a:xfrm>
+          <a:prstGeom prst="rect">
+            <a:avLst/>
+          </a:prstGeom>
+          <a:noFill/>
+        </p:spPr>
+        <p:txBody>
+          <a:bodyPr wrap="square" rtlCol="0">
+            <a:spAutoFit/>
+          </a:bodyPr>
+          <a:lstStyle/>
+          <a:p>
+            <a:r>
+              <a:rPr lang="en-US" sz="3200" dirty="0">
+                <a:sym typeface="Symbol"/>
+              </a:rPr>
+              <a:t>x</a:t>
+            </a:r>
+            <a:endParaRPr lang="en-US" sz="3200" dirty="0"/>
+          </a:p>
+        </p:txBody>
+      </p:sp>
+      <p:cxnSp>
+        <p:nvCxnSpPr>
+          <p:cNvPr id="26" name="Straight Arrow Connector 25">
+            <a:extLst>
+              <a:ext uri="{FF2B5EF4-FFF2-40B4-BE49-F238E27FC236}">
+                <a16:creationId xmlns:a16="http://schemas.microsoft.com/office/drawing/2014/main" id="{224259E4-62EB-45BA-B378-D147092C6323}"/>
+              </a:ext>
+            </a:extLst>
+          </p:cNvPr>
+          <p:cNvCxnSpPr/>
+          <p:nvPr/>
+        </p:nvCxnSpPr>
+        <p:spPr>
+          <a:xfrm>
+            <a:off x="3348310" y="3413760"/>
+            <a:ext cx="548640" cy="0"/>
+          </a:xfrm>
+          <a:prstGeom prst="straightConnector1">
+            <a:avLst/>
+          </a:prstGeom>
+          <a:ln>
+            <a:solidFill>
+              <a:schemeClr val="tx1"/>
+            </a:solidFill>
+            <a:tailEnd type="arrow"/>
+          </a:ln>
+        </p:spPr>
+        <p:style>
+          <a:lnRef idx="1">
+            <a:schemeClr val="accent1"/>
+          </a:lnRef>
+          <a:fillRef idx="0">
+            <a:schemeClr val="accent1"/>
+          </a:fillRef>
+          <a:effectRef idx="0">
+            <a:schemeClr val="accent1"/>
+          </a:effectRef>
+          <a:fontRef idx="minor">
+            <a:schemeClr val="tx1"/>
+          </a:fontRef>
+        </p:style>
+      </p:cxnSp>
+      <p:cxnSp>
+        <p:nvCxnSpPr>
+          <p:cNvPr id="27" name="Straight Arrow Connector 26">
+            <a:extLst>
+              <a:ext uri="{FF2B5EF4-FFF2-40B4-BE49-F238E27FC236}">
+                <a16:creationId xmlns:a16="http://schemas.microsoft.com/office/drawing/2014/main" id="{CFC4EE35-176C-10A3-75B9-BC94971B7994}"/>
+              </a:ext>
+            </a:extLst>
+          </p:cNvPr>
+          <p:cNvCxnSpPr/>
+          <p:nvPr/>
+        </p:nvCxnSpPr>
+        <p:spPr>
+          <a:xfrm flipH="1">
+            <a:off x="4892040" y="3413760"/>
+            <a:ext cx="548640" cy="0"/>
+          </a:xfrm>
+          <a:prstGeom prst="straightConnector1">
+            <a:avLst/>
+          </a:prstGeom>
+          <a:ln>
+            <a:solidFill>
+              <a:schemeClr val="tx1"/>
+            </a:solidFill>
+            <a:tailEnd type="arrow"/>
+          </a:ln>
+        </p:spPr>
+        <p:style>
+          <a:lnRef idx="1">
+            <a:schemeClr val="accent1"/>
+          </a:lnRef>
+          <a:fillRef idx="0">
+            <a:schemeClr val="accent1"/>
+          </a:fillRef>
+          <a:effectRef idx="0">
+            <a:schemeClr val="accent1"/>
+          </a:effectRef>
+          <a:fontRef idx="minor">
+            <a:schemeClr val="tx1"/>
+          </a:fontRef>
+        </p:style>
+      </p:cxnSp>
+      <p:sp>
+        <p:nvSpPr>
+          <p:cNvPr id="28" name="TextBox 27">
+            <a:extLst>
+              <a:ext uri="{FF2B5EF4-FFF2-40B4-BE49-F238E27FC236}">
+                <a16:creationId xmlns:a16="http://schemas.microsoft.com/office/drawing/2014/main" id="{AC98FFE5-4161-9776-2984-D5FFEDCC11B1}"/>
+              </a:ext>
+            </a:extLst>
+          </p:cNvPr>
+          <p:cNvSpPr txBox="1"/>
+          <p:nvPr/>
+        </p:nvSpPr>
+        <p:spPr>
+          <a:xfrm>
+            <a:off x="2513208" y="4172484"/>
+            <a:ext cx="1125629" cy="584775"/>
+          </a:xfrm>
+          <a:prstGeom prst="rect">
+            <a:avLst/>
+          </a:prstGeom>
+          <a:noFill/>
+        </p:spPr>
+        <p:txBody>
+          <a:bodyPr wrap="none" rtlCol="0">
+            <a:spAutoFit/>
+          </a:bodyPr>
+          <a:lstStyle/>
+          <a:p>
+            <a:r>
+              <a:rPr lang="en-US" sz="3200" dirty="0"/>
+              <a:t>P</a:t>
+            </a:r>
+            <a:r>
+              <a:rPr lang="en-US" sz="3200" baseline="-25000" dirty="0"/>
+              <a:t>i</a:t>
+            </a:r>
+            <a:r>
+              <a:rPr lang="en-US" sz="3200" dirty="0"/>
+              <a:t>    V</a:t>
+            </a:r>
+            <a:r>
+              <a:rPr lang="en-US" sz="3200" baseline="-25000" dirty="0"/>
+              <a:t>i</a:t>
+            </a:r>
+          </a:p>
+        </p:txBody>
+      </p:sp>
+      <p:sp>
+        <p:nvSpPr>
+          <p:cNvPr id="29" name="TextBox 28">
+            <a:extLst>
+              <a:ext uri="{FF2B5EF4-FFF2-40B4-BE49-F238E27FC236}">
+                <a16:creationId xmlns:a16="http://schemas.microsoft.com/office/drawing/2014/main" id="{CFD7752F-5AD7-EDCD-307F-AEFEAEE7A794}"/>
+              </a:ext>
+            </a:extLst>
+          </p:cNvPr>
+          <p:cNvSpPr txBox="1"/>
+          <p:nvPr/>
+        </p:nvSpPr>
+        <p:spPr>
+          <a:xfrm>
+            <a:off x="2562862" y="1246554"/>
+            <a:ext cx="1076770" cy="584775"/>
+          </a:xfrm>
+          <a:prstGeom prst="rect">
+            <a:avLst/>
+          </a:prstGeom>
+          <a:noFill/>
+        </p:spPr>
+        <p:txBody>
+          <a:bodyPr wrap="none" rtlCol="0">
+            <a:spAutoFit/>
+          </a:bodyPr>
+          <a:lstStyle/>
+          <a:p>
+            <a:r>
+              <a:rPr lang="en-US" sz="3200" dirty="0"/>
+              <a:t>P</a:t>
+            </a:r>
+            <a:r>
+              <a:rPr lang="en-US" sz="3200" baseline="-25000" dirty="0"/>
+              <a:t>f</a:t>
+            </a:r>
+            <a:r>
+              <a:rPr lang="en-US" sz="3200" dirty="0"/>
+              <a:t>   </a:t>
+            </a:r>
+            <a:r>
+              <a:rPr lang="en-US" sz="3200" dirty="0" err="1"/>
+              <a:t>V</a:t>
+            </a:r>
+            <a:r>
+              <a:rPr lang="en-US" sz="3200" baseline="-25000" dirty="0" err="1"/>
+              <a:t>f</a:t>
+            </a:r>
+            <a:endParaRPr lang="en-US" sz="3200" baseline="-25000" dirty="0"/>
+          </a:p>
+        </p:txBody>
+      </p:sp>
+      <p:sp>
+        <p:nvSpPr>
+          <p:cNvPr id="22" name="Left Arrow 21">
+            <a:extLst>
+              <a:ext uri="{FF2B5EF4-FFF2-40B4-BE49-F238E27FC236}">
+                <a16:creationId xmlns:a16="http://schemas.microsoft.com/office/drawing/2014/main" id="{4D395F34-47F3-D1DB-D43C-32FC5FE20D3B}"/>
+              </a:ext>
+            </a:extLst>
+          </p:cNvPr>
+          <p:cNvSpPr/>
+          <p:nvPr/>
+        </p:nvSpPr>
+        <p:spPr>
+          <a:xfrm flipH="1">
+            <a:off x="2689083" y="4735924"/>
+            <a:ext cx="1170877" cy="367247"/>
+          </a:xfrm>
+          <a:prstGeom prst="leftArrow">
+            <a:avLst>
+              <a:gd name="adj1" fmla="val 50000"/>
+              <a:gd name="adj2" fmla="val 53037"/>
+            </a:avLst>
+          </a:prstGeom>
+          <a:solidFill>
+            <a:srgbClr val="FF0000"/>
+          </a:solidFill>
+          <a:ln>
+            <a:noFill/>
+          </a:ln>
+        </p:spPr>
+        <p:style>
+          <a:lnRef idx="2">
+            <a:schemeClr val="accent1">
+              <a:shade val="50000"/>
+            </a:schemeClr>
+          </a:lnRef>
+          <a:fillRef idx="1">
+            <a:schemeClr val="accent1"/>
+          </a:fillRef>
+          <a:effectRef idx="0">
+            <a:schemeClr val="accent1"/>
+          </a:effectRef>
+          <a:fontRef idx="minor">
+            <a:schemeClr val="lt1"/>
+          </a:fontRef>
+        </p:style>
+        <p:txBody>
+          <a:bodyPr rtlCol="0" anchor="ctr"/>
+          <a:lstStyle/>
+          <a:p>
+            <a:pPr algn="ctr"/>
+            <a:endParaRPr lang="en-US"/>
+          </a:p>
+        </p:txBody>
+      </p:sp>
+      <p:sp>
+        <p:nvSpPr>
+          <p:cNvPr id="25" name="TextBox 24">
+            <a:extLst>
+              <a:ext uri="{FF2B5EF4-FFF2-40B4-BE49-F238E27FC236}">
+                <a16:creationId xmlns:a16="http://schemas.microsoft.com/office/drawing/2014/main" id="{243FFC3A-0B5D-7ADE-4ACD-7231E39F403E}"/>
+              </a:ext>
+            </a:extLst>
+          </p:cNvPr>
+          <p:cNvSpPr txBox="1"/>
+          <p:nvPr/>
+        </p:nvSpPr>
+        <p:spPr>
+          <a:xfrm>
+            <a:off x="2810630" y="4889439"/>
+            <a:ext cx="702436" cy="646331"/>
+          </a:xfrm>
+          <a:prstGeom prst="rect">
+            <a:avLst/>
+          </a:prstGeom>
+          <a:noFill/>
+        </p:spPr>
+        <p:txBody>
+          <a:bodyPr wrap="none" rtlCol="0">
+            <a:spAutoFit/>
+          </a:bodyPr>
+          <a:lstStyle/>
+          <a:p>
+            <a:r>
+              <a:rPr lang="en-US" sz="3600" dirty="0" err="1">
+                <a:solidFill>
+                  <a:srgbClr val="FF0000"/>
+                </a:solidFill>
+              </a:rPr>
+              <a:t>F</a:t>
+            </a:r>
+            <a:r>
+              <a:rPr lang="en-US" sz="3600" baseline="-25000" dirty="0" err="1">
+                <a:solidFill>
+                  <a:srgbClr val="FF0000"/>
+                </a:solidFill>
+              </a:rPr>
+              <a:t>pg</a:t>
+            </a:r>
+            <a:endParaRPr lang="en-US" sz="3600" baseline="-25000" dirty="0">
+              <a:solidFill>
+                <a:srgbClr val="FF0000"/>
+              </a:solidFill>
+            </a:endParaRPr>
+          </a:p>
+        </p:txBody>
+      </p:sp>
+      <p:sp>
+        <p:nvSpPr>
+          <p:cNvPr id="30" name="Left Arrow 29">
+            <a:extLst>
+              <a:ext uri="{FF2B5EF4-FFF2-40B4-BE49-F238E27FC236}">
+                <a16:creationId xmlns:a16="http://schemas.microsoft.com/office/drawing/2014/main" id="{A4122155-8F10-7D41-48B3-4D8FA7702BCA}"/>
+              </a:ext>
+            </a:extLst>
+          </p:cNvPr>
+          <p:cNvSpPr/>
+          <p:nvPr/>
+        </p:nvSpPr>
+        <p:spPr>
+          <a:xfrm>
+            <a:off x="5256625" y="1719730"/>
+            <a:ext cx="1158240" cy="335280"/>
+          </a:xfrm>
+          <a:prstGeom prst="leftArrow">
+            <a:avLst/>
+          </a:prstGeom>
+          <a:solidFill>
+            <a:srgbClr val="FF0000"/>
+          </a:solidFill>
+          <a:ln>
+            <a:noFill/>
+          </a:ln>
+        </p:spPr>
+        <p:style>
+          <a:lnRef idx="2">
+            <a:schemeClr val="accent1">
+              <a:shade val="50000"/>
+            </a:schemeClr>
+          </a:lnRef>
+          <a:fillRef idx="1">
+            <a:schemeClr val="accent1"/>
+          </a:fillRef>
+          <a:effectRef idx="0">
+            <a:schemeClr val="accent1"/>
+          </a:effectRef>
+          <a:fontRef idx="minor">
+            <a:schemeClr val="lt1"/>
+          </a:fontRef>
+        </p:style>
+        <p:txBody>
+          <a:bodyPr rtlCol="0" anchor="ctr"/>
+          <a:lstStyle/>
+          <a:p>
+            <a:pPr algn="ctr"/>
+            <a:endParaRPr lang="en-US"/>
+          </a:p>
+        </p:txBody>
+      </p:sp>
+      <p:sp>
+        <p:nvSpPr>
+          <p:cNvPr id="31" name="TextBox 30">
+            <a:extLst>
+              <a:ext uri="{FF2B5EF4-FFF2-40B4-BE49-F238E27FC236}">
+                <a16:creationId xmlns:a16="http://schemas.microsoft.com/office/drawing/2014/main" id="{D7AAE4DA-961B-8FAB-301E-39E54ADE69DC}"/>
+              </a:ext>
+            </a:extLst>
+          </p:cNvPr>
+          <p:cNvSpPr txBox="1"/>
+          <p:nvPr/>
+        </p:nvSpPr>
+        <p:spPr>
+          <a:xfrm>
+            <a:off x="6475824" y="1494104"/>
+            <a:ext cx="781432" cy="769441"/>
+          </a:xfrm>
+          <a:prstGeom prst="rect">
+            <a:avLst/>
+          </a:prstGeom>
+          <a:noFill/>
+        </p:spPr>
+        <p:txBody>
+          <a:bodyPr wrap="none" rtlCol="0">
+            <a:spAutoFit/>
+          </a:bodyPr>
+          <a:lstStyle/>
+          <a:p>
+            <a:r>
+              <a:rPr lang="en-US" sz="4400" dirty="0" err="1">
+                <a:solidFill>
+                  <a:srgbClr val="FF0000"/>
+                </a:solidFill>
+              </a:rPr>
+              <a:t>F</a:t>
+            </a:r>
+            <a:r>
+              <a:rPr lang="en-US" sz="4400" baseline="-25000" dirty="0" err="1">
+                <a:solidFill>
+                  <a:srgbClr val="FF0000"/>
+                </a:solidFill>
+              </a:rPr>
+              <a:t>ex</a:t>
+            </a:r>
+            <a:endParaRPr lang="en-US" sz="4400" baseline="-25000" dirty="0">
+              <a:solidFill>
+                <a:srgbClr val="FF0000"/>
+              </a:solidFill>
+            </a:endParaRPr>
+          </a:p>
+        </p:txBody>
+      </p:sp>
+      <p:sp>
+        <p:nvSpPr>
+          <p:cNvPr id="32" name="Left Arrow 31">
+            <a:extLst>
+              <a:ext uri="{FF2B5EF4-FFF2-40B4-BE49-F238E27FC236}">
+                <a16:creationId xmlns:a16="http://schemas.microsoft.com/office/drawing/2014/main" id="{A1F323C0-A915-F6E2-B652-B17952D13E5A}"/>
+              </a:ext>
+            </a:extLst>
+          </p:cNvPr>
+          <p:cNvSpPr/>
+          <p:nvPr/>
+        </p:nvSpPr>
+        <p:spPr>
+          <a:xfrm flipH="1">
+            <a:off x="3741175" y="1716013"/>
+            <a:ext cx="1170877" cy="367247"/>
+          </a:xfrm>
+          <a:prstGeom prst="leftArrow">
+            <a:avLst>
+              <a:gd name="adj1" fmla="val 50000"/>
+              <a:gd name="adj2" fmla="val 53037"/>
+            </a:avLst>
+          </a:prstGeom>
+          <a:solidFill>
+            <a:srgbClr val="FF0000"/>
+          </a:solidFill>
+          <a:ln>
+            <a:noFill/>
+          </a:ln>
+        </p:spPr>
+        <p:style>
+          <a:lnRef idx="2">
+            <a:schemeClr val="accent1">
+              <a:shade val="50000"/>
+            </a:schemeClr>
+          </a:lnRef>
+          <a:fillRef idx="1">
+            <a:schemeClr val="accent1"/>
+          </a:fillRef>
+          <a:effectRef idx="0">
+            <a:schemeClr val="accent1"/>
+          </a:effectRef>
+          <a:fontRef idx="minor">
+            <a:schemeClr val="lt1"/>
+          </a:fontRef>
+        </p:style>
+        <p:txBody>
+          <a:bodyPr rtlCol="0" anchor="ctr"/>
+          <a:lstStyle/>
+          <a:p>
+            <a:pPr algn="ctr"/>
+            <a:endParaRPr lang="en-US"/>
+          </a:p>
+        </p:txBody>
+      </p:sp>
+      <p:sp>
+        <p:nvSpPr>
+          <p:cNvPr id="33" name="TextBox 32">
+            <a:extLst>
+              <a:ext uri="{FF2B5EF4-FFF2-40B4-BE49-F238E27FC236}">
+                <a16:creationId xmlns:a16="http://schemas.microsoft.com/office/drawing/2014/main" id="{889D2C21-4BD0-22C0-2FA4-05D1EA94E02C}"/>
+              </a:ext>
+            </a:extLst>
+          </p:cNvPr>
+          <p:cNvSpPr txBox="1"/>
+          <p:nvPr/>
+        </p:nvSpPr>
+        <p:spPr>
+          <a:xfrm>
+            <a:off x="3862722" y="1869528"/>
+            <a:ext cx="702436" cy="646331"/>
+          </a:xfrm>
+          <a:prstGeom prst="rect">
+            <a:avLst/>
+          </a:prstGeom>
+          <a:noFill/>
+        </p:spPr>
+        <p:txBody>
+          <a:bodyPr wrap="none" rtlCol="0">
+            <a:spAutoFit/>
+          </a:bodyPr>
+          <a:lstStyle/>
+          <a:p>
+            <a:r>
+              <a:rPr lang="en-US" sz="3600" dirty="0" err="1">
+                <a:solidFill>
+                  <a:srgbClr val="FF0000"/>
+                </a:solidFill>
+              </a:rPr>
+              <a:t>F</a:t>
+            </a:r>
+            <a:r>
+              <a:rPr lang="en-US" sz="3600" baseline="-25000" dirty="0" err="1">
+                <a:solidFill>
+                  <a:srgbClr val="FF0000"/>
+                </a:solidFill>
+              </a:rPr>
+              <a:t>pg</a:t>
+            </a:r>
+            <a:endParaRPr lang="en-US" sz="3600" baseline="-25000" dirty="0">
+              <a:solidFill>
+                <a:srgbClr val="FF0000"/>
+              </a:solidFill>
+            </a:endParaRPr>
+          </a:p>
+        </p:txBody>
+      </p:sp>
+    </p:spTree>
+    <p:extLst>
+      <p:ext uri="{BB962C8B-B14F-4D97-AF65-F5344CB8AC3E}">
+        <p14:creationId xmlns:p14="http://schemas.microsoft.com/office/powerpoint/2010/main" val="4146382728"/>
+      </p:ext>
+    </p:extLst>
+  </p:cSld>
+  <p:clrMapOvr>
+    <a:masterClrMapping/>
+  </p:clrMapOvr>
+</p:sld>
+</file>
+
+<file path=ppt/slides/slide12.xml><?xml version="1.0" encoding="utf-8"?>
 <p:sld xmlns:a="http://schemas.openxmlformats.org/drawingml/2006/main" xmlns:r="http://schemas.openxmlformats.org/officeDocument/2006/relationships" xmlns:p="http://schemas.openxmlformats.org/presentationml/2006/main">
   <p:cSld>
     <p:spTree>
@@ -8256,7 +9547,7 @@
 </p:sld>
 </file>
 
-<file path=ppt/slides/slide12.xml><?xml version="1.0" encoding="utf-8"?>
+<file path=ppt/slides/slide13.xml><?xml version="1.0" encoding="utf-8"?>
 <p:sld xmlns:a="http://schemas.openxmlformats.org/drawingml/2006/main" xmlns:r="http://schemas.openxmlformats.org/officeDocument/2006/relationships" xmlns:p="http://schemas.openxmlformats.org/presentationml/2006/main">
   <p:cSld>
     <p:spTree>
@@ -9059,7 +10350,7 @@
 </p:sld>
 </file>
 
-<file path=ppt/slides/slide13.xml><?xml version="1.0" encoding="utf-8"?>
+<file path=ppt/slides/slide14.xml><?xml version="1.0" encoding="utf-8"?>
 <p:sld xmlns:a="http://schemas.openxmlformats.org/drawingml/2006/main" xmlns:r="http://schemas.openxmlformats.org/officeDocument/2006/relationships" xmlns:p="http://schemas.openxmlformats.org/presentationml/2006/main">
   <p:cSld>
     <p:spTree>
@@ -9812,7 +11103,7 @@
 </p:sld>
 </file>
 
-<file path=ppt/slides/slide14.xml><?xml version="1.0" encoding="utf-8"?>
+<file path=ppt/slides/slide15.xml><?xml version="1.0" encoding="utf-8"?>
 <p:sld xmlns:a="http://schemas.openxmlformats.org/drawingml/2006/main" xmlns:r="http://schemas.openxmlformats.org/officeDocument/2006/relationships" xmlns:p="http://schemas.openxmlformats.org/presentationml/2006/main">
   <p:cSld>
     <p:spTree>
@@ -10567,7 +11858,7 @@
 </p:sld>
 </file>
 
-<file path=ppt/slides/slide15.xml><?xml version="1.0" encoding="utf-8"?>
+<file path=ppt/slides/slide16.xml><?xml version="1.0" encoding="utf-8"?>
 <p:sld xmlns:a="http://schemas.openxmlformats.org/drawingml/2006/main" xmlns:r="http://schemas.openxmlformats.org/officeDocument/2006/relationships" xmlns:p="http://schemas.openxmlformats.org/presentationml/2006/main">
   <p:cSld>
     <p:spTree>
@@ -12828,7 +14119,7 @@
 </p:sld>
 </file>
 
-<file path=ppt/slides/slide16.xml><?xml version="1.0" encoding="utf-8"?>
+<file path=ppt/slides/slide17.xml><?xml version="1.0" encoding="utf-8"?>
 <p:sld xmlns:a="http://schemas.openxmlformats.org/drawingml/2006/main" xmlns:r="http://schemas.openxmlformats.org/officeDocument/2006/relationships" xmlns:p="http://schemas.openxmlformats.org/presentationml/2006/main">
   <p:cSld>
     <p:spTree>
@@ -12869,7 +14160,7 @@
             <a:fld id="{005D29CD-E9E5-43F0-9F4C-9122175FCE73}" type="slidenum">
               <a:rPr lang="en-US" smtClean="0"/>
               <a:pPr/>
-              <a:t>16</a:t>
+              <a:t>17</a:t>
             </a:fld>
             <a:endParaRPr lang="en-US"/>
           </a:p>
@@ -15210,7 +16501,7 @@
 </p:sld>
 </file>
 
-<file path=ppt/slides/slide17.xml><?xml version="1.0" encoding="utf-8"?>
+<file path=ppt/slides/slide18.xml><?xml version="1.0" encoding="utf-8"?>
 <p:sld xmlns:a="http://schemas.openxmlformats.org/drawingml/2006/main" xmlns:r="http://schemas.openxmlformats.org/officeDocument/2006/relationships" xmlns:p="http://schemas.openxmlformats.org/presentationml/2006/main">
   <p:cSld>
     <p:spTree>
@@ -15305,7 +16596,7 @@
 </p:sld>
 </file>
 
-<file path=ppt/slides/slide18.xml><?xml version="1.0" encoding="utf-8"?>
+<file path=ppt/slides/slide19.xml><?xml version="1.0" encoding="utf-8"?>
 <p:sld xmlns:a="http://schemas.openxmlformats.org/drawingml/2006/main" xmlns:r="http://schemas.openxmlformats.org/officeDocument/2006/relationships" xmlns:p="http://schemas.openxmlformats.org/presentationml/2006/main">
   <p:cSld>
     <p:spTree>
@@ -15400,7 +16691,213 @@
 </p:sld>
 </file>
 
-<file path=ppt/slides/slide19.xml><?xml version="1.0" encoding="utf-8"?>
+<file path=ppt/slides/slide2.xml><?xml version="1.0" encoding="utf-8"?>
+<p:sld xmlns:a="http://schemas.openxmlformats.org/drawingml/2006/main" xmlns:r="http://schemas.openxmlformats.org/officeDocument/2006/relationships" xmlns:p="http://schemas.openxmlformats.org/presentationml/2006/main">
+  <p:cSld>
+    <p:spTree>
+      <p:nvGrpSpPr>
+        <p:cNvPr id="1" name=""/>
+        <p:cNvGrpSpPr/>
+        <p:nvPr/>
+      </p:nvGrpSpPr>
+      <p:grpSpPr>
+        <a:xfrm>
+          <a:off x="0" y="0"/>
+          <a:ext cx="0" cy="0"/>
+          <a:chOff x="0" y="0"/>
+          <a:chExt cx="0" cy="0"/>
+        </a:xfrm>
+      </p:grpSpPr>
+      <p:sp>
+        <p:nvSpPr>
+          <p:cNvPr id="2" name="Title 1"/>
+          <p:cNvSpPr>
+            <a:spLocks noGrp="1"/>
+          </p:cNvSpPr>
+          <p:nvPr>
+            <p:ph type="title"/>
+          </p:nvPr>
+        </p:nvSpPr>
+        <p:spPr/>
+        <p:txBody>
+          <a:bodyPr/>
+          <a:lstStyle/>
+          <a:p>
+            <a:r>
+              <a:rPr lang="en-US" dirty="0"/>
+              <a:t>Question 123.10.1</a:t>
+            </a:r>
+          </a:p>
+        </p:txBody>
+      </p:sp>
+      <p:sp>
+        <p:nvSpPr>
+          <p:cNvPr id="3" name="Content Placeholder 2"/>
+          <p:cNvSpPr>
+            <a:spLocks noGrp="1"/>
+          </p:cNvSpPr>
+          <p:nvPr>
+            <p:ph idx="1"/>
+          </p:nvPr>
+        </p:nvSpPr>
+        <p:spPr/>
+        <p:txBody>
+          <a:bodyPr/>
+          <a:lstStyle/>
+          <a:p>
+            <a:pPr>
+              <a:buNone/>
+            </a:pPr>
+            <a:r>
+              <a:rPr lang="en-US" dirty="0"/>
+              <a:t>In the work energy theorem, </a:t>
+            </a:r>
+            <a:r>
+              <a:rPr lang="en-US" dirty="0">
+                <a:sym typeface="Symbol"/>
+              </a:rPr>
+              <a:t>K = ?</a:t>
+            </a:r>
+          </a:p>
+          <a:p>
+            <a:pPr>
+              <a:buNone/>
+            </a:pPr>
+            <a:endParaRPr lang="en-US" dirty="0">
+              <a:sym typeface="Symbol"/>
+            </a:endParaRPr>
+          </a:p>
+          <a:p>
+            <a:pPr marL="514350" indent="-514350">
+              <a:buFont typeface="+mj-lt"/>
+              <a:buAutoNum type="alphaLcParenR"/>
+            </a:pPr>
+            <a:r>
+              <a:rPr lang="en-US" dirty="0">
+                <a:sym typeface="Symbol"/>
+              </a:rPr>
+              <a:t>w</a:t>
+            </a:r>
+          </a:p>
+          <a:p>
+            <a:pPr marL="514350" indent="-514350">
+              <a:buFont typeface="+mj-lt"/>
+              <a:buAutoNum type="alphaLcParenR"/>
+            </a:pPr>
+            <a:r>
+              <a:rPr lang="en-US" dirty="0">
+                <a:sym typeface="Symbol"/>
+              </a:rPr>
+              <a:t>U</a:t>
+            </a:r>
+          </a:p>
+          <a:p>
+            <a:pPr marL="514350" indent="-514350">
+              <a:buFont typeface="+mj-lt"/>
+              <a:buAutoNum type="alphaLcParenR"/>
+            </a:pPr>
+            <a:r>
+              <a:rPr lang="en-US" dirty="0">
+                <a:sym typeface="Symbol"/>
+              </a:rPr>
+              <a:t>F</a:t>
+            </a:r>
+          </a:p>
+          <a:p>
+            <a:pPr marL="514350" indent="-514350">
+              <a:buFont typeface="+mj-lt"/>
+              <a:buAutoNum type="alphaLcParenR"/>
+            </a:pPr>
+            <a:r>
+              <a:rPr lang="en-US" dirty="0">
+                <a:sym typeface="Symbol"/>
+              </a:rPr>
+              <a:t>0.5mv</a:t>
+            </a:r>
+            <a:r>
+              <a:rPr lang="en-US" baseline="30000" dirty="0">
+                <a:sym typeface="Symbol"/>
+              </a:rPr>
+              <a:t>2</a:t>
+            </a:r>
+            <a:endParaRPr lang="en-US" baseline="30000" dirty="0"/>
+          </a:p>
+        </p:txBody>
+      </p:sp>
+      <p:sp>
+        <p:nvSpPr>
+          <p:cNvPr id="4" name="Slide Number Placeholder 3"/>
+          <p:cNvSpPr>
+            <a:spLocks noGrp="1"/>
+          </p:cNvSpPr>
+          <p:nvPr>
+            <p:ph type="sldNum" sz="quarter" idx="12"/>
+          </p:nvPr>
+        </p:nvSpPr>
+        <p:spPr/>
+        <p:txBody>
+          <a:bodyPr/>
+          <a:lstStyle/>
+          <a:p>
+            <a:pPr>
+              <a:defRPr/>
+            </a:pPr>
+            <a:fld id="{4E87D1FB-7ED3-4D53-B026-4508F19EE3B8}" type="slidenum">
+              <a:rPr lang="en-US" smtClean="0"/>
+              <a:pPr>
+                <a:defRPr/>
+              </a:pPr>
+              <a:t>2</a:t>
+            </a:fld>
+            <a:endParaRPr lang="en-US"/>
+          </a:p>
+        </p:txBody>
+      </p:sp>
+      <p:sp>
+        <p:nvSpPr>
+          <p:cNvPr id="5" name="Rectangle 4"/>
+          <p:cNvSpPr/>
+          <p:nvPr/>
+        </p:nvSpPr>
+        <p:spPr>
+          <a:xfrm>
+            <a:off x="4437187" y="3244334"/>
+            <a:ext cx="269626" cy="369332"/>
+          </a:xfrm>
+          <a:prstGeom prst="rect">
+            <a:avLst/>
+          </a:prstGeom>
+        </p:spPr>
+        <p:txBody>
+          <a:bodyPr wrap="none">
+            <a:spAutoFit/>
+          </a:bodyPr>
+          <a:lstStyle/>
+          <a:p>
+            <a:r>
+              <a:rPr lang="en-US" baseline="30000" dirty="0">
+                <a:sym typeface="Symbol"/>
+              </a:rPr>
+              <a:t>2</a:t>
+            </a:r>
+            <a:endParaRPr lang="en-US" dirty="0"/>
+          </a:p>
+        </p:txBody>
+      </p:sp>
+    </p:spTree>
+    <p:extLst>
+      <p:ext uri="{BB962C8B-B14F-4D97-AF65-F5344CB8AC3E}">
+        <p14:creationId xmlns:p14="http://schemas.microsoft.com/office/powerpoint/2010/main" val="3199979828"/>
+      </p:ext>
+    </p:extLst>
+  </p:cSld>
+  <p:clrMapOvr>
+    <a:masterClrMapping/>
+  </p:clrMapOvr>
+</p:sld>
+</file>
+
+<file path=ppt/slides/slide20.xml><?xml version="1.0" encoding="utf-8"?>
 <p:sld xmlns:a="http://schemas.openxmlformats.org/drawingml/2006/main" xmlns:r="http://schemas.openxmlformats.org/officeDocument/2006/relationships" xmlns:p="http://schemas.openxmlformats.org/presentationml/2006/main">
   <p:cSld>
     <p:spTree>
@@ -15530,213 +17027,7 @@
 </p:sld>
 </file>
 
-<file path=ppt/slides/slide2.xml><?xml version="1.0" encoding="utf-8"?>
-<p:sld xmlns:a="http://schemas.openxmlformats.org/drawingml/2006/main" xmlns:r="http://schemas.openxmlformats.org/officeDocument/2006/relationships" xmlns:p="http://schemas.openxmlformats.org/presentationml/2006/main">
-  <p:cSld>
-    <p:spTree>
-      <p:nvGrpSpPr>
-        <p:cNvPr id="1" name=""/>
-        <p:cNvGrpSpPr/>
-        <p:nvPr/>
-      </p:nvGrpSpPr>
-      <p:grpSpPr>
-        <a:xfrm>
-          <a:off x="0" y="0"/>
-          <a:ext cx="0" cy="0"/>
-          <a:chOff x="0" y="0"/>
-          <a:chExt cx="0" cy="0"/>
-        </a:xfrm>
-      </p:grpSpPr>
-      <p:sp>
-        <p:nvSpPr>
-          <p:cNvPr id="2" name="Title 1"/>
-          <p:cNvSpPr>
-            <a:spLocks noGrp="1"/>
-          </p:cNvSpPr>
-          <p:nvPr>
-            <p:ph type="title"/>
-          </p:nvPr>
-        </p:nvSpPr>
-        <p:spPr/>
-        <p:txBody>
-          <a:bodyPr/>
-          <a:lstStyle/>
-          <a:p>
-            <a:r>
-              <a:rPr lang="en-US" dirty="0"/>
-              <a:t>Question 123.10.1</a:t>
-            </a:r>
-          </a:p>
-        </p:txBody>
-      </p:sp>
-      <p:sp>
-        <p:nvSpPr>
-          <p:cNvPr id="3" name="Content Placeholder 2"/>
-          <p:cNvSpPr>
-            <a:spLocks noGrp="1"/>
-          </p:cNvSpPr>
-          <p:nvPr>
-            <p:ph idx="1"/>
-          </p:nvPr>
-        </p:nvSpPr>
-        <p:spPr/>
-        <p:txBody>
-          <a:bodyPr/>
-          <a:lstStyle/>
-          <a:p>
-            <a:pPr>
-              <a:buNone/>
-            </a:pPr>
-            <a:r>
-              <a:rPr lang="en-US" dirty="0"/>
-              <a:t>In the work energy theorem, </a:t>
-            </a:r>
-            <a:r>
-              <a:rPr lang="en-US" dirty="0">
-                <a:sym typeface="Symbol"/>
-              </a:rPr>
-              <a:t>K = ?</a:t>
-            </a:r>
-          </a:p>
-          <a:p>
-            <a:pPr>
-              <a:buNone/>
-            </a:pPr>
-            <a:endParaRPr lang="en-US" dirty="0">
-              <a:sym typeface="Symbol"/>
-            </a:endParaRPr>
-          </a:p>
-          <a:p>
-            <a:pPr marL="514350" indent="-514350">
-              <a:buFont typeface="+mj-lt"/>
-              <a:buAutoNum type="alphaLcParenR"/>
-            </a:pPr>
-            <a:r>
-              <a:rPr lang="en-US" dirty="0">
-                <a:sym typeface="Symbol"/>
-              </a:rPr>
-              <a:t>W</a:t>
-            </a:r>
-          </a:p>
-          <a:p>
-            <a:pPr marL="514350" indent="-514350">
-              <a:buFont typeface="+mj-lt"/>
-              <a:buAutoNum type="alphaLcParenR"/>
-            </a:pPr>
-            <a:r>
-              <a:rPr lang="en-US" dirty="0">
-                <a:sym typeface="Symbol"/>
-              </a:rPr>
-              <a:t>U</a:t>
-            </a:r>
-          </a:p>
-          <a:p>
-            <a:pPr marL="514350" indent="-514350">
-              <a:buFont typeface="+mj-lt"/>
-              <a:buAutoNum type="alphaLcParenR"/>
-            </a:pPr>
-            <a:r>
-              <a:rPr lang="en-US" dirty="0">
-                <a:sym typeface="Symbol"/>
-              </a:rPr>
-              <a:t>F</a:t>
-            </a:r>
-          </a:p>
-          <a:p>
-            <a:pPr marL="514350" indent="-514350">
-              <a:buFont typeface="+mj-lt"/>
-              <a:buAutoNum type="alphaLcParenR"/>
-            </a:pPr>
-            <a:r>
-              <a:rPr lang="en-US" dirty="0">
-                <a:sym typeface="Symbol"/>
-              </a:rPr>
-              <a:t>0.5mv</a:t>
-            </a:r>
-            <a:r>
-              <a:rPr lang="en-US" baseline="30000" dirty="0">
-                <a:sym typeface="Symbol"/>
-              </a:rPr>
-              <a:t>2</a:t>
-            </a:r>
-            <a:endParaRPr lang="en-US" baseline="30000" dirty="0"/>
-          </a:p>
-        </p:txBody>
-      </p:sp>
-      <p:sp>
-        <p:nvSpPr>
-          <p:cNvPr id="4" name="Slide Number Placeholder 3"/>
-          <p:cNvSpPr>
-            <a:spLocks noGrp="1"/>
-          </p:cNvSpPr>
-          <p:nvPr>
-            <p:ph type="sldNum" sz="quarter" idx="12"/>
-          </p:nvPr>
-        </p:nvSpPr>
-        <p:spPr/>
-        <p:txBody>
-          <a:bodyPr/>
-          <a:lstStyle/>
-          <a:p>
-            <a:pPr>
-              <a:defRPr/>
-            </a:pPr>
-            <a:fld id="{4E87D1FB-7ED3-4D53-B026-4508F19EE3B8}" type="slidenum">
-              <a:rPr lang="en-US" smtClean="0"/>
-              <a:pPr>
-                <a:defRPr/>
-              </a:pPr>
-              <a:t>2</a:t>
-            </a:fld>
-            <a:endParaRPr lang="en-US"/>
-          </a:p>
-        </p:txBody>
-      </p:sp>
-      <p:sp>
-        <p:nvSpPr>
-          <p:cNvPr id="5" name="Rectangle 4"/>
-          <p:cNvSpPr/>
-          <p:nvPr/>
-        </p:nvSpPr>
-        <p:spPr>
-          <a:xfrm>
-            <a:off x="4437187" y="3244334"/>
-            <a:ext cx="269626" cy="369332"/>
-          </a:xfrm>
-          <a:prstGeom prst="rect">
-            <a:avLst/>
-          </a:prstGeom>
-        </p:spPr>
-        <p:txBody>
-          <a:bodyPr wrap="none">
-            <a:spAutoFit/>
-          </a:bodyPr>
-          <a:lstStyle/>
-          <a:p>
-            <a:r>
-              <a:rPr lang="en-US" baseline="30000" dirty="0">
-                <a:sym typeface="Symbol"/>
-              </a:rPr>
-              <a:t>2</a:t>
-            </a:r>
-            <a:endParaRPr lang="en-US" dirty="0"/>
-          </a:p>
-        </p:txBody>
-      </p:sp>
-    </p:spTree>
-    <p:extLst>
-      <p:ext uri="{BB962C8B-B14F-4D97-AF65-F5344CB8AC3E}">
-        <p14:creationId xmlns:p14="http://schemas.microsoft.com/office/powerpoint/2010/main" val="3199979828"/>
-      </p:ext>
-    </p:extLst>
-  </p:cSld>
-  <p:clrMapOvr>
-    <a:masterClrMapping/>
-  </p:clrMapOvr>
-</p:sld>
-</file>
-
-<file path=ppt/slides/slide20.xml><?xml version="1.0" encoding="utf-8"?>
+<file path=ppt/slides/slide21.xml><?xml version="1.0" encoding="utf-8"?>
 <p:sld xmlns:a="http://schemas.openxmlformats.org/drawingml/2006/main" xmlns:r="http://schemas.openxmlformats.org/officeDocument/2006/relationships" xmlns:p="http://schemas.openxmlformats.org/presentationml/2006/main">
   <p:cSld>
     <p:spTree>
@@ -15932,8 +17223,8 @@
           </a:p>
         </p:txBody>
       </p:sp>
-      <mc:AlternateContent xmlns:mc="http://schemas.openxmlformats.org/markup-compatibility/2006">
-        <mc:Choice xmlns:a14="http://schemas.microsoft.com/office/drawing/2010/main" Requires="a14">
+      <mc:AlternateContent xmlns:mc="http://schemas.openxmlformats.org/markup-compatibility/2006" xmlns:a14="http://schemas.microsoft.com/office/drawing/2010/main">
+        <mc:Choice Requires="a14">
           <p:sp>
             <p:nvSpPr>
               <p:cNvPr id="6" name="TextBox 5">
@@ -15962,6 +17253,7 @@
               </a:bodyPr>
               <a:lstStyle/>
               <a:p>
+                <a:pPr/>
                 <a14:m>
                   <m:oMathPara xmlns:m="http://schemas.openxmlformats.org/officeDocument/2006/math">
                     <m:oMathParaPr>
@@ -16011,7 +17303,7 @@
             </p:txBody>
           </p:sp>
         </mc:Choice>
-        <mc:Fallback>
+        <mc:Fallback xmlns="">
           <p:sp>
             <p:nvSpPr>
               <p:cNvPr id="6" name="TextBox 5">
@@ -16056,8 +17348,8 @@
           </p:sp>
         </mc:Fallback>
       </mc:AlternateContent>
-      <mc:AlternateContent xmlns:mc="http://schemas.openxmlformats.org/markup-compatibility/2006">
-        <mc:Choice xmlns:a14="http://schemas.microsoft.com/office/drawing/2010/main" Requires="a14">
+      <mc:AlternateContent xmlns:mc="http://schemas.openxmlformats.org/markup-compatibility/2006" xmlns:a14="http://schemas.microsoft.com/office/drawing/2010/main">
+        <mc:Choice Requires="a14">
           <p:sp>
             <p:nvSpPr>
               <p:cNvPr id="14" name="TextBox 13">
@@ -16086,6 +17378,7 @@
               </a:bodyPr>
               <a:lstStyle/>
               <a:p>
+                <a:pPr/>
                 <a14:m>
                   <m:oMathPara xmlns:m="http://schemas.openxmlformats.org/officeDocument/2006/math">
                     <m:oMathParaPr>
@@ -16144,7 +17437,7 @@
             </p:txBody>
           </p:sp>
         </mc:Choice>
-        <mc:Fallback>
+        <mc:Fallback xmlns="">
           <p:sp>
             <p:nvSpPr>
               <p:cNvPr id="14" name="TextBox 13">
@@ -16189,8 +17482,8 @@
           </p:sp>
         </mc:Fallback>
       </mc:AlternateContent>
-      <mc:AlternateContent xmlns:mc="http://schemas.openxmlformats.org/markup-compatibility/2006">
-        <mc:Choice xmlns:a14="http://schemas.microsoft.com/office/drawing/2010/main" Requires="a14">
+      <mc:AlternateContent xmlns:mc="http://schemas.openxmlformats.org/markup-compatibility/2006" xmlns:a14="http://schemas.microsoft.com/office/drawing/2010/main">
+        <mc:Choice Requires="a14">
           <p:sp>
             <p:nvSpPr>
               <p:cNvPr id="15" name="TextBox 14">
@@ -16219,6 +17512,7 @@
               </a:bodyPr>
               <a:lstStyle/>
               <a:p>
+                <a:pPr/>
                 <a14:m>
                   <m:oMathPara xmlns:m="http://schemas.openxmlformats.org/officeDocument/2006/math">
                     <m:oMathParaPr>
@@ -16277,7 +17571,7 @@
             </p:txBody>
           </p:sp>
         </mc:Choice>
-        <mc:Fallback>
+        <mc:Fallback xmlns="">
           <p:sp>
             <p:nvSpPr>
               <p:cNvPr id="15" name="TextBox 14">
@@ -16335,7 +17629,7 @@
 </p:sld>
 </file>
 
-<file path=ppt/slides/slide21.xml><?xml version="1.0" encoding="utf-8"?>
+<file path=ppt/slides/slide22.xml><?xml version="1.0" encoding="utf-8"?>
 <p:sld xmlns:a="http://schemas.openxmlformats.org/drawingml/2006/main" xmlns:r="http://schemas.openxmlformats.org/officeDocument/2006/relationships" xmlns:p="http://schemas.openxmlformats.org/presentationml/2006/main">
   <p:cSld>
     <p:spTree>
@@ -16531,8 +17825,8 @@
           </a:p>
         </p:txBody>
       </p:sp>
-      <mc:AlternateContent xmlns:mc="http://schemas.openxmlformats.org/markup-compatibility/2006">
-        <mc:Choice xmlns:a14="http://schemas.microsoft.com/office/drawing/2010/main" Requires="a14">
+      <mc:AlternateContent xmlns:mc="http://schemas.openxmlformats.org/markup-compatibility/2006" xmlns:a14="http://schemas.microsoft.com/office/drawing/2010/main">
+        <mc:Choice Requires="a14">
           <p:sp>
             <p:nvSpPr>
               <p:cNvPr id="6" name="TextBox 5">
@@ -16561,6 +17855,7 @@
               </a:bodyPr>
               <a:lstStyle/>
               <a:p>
+                <a:pPr/>
                 <a14:m>
                   <m:oMathPara xmlns:m="http://schemas.openxmlformats.org/officeDocument/2006/math">
                     <m:oMathParaPr>
@@ -16610,7 +17905,7 @@
             </p:txBody>
           </p:sp>
         </mc:Choice>
-        <mc:Fallback>
+        <mc:Fallback xmlns="">
           <p:sp>
             <p:nvSpPr>
               <p:cNvPr id="6" name="TextBox 5">
@@ -16694,8 +17989,8 @@
           </a:fontRef>
         </p:style>
       </p:cxnSp>
-      <mc:AlternateContent xmlns:mc="http://schemas.openxmlformats.org/markup-compatibility/2006">
-        <mc:Choice xmlns:a14="http://schemas.microsoft.com/office/drawing/2010/main" Requires="a14">
+      <mc:AlternateContent xmlns:mc="http://schemas.openxmlformats.org/markup-compatibility/2006" xmlns:a14="http://schemas.microsoft.com/office/drawing/2010/main">
+        <mc:Choice Requires="a14">
           <p:sp>
             <p:nvSpPr>
               <p:cNvPr id="11" name="TextBox 10">
@@ -16724,6 +18019,7 @@
               </a:bodyPr>
               <a:lstStyle/>
               <a:p>
+                <a:pPr/>
                 <a14:m>
                   <m:oMathPara xmlns:m="http://schemas.openxmlformats.org/officeDocument/2006/math">
                     <m:oMathParaPr>
@@ -16782,7 +18078,7 @@
             </p:txBody>
           </p:sp>
         </mc:Choice>
-        <mc:Fallback>
+        <mc:Fallback xmlns="">
           <p:sp>
             <p:nvSpPr>
               <p:cNvPr id="11" name="TextBox 10">
@@ -16827,8 +18123,8 @@
           </p:sp>
         </mc:Fallback>
       </mc:AlternateContent>
-      <mc:AlternateContent xmlns:mc="http://schemas.openxmlformats.org/markup-compatibility/2006">
-        <mc:Choice xmlns:a14="http://schemas.microsoft.com/office/drawing/2010/main" Requires="a14">
+      <mc:AlternateContent xmlns:mc="http://schemas.openxmlformats.org/markup-compatibility/2006" xmlns:a14="http://schemas.microsoft.com/office/drawing/2010/main">
+        <mc:Choice Requires="a14">
           <p:sp>
             <p:nvSpPr>
               <p:cNvPr id="12" name="TextBox 11">
@@ -16857,6 +18153,7 @@
               </a:bodyPr>
               <a:lstStyle/>
               <a:p>
+                <a:pPr/>
                 <a14:m>
                   <m:oMathPara xmlns:m="http://schemas.openxmlformats.org/officeDocument/2006/math">
                     <m:oMathParaPr>
@@ -16915,7 +18212,7 @@
             </p:txBody>
           </p:sp>
         </mc:Choice>
-        <mc:Fallback>
+        <mc:Fallback xmlns="">
           <p:sp>
             <p:nvSpPr>
               <p:cNvPr id="12" name="TextBox 11">
@@ -16973,7 +18270,7 @@
 </p:sld>
 </file>
 
-<file path=ppt/slides/slide22.xml><?xml version="1.0" encoding="utf-8"?>
+<file path=ppt/slides/slide23.xml><?xml version="1.0" encoding="utf-8"?>
 <p:sld xmlns:a="http://schemas.openxmlformats.org/drawingml/2006/main" xmlns:r="http://schemas.openxmlformats.org/officeDocument/2006/relationships" xmlns:p="http://schemas.openxmlformats.org/presentationml/2006/main">
   <p:cSld>
     <p:spTree>
@@ -17065,8 +18362,8 @@
           </a:fontRef>
         </p:style>
       </p:cxnSp>
-      <mc:AlternateContent xmlns:mc="http://schemas.openxmlformats.org/markup-compatibility/2006">
-        <mc:Choice xmlns:a14="http://schemas.microsoft.com/office/drawing/2010/main" Requires="a14">
+      <mc:AlternateContent xmlns:mc="http://schemas.openxmlformats.org/markup-compatibility/2006" xmlns:a14="http://schemas.microsoft.com/office/drawing/2010/main">
+        <mc:Choice Requires="a14">
           <p:sp>
             <p:nvSpPr>
               <p:cNvPr id="6" name="TextBox 5">
@@ -17095,6 +18392,7 @@
               </a:bodyPr>
               <a:lstStyle/>
               <a:p>
+                <a:pPr/>
                 <a14:m>
                   <m:oMathPara xmlns:m="http://schemas.openxmlformats.org/officeDocument/2006/math">
                     <m:oMathParaPr>
@@ -17144,7 +18442,7 @@
             </p:txBody>
           </p:sp>
         </mc:Choice>
-        <mc:Fallback>
+        <mc:Fallback xmlns="">
           <p:sp>
             <p:nvSpPr>
               <p:cNvPr id="6" name="TextBox 5">
@@ -17371,8 +18669,8 @@
           </a:p>
         </p:txBody>
       </p:sp>
-      <mc:AlternateContent xmlns:mc="http://schemas.openxmlformats.org/markup-compatibility/2006">
-        <mc:Choice xmlns:a14="http://schemas.microsoft.com/office/drawing/2010/main" Requires="a14">
+      <mc:AlternateContent xmlns:mc="http://schemas.openxmlformats.org/markup-compatibility/2006" xmlns:a14="http://schemas.microsoft.com/office/drawing/2010/main">
+        <mc:Choice Requires="a14">
           <p:sp>
             <p:nvSpPr>
               <p:cNvPr id="13" name="TextBox 12">
@@ -17401,6 +18699,7 @@
               </a:bodyPr>
               <a:lstStyle/>
               <a:p>
+                <a:pPr/>
                 <a14:m>
                   <m:oMathPara xmlns:m="http://schemas.openxmlformats.org/officeDocument/2006/math">
                     <m:oMathParaPr>
@@ -17459,7 +18758,7 @@
             </p:txBody>
           </p:sp>
         </mc:Choice>
-        <mc:Fallback>
+        <mc:Fallback xmlns="">
           <p:sp>
             <p:nvSpPr>
               <p:cNvPr id="13" name="TextBox 12">
@@ -17504,8 +18803,8 @@
           </p:sp>
         </mc:Fallback>
       </mc:AlternateContent>
-      <mc:AlternateContent xmlns:mc="http://schemas.openxmlformats.org/markup-compatibility/2006">
-        <mc:Choice xmlns:a14="http://schemas.microsoft.com/office/drawing/2010/main" Requires="a14">
+      <mc:AlternateContent xmlns:mc="http://schemas.openxmlformats.org/markup-compatibility/2006" xmlns:a14="http://schemas.microsoft.com/office/drawing/2010/main">
+        <mc:Choice Requires="a14">
           <p:sp>
             <p:nvSpPr>
               <p:cNvPr id="14" name="TextBox 13">
@@ -17534,6 +18833,7 @@
               </a:bodyPr>
               <a:lstStyle/>
               <a:p>
+                <a:pPr/>
                 <a14:m>
                   <m:oMathPara xmlns:m="http://schemas.openxmlformats.org/officeDocument/2006/math">
                     <m:oMathParaPr>
@@ -17592,7 +18892,7 @@
             </p:txBody>
           </p:sp>
         </mc:Choice>
-        <mc:Fallback>
+        <mc:Fallback xmlns="">
           <p:sp>
             <p:nvSpPr>
               <p:cNvPr id="14" name="TextBox 13">
@@ -17650,7 +18950,7 @@
 </p:sld>
 </file>
 
-<file path=ppt/slides/slide23.xml><?xml version="1.0" encoding="utf-8"?>
+<file path=ppt/slides/slide24.xml><?xml version="1.0" encoding="utf-8"?>
 <p:sld xmlns:a="http://schemas.openxmlformats.org/drawingml/2006/main" xmlns:r="http://schemas.openxmlformats.org/officeDocument/2006/relationships" xmlns:p="http://schemas.openxmlformats.org/presentationml/2006/main">
   <p:cSld>
     <p:spTree>
@@ -17703,8 +19003,8 @@
           </a:prstGeom>
         </p:spPr>
       </p:pic>
-      <mc:AlternateContent xmlns:mc="http://schemas.openxmlformats.org/markup-compatibility/2006">
-        <mc:Choice xmlns:a14="http://schemas.microsoft.com/office/drawing/2010/main" Requires="a14">
+      <mc:AlternateContent xmlns:mc="http://schemas.openxmlformats.org/markup-compatibility/2006" xmlns:a14="http://schemas.microsoft.com/office/drawing/2010/main">
+        <mc:Choice Requires="a14">
           <p:sp>
             <p:nvSpPr>
               <p:cNvPr id="6" name="TextBox 5">
@@ -17733,6 +19033,7 @@
               </a:bodyPr>
               <a:lstStyle/>
               <a:p>
+                <a:pPr/>
                 <a14:m>
                   <m:oMathPara xmlns:m="http://schemas.openxmlformats.org/officeDocument/2006/math">
                     <m:oMathParaPr>
@@ -17782,7 +19083,7 @@
             </p:txBody>
           </p:sp>
         </mc:Choice>
-        <mc:Fallback>
+        <mc:Fallback xmlns="">
           <p:sp>
             <p:nvSpPr>
               <p:cNvPr id="6" name="TextBox 5">
@@ -18104,8 +19405,8 @@
           </a:p>
         </p:txBody>
       </p:sp>
-      <mc:AlternateContent xmlns:mc="http://schemas.openxmlformats.org/markup-compatibility/2006">
-        <mc:Choice xmlns:a14="http://schemas.microsoft.com/office/drawing/2010/main" Requires="a14">
+      <mc:AlternateContent xmlns:mc="http://schemas.openxmlformats.org/markup-compatibility/2006" xmlns:a14="http://schemas.microsoft.com/office/drawing/2010/main">
+        <mc:Choice Requires="a14">
           <p:sp>
             <p:nvSpPr>
               <p:cNvPr id="9" name="TextBox 8">
@@ -18134,6 +19435,7 @@
               </a:bodyPr>
               <a:lstStyle/>
               <a:p>
+                <a:pPr/>
                 <a14:m>
                   <m:oMathPara xmlns:m="http://schemas.openxmlformats.org/officeDocument/2006/math">
                     <m:oMathParaPr>
@@ -18192,7 +19494,7 @@
             </p:txBody>
           </p:sp>
         </mc:Choice>
-        <mc:Fallback>
+        <mc:Fallback xmlns="">
           <p:sp>
             <p:nvSpPr>
               <p:cNvPr id="9" name="TextBox 8">
@@ -18237,8 +19539,8 @@
           </p:sp>
         </mc:Fallback>
       </mc:AlternateContent>
-      <mc:AlternateContent xmlns:mc="http://schemas.openxmlformats.org/markup-compatibility/2006">
-        <mc:Choice xmlns:a14="http://schemas.microsoft.com/office/drawing/2010/main" Requires="a14">
+      <mc:AlternateContent xmlns:mc="http://schemas.openxmlformats.org/markup-compatibility/2006" xmlns:a14="http://schemas.microsoft.com/office/drawing/2010/main">
+        <mc:Choice Requires="a14">
           <p:sp>
             <p:nvSpPr>
               <p:cNvPr id="11" name="TextBox 10">
@@ -18267,6 +19569,7 @@
               </a:bodyPr>
               <a:lstStyle/>
               <a:p>
+                <a:pPr/>
                 <a14:m>
                   <m:oMathPara xmlns:m="http://schemas.openxmlformats.org/officeDocument/2006/math">
                     <m:oMathParaPr>
@@ -18325,7 +19628,7 @@
             </p:txBody>
           </p:sp>
         </mc:Choice>
-        <mc:Fallback>
+        <mc:Fallback xmlns="">
           <p:sp>
             <p:nvSpPr>
               <p:cNvPr id="11" name="TextBox 10">
@@ -18383,7 +19686,7 @@
 </p:sld>
 </file>
 
-<file path=ppt/slides/slide24.xml><?xml version="1.0" encoding="utf-8"?>
+<file path=ppt/slides/slide25.xml><?xml version="1.0" encoding="utf-8"?>
 <p:sld xmlns:a="http://schemas.openxmlformats.org/drawingml/2006/main" xmlns:r="http://schemas.openxmlformats.org/officeDocument/2006/relationships" xmlns:p="http://schemas.openxmlformats.org/presentationml/2006/main">
   <p:cSld>
     <p:spTree>
@@ -18436,8 +19739,8 @@
           </a:prstGeom>
         </p:spPr>
       </p:pic>
-      <mc:AlternateContent xmlns:mc="http://schemas.openxmlformats.org/markup-compatibility/2006">
-        <mc:Choice xmlns:a14="http://schemas.microsoft.com/office/drawing/2010/main" Requires="a14">
+      <mc:AlternateContent xmlns:mc="http://schemas.openxmlformats.org/markup-compatibility/2006" xmlns:a14="http://schemas.microsoft.com/office/drawing/2010/main">
+        <mc:Choice Requires="a14">
           <p:sp>
             <p:nvSpPr>
               <p:cNvPr id="6" name="TextBox 5">
@@ -18466,6 +19769,7 @@
               </a:bodyPr>
               <a:lstStyle/>
               <a:p>
+                <a:pPr/>
                 <a14:m>
                   <m:oMathPara xmlns:m="http://schemas.openxmlformats.org/officeDocument/2006/math">
                     <m:oMathParaPr>
@@ -18515,7 +19819,7 @@
             </p:txBody>
           </p:sp>
         </mc:Choice>
-        <mc:Fallback>
+        <mc:Fallback xmlns="">
           <p:sp>
             <p:nvSpPr>
               <p:cNvPr id="6" name="TextBox 5">
@@ -19097,8 +20401,8 @@
           </a:fontRef>
         </p:style>
       </p:cxnSp>
-      <mc:AlternateContent xmlns:mc="http://schemas.openxmlformats.org/markup-compatibility/2006">
-        <mc:Choice xmlns:a14="http://schemas.microsoft.com/office/drawing/2010/main" Requires="a14">
+      <mc:AlternateContent xmlns:mc="http://schemas.openxmlformats.org/markup-compatibility/2006" xmlns:a14="http://schemas.microsoft.com/office/drawing/2010/main">
+        <mc:Choice Requires="a14">
           <p:sp>
             <p:nvSpPr>
               <p:cNvPr id="13" name="TextBox 12">
@@ -19127,6 +20431,7 @@
               </a:bodyPr>
               <a:lstStyle/>
               <a:p>
+                <a:pPr/>
                 <a14:m>
                   <m:oMathPara xmlns:m="http://schemas.openxmlformats.org/officeDocument/2006/math">
                     <m:oMathParaPr>
@@ -19185,7 +20490,7 @@
             </p:txBody>
           </p:sp>
         </mc:Choice>
-        <mc:Fallback>
+        <mc:Fallback xmlns="">
           <p:sp>
             <p:nvSpPr>
               <p:cNvPr id="13" name="TextBox 12">
@@ -19230,8 +20535,8 @@
           </p:sp>
         </mc:Fallback>
       </mc:AlternateContent>
-      <mc:AlternateContent xmlns:mc="http://schemas.openxmlformats.org/markup-compatibility/2006">
-        <mc:Choice xmlns:a14="http://schemas.microsoft.com/office/drawing/2010/main" Requires="a14">
+      <mc:AlternateContent xmlns:mc="http://schemas.openxmlformats.org/markup-compatibility/2006" xmlns:a14="http://schemas.microsoft.com/office/drawing/2010/main">
+        <mc:Choice Requires="a14">
           <p:sp>
             <p:nvSpPr>
               <p:cNvPr id="14" name="TextBox 13">
@@ -19260,6 +20565,7 @@
               </a:bodyPr>
               <a:lstStyle/>
               <a:p>
+                <a:pPr/>
                 <a14:m>
                   <m:oMathPara xmlns:m="http://schemas.openxmlformats.org/officeDocument/2006/math">
                     <m:oMathParaPr>
@@ -19318,7 +20624,7 @@
             </p:txBody>
           </p:sp>
         </mc:Choice>
-        <mc:Fallback>
+        <mc:Fallback xmlns="">
           <p:sp>
             <p:nvSpPr>
               <p:cNvPr id="14" name="TextBox 13">
@@ -19376,7 +20682,7 @@
 </p:sld>
 </file>
 
-<file path=ppt/slides/slide25.xml><?xml version="1.0" encoding="utf-8"?>
+<file path=ppt/slides/slide26.xml><?xml version="1.0" encoding="utf-8"?>
 <p:sld xmlns:a="http://schemas.openxmlformats.org/drawingml/2006/main" xmlns:r="http://schemas.openxmlformats.org/officeDocument/2006/relationships" xmlns:p="http://schemas.openxmlformats.org/presentationml/2006/main">
   <p:cSld>
     <p:spTree>
@@ -19572,8 +20878,8 @@
           </a:p>
         </p:txBody>
       </p:sp>
-      <mc:AlternateContent xmlns:mc="http://schemas.openxmlformats.org/markup-compatibility/2006">
-        <mc:Choice xmlns:a14="http://schemas.microsoft.com/office/drawing/2010/main" Requires="a14">
+      <mc:AlternateContent xmlns:mc="http://schemas.openxmlformats.org/markup-compatibility/2006" xmlns:a14="http://schemas.microsoft.com/office/drawing/2010/main">
+        <mc:Choice Requires="a14">
           <p:sp>
             <p:nvSpPr>
               <p:cNvPr id="6" name="TextBox 5">
@@ -19602,6 +20908,7 @@
               </a:bodyPr>
               <a:lstStyle/>
               <a:p>
+                <a:pPr/>
                 <a14:m>
                   <m:oMathPara xmlns:m="http://schemas.openxmlformats.org/officeDocument/2006/math">
                     <m:oMathParaPr>
@@ -19630,7 +20937,7 @@
             </p:txBody>
           </p:sp>
         </mc:Choice>
-        <mc:Fallback>
+        <mc:Fallback xmlns="">
           <p:sp>
             <p:nvSpPr>
               <p:cNvPr id="6" name="TextBox 5">
@@ -19675,8 +20982,8 @@
           </p:sp>
         </mc:Fallback>
       </mc:AlternateContent>
-      <mc:AlternateContent xmlns:mc="http://schemas.openxmlformats.org/markup-compatibility/2006">
-        <mc:Choice xmlns:a14="http://schemas.microsoft.com/office/drawing/2010/main" Requires="a14">
+      <mc:AlternateContent xmlns:mc="http://schemas.openxmlformats.org/markup-compatibility/2006" xmlns:a14="http://schemas.microsoft.com/office/drawing/2010/main">
+        <mc:Choice Requires="a14">
           <p:sp>
             <p:nvSpPr>
               <p:cNvPr id="14" name="TextBox 13">
@@ -19705,6 +21012,7 @@
               </a:bodyPr>
               <a:lstStyle/>
               <a:p>
+                <a:pPr/>
                 <a14:m>
                   <m:oMathPara xmlns:m="http://schemas.openxmlformats.org/officeDocument/2006/math">
                     <m:oMathParaPr>
@@ -19744,7 +21052,7 @@
             </p:txBody>
           </p:sp>
         </mc:Choice>
-        <mc:Fallback>
+        <mc:Fallback xmlns="">
           <p:sp>
             <p:nvSpPr>
               <p:cNvPr id="14" name="TextBox 13">
@@ -19789,8 +21097,8 @@
           </p:sp>
         </mc:Fallback>
       </mc:AlternateContent>
-      <mc:AlternateContent xmlns:mc="http://schemas.openxmlformats.org/markup-compatibility/2006">
-        <mc:Choice xmlns:a14="http://schemas.microsoft.com/office/drawing/2010/main" Requires="a14">
+      <mc:AlternateContent xmlns:mc="http://schemas.openxmlformats.org/markup-compatibility/2006" xmlns:a14="http://schemas.microsoft.com/office/drawing/2010/main">
+        <mc:Choice Requires="a14">
           <p:sp>
             <p:nvSpPr>
               <p:cNvPr id="15" name="TextBox 14">
@@ -19819,6 +21127,7 @@
               </a:bodyPr>
               <a:lstStyle/>
               <a:p>
+                <a:pPr/>
                 <a14:m>
                   <m:oMathPara xmlns:m="http://schemas.openxmlformats.org/officeDocument/2006/math">
                     <m:oMathParaPr>
@@ -19858,7 +21167,7 @@
             </p:txBody>
           </p:sp>
         </mc:Choice>
-        <mc:Fallback>
+        <mc:Fallback xmlns="">
           <p:sp>
             <p:nvSpPr>
               <p:cNvPr id="15" name="TextBox 14">
@@ -19916,7 +21225,7 @@
 </p:sld>
 </file>
 
-<file path=ppt/slides/slide26.xml><?xml version="1.0" encoding="utf-8"?>
+<file path=ppt/slides/slide27.xml><?xml version="1.0" encoding="utf-8"?>
 <p:sld xmlns:a="http://schemas.openxmlformats.org/drawingml/2006/main" xmlns:r="http://schemas.openxmlformats.org/officeDocument/2006/relationships" xmlns:p="http://schemas.openxmlformats.org/presentationml/2006/main">
   <p:cSld>
     <p:spTree>
@@ -19999,7 +21308,7 @@
 </p:sld>
 </file>
 
-<file path=ppt/slides/slide27.xml><?xml version="1.0" encoding="utf-8"?>
+<file path=ppt/slides/slide28.xml><?xml version="1.0" encoding="utf-8"?>
 <p:sld xmlns:a="http://schemas.openxmlformats.org/drawingml/2006/main" xmlns:r="http://schemas.openxmlformats.org/officeDocument/2006/relationships" xmlns:p="http://schemas.openxmlformats.org/presentationml/2006/main">
   <p:cSld>
     <p:spTree>
@@ -20123,7 +21432,7 @@
 </p:sld>
 </file>
 
-<file path=ppt/slides/slide28.xml><?xml version="1.0" encoding="utf-8"?>
+<file path=ppt/slides/slide29.xml><?xml version="1.0" encoding="utf-8"?>
 <p:sld xmlns:a="http://schemas.openxmlformats.org/drawingml/2006/main" xmlns:r="http://schemas.openxmlformats.org/officeDocument/2006/relationships" xmlns:p="http://schemas.openxmlformats.org/presentationml/2006/main">
   <p:cSld>
     <p:spTree>
@@ -20741,7 +22050,355 @@
 </p:sld>
 </file>
 
-<file path=ppt/slides/slide29.xml><?xml version="1.0" encoding="utf-8"?>
+<file path=ppt/slides/slide3.xml><?xml version="1.0" encoding="utf-8"?>
+<p:sld xmlns:a="http://schemas.openxmlformats.org/drawingml/2006/main" xmlns:r="http://schemas.openxmlformats.org/officeDocument/2006/relationships" xmlns:p="http://schemas.openxmlformats.org/presentationml/2006/main">
+  <p:cSld>
+    <p:spTree>
+      <p:nvGrpSpPr>
+        <p:cNvPr id="1" name=""/>
+        <p:cNvGrpSpPr/>
+        <p:nvPr/>
+      </p:nvGrpSpPr>
+      <p:grpSpPr>
+        <a:xfrm>
+          <a:off x="0" y="0"/>
+          <a:ext cx="0" cy="0"/>
+          <a:chOff x="0" y="0"/>
+          <a:chExt cx="0" cy="0"/>
+        </a:xfrm>
+      </p:grpSpPr>
+      <p:sp>
+        <p:nvSpPr>
+          <p:cNvPr id="2" name="Title 1"/>
+          <p:cNvSpPr>
+            <a:spLocks noGrp="1"/>
+          </p:cNvSpPr>
+          <p:nvPr>
+            <p:ph type="title"/>
+          </p:nvPr>
+        </p:nvSpPr>
+        <p:spPr/>
+        <p:txBody>
+          <a:bodyPr/>
+          <a:lstStyle/>
+          <a:p>
+            <a:r>
+              <a:rPr lang="en-US" dirty="0"/>
+              <a:t>Question 123.10.2</a:t>
+            </a:r>
+          </a:p>
+        </p:txBody>
+      </p:sp>
+      <p:sp>
+        <p:nvSpPr>
+          <p:cNvPr id="3" name="Content Placeholder 2"/>
+          <p:cNvSpPr>
+            <a:spLocks noGrp="1"/>
+          </p:cNvSpPr>
+          <p:nvPr>
+            <p:ph idx="1"/>
+          </p:nvPr>
+        </p:nvSpPr>
+        <p:spPr>
+          <a:xfrm>
+            <a:off x="471714" y="1179285"/>
+            <a:ext cx="8229600" cy="4525963"/>
+          </a:xfrm>
+        </p:spPr>
+        <p:txBody>
+          <a:bodyPr>
+            <a:normAutofit fontScale="77500" lnSpcReduction="20000"/>
+          </a:bodyPr>
+          <a:lstStyle/>
+          <a:p>
+            <a:pPr>
+              <a:buNone/>
+            </a:pPr>
+            <a:r>
+              <a:rPr lang="en-US" dirty="0"/>
+              <a:t>Mechanical work is defined as …</a:t>
+            </a:r>
+            <a:endParaRPr lang="en-US" dirty="0">
+              <a:sym typeface="Symbol"/>
+            </a:endParaRPr>
+          </a:p>
+          <a:p>
+            <a:pPr>
+              <a:buNone/>
+            </a:pPr>
+            <a:endParaRPr lang="en-US" dirty="0">
+              <a:sym typeface="Symbol"/>
+            </a:endParaRPr>
+          </a:p>
+          <a:p>
+            <a:pPr marL="514350" indent="-514350">
+              <a:buFont typeface="+mj-lt"/>
+              <a:buAutoNum type="alphaLcParenR"/>
+            </a:pPr>
+            <a:r>
+              <a:rPr lang="en-US" dirty="0">
+                <a:sym typeface="Symbol"/>
+              </a:rPr>
+              <a:t> F/A</a:t>
+            </a:r>
+          </a:p>
+          <a:p>
+            <a:pPr marL="514350" indent="-514350">
+              <a:buFont typeface="+mj-lt"/>
+              <a:buAutoNum type="alphaLcParenR"/>
+            </a:pPr>
+            <a:endParaRPr lang="en-US" dirty="0">
+              <a:sym typeface="Symbol"/>
+            </a:endParaRPr>
+          </a:p>
+          <a:p>
+            <a:pPr marL="514350" indent="-514350">
+              <a:buFont typeface="+mj-lt"/>
+              <a:buAutoNum type="alphaLcParenR"/>
+            </a:pPr>
+            <a:r>
+              <a:rPr lang="en-US" dirty="0">
+                <a:sym typeface="Symbol"/>
+              </a:rPr>
+              <a:t> </a:t>
+            </a:r>
+          </a:p>
+          <a:p>
+            <a:pPr marL="514350" indent="-514350">
+              <a:buFont typeface="+mj-lt"/>
+              <a:buAutoNum type="alphaLcParenR"/>
+            </a:pPr>
+            <a:endParaRPr lang="en-US" dirty="0">
+              <a:sym typeface="Symbol"/>
+            </a:endParaRPr>
+          </a:p>
+          <a:p>
+            <a:pPr marL="514350" indent="-514350">
+              <a:buFont typeface="+mj-lt"/>
+              <a:buAutoNum type="alphaLcParenR"/>
+            </a:pPr>
+            <a:r>
+              <a:rPr lang="en-US" dirty="0">
+                <a:sym typeface="Symbol"/>
+              </a:rPr>
+              <a:t>  0.5mv</a:t>
+            </a:r>
+            <a:r>
+              <a:rPr lang="en-US" baseline="30000" dirty="0">
+                <a:sym typeface="Symbol"/>
+              </a:rPr>
+              <a:t>2</a:t>
+            </a:r>
+            <a:endParaRPr lang="en-US" dirty="0">
+              <a:sym typeface="Symbol"/>
+            </a:endParaRPr>
+          </a:p>
+          <a:p>
+            <a:pPr marL="514350" indent="-514350">
+              <a:buFont typeface="+mj-lt"/>
+              <a:buAutoNum type="alphaLcParenR"/>
+            </a:pPr>
+            <a:endParaRPr lang="en-US" dirty="0">
+              <a:sym typeface="Symbol"/>
+            </a:endParaRPr>
+          </a:p>
+          <a:p>
+            <a:pPr marL="514350" indent="-514350">
+              <a:buFont typeface="+mj-lt"/>
+              <a:buAutoNum type="alphaLcParenR"/>
+            </a:pPr>
+            <a:r>
+              <a:rPr lang="en-US" dirty="0">
+                <a:sym typeface="Symbol"/>
+              </a:rPr>
+              <a:t>  PH 123</a:t>
+            </a:r>
+          </a:p>
+          <a:p>
+            <a:pPr marL="514350" indent="-514350">
+              <a:buNone/>
+            </a:pPr>
+            <a:r>
+              <a:rPr lang="en-US" dirty="0">
+                <a:sym typeface="Symbol"/>
+              </a:rPr>
+              <a:t> </a:t>
+            </a:r>
+          </a:p>
+          <a:p>
+            <a:pPr marL="514350" indent="-514350">
+              <a:buNone/>
+            </a:pPr>
+            <a:r>
+              <a:rPr lang="en-US" dirty="0">
+                <a:sym typeface="Symbol"/>
+              </a:rPr>
+              <a:t> </a:t>
+            </a:r>
+          </a:p>
+          <a:p>
+            <a:pPr marL="514350" indent="-514350">
+              <a:buFont typeface="+mj-lt"/>
+              <a:buAutoNum type="alphaLcParenR"/>
+            </a:pPr>
+            <a:endParaRPr lang="en-US" dirty="0">
+              <a:sym typeface="Symbol"/>
+            </a:endParaRPr>
+          </a:p>
+          <a:p>
+            <a:pPr marL="514350" indent="-514350">
+              <a:buFont typeface="+mj-lt"/>
+              <a:buAutoNum type="alphaLcParenR"/>
+            </a:pPr>
+            <a:endParaRPr lang="en-US" baseline="30000" dirty="0"/>
+          </a:p>
+        </p:txBody>
+      </p:sp>
+      <p:sp>
+        <p:nvSpPr>
+          <p:cNvPr id="4" name="Slide Number Placeholder 3"/>
+          <p:cNvSpPr>
+            <a:spLocks noGrp="1"/>
+          </p:cNvSpPr>
+          <p:nvPr>
+            <p:ph type="sldNum" sz="quarter" idx="12"/>
+          </p:nvPr>
+        </p:nvSpPr>
+        <p:spPr/>
+        <p:txBody>
+          <a:bodyPr/>
+          <a:lstStyle/>
+          <a:p>
+            <a:pPr>
+              <a:defRPr/>
+            </a:pPr>
+            <a:fld id="{4E87D1FB-7ED3-4D53-B026-4508F19EE3B8}" type="slidenum">
+              <a:rPr lang="en-US" smtClean="0"/>
+              <a:pPr>
+                <a:defRPr/>
+              </a:pPr>
+              <a:t>3</a:t>
+            </a:fld>
+            <a:endParaRPr lang="en-US"/>
+          </a:p>
+        </p:txBody>
+      </p:sp>
+      <p:sp>
+        <p:nvSpPr>
+          <p:cNvPr id="292866" name="Rectangle 2"/>
+          <p:cNvSpPr>
+            <a:spLocks noChangeArrowheads="1"/>
+          </p:cNvSpPr>
+          <p:nvPr/>
+        </p:nvSpPr>
+        <p:spPr bwMode="auto">
+          <a:xfrm>
+            <a:off x="0" y="0"/>
+            <a:ext cx="9144000" cy="0"/>
+          </a:xfrm>
+          <a:prstGeom prst="rect">
+            <a:avLst/>
+          </a:prstGeom>
+          <a:noFill/>
+          <a:ln w="9525">
+            <a:noFill/>
+            <a:miter lim="800000"/>
+            <a:headEnd/>
+            <a:tailEnd/>
+          </a:ln>
+          <a:effectLst/>
+        </p:spPr>
+        <p:txBody>
+          <a:bodyPr vert="horz" wrap="none" lIns="91440" tIns="45720" rIns="91440" bIns="45720" numCol="1" anchor="ctr" anchorCtr="0" compatLnSpc="1">
+            <a:prstTxWarp prst="textNoShape">
+              <a:avLst/>
+            </a:prstTxWarp>
+            <a:spAutoFit/>
+          </a:bodyPr>
+          <a:lstStyle/>
+          <a:p>
+            <a:endParaRPr lang="en-US"/>
+          </a:p>
+        </p:txBody>
+      </p:sp>
+      <p:graphicFrame>
+        <p:nvGraphicFramePr>
+          <p:cNvPr id="292865" name="Object 1"/>
+          <p:cNvGraphicFramePr>
+            <a:graphicFrameLocks noChangeAspect="1"/>
+          </p:cNvGraphicFramePr>
+          <p:nvPr/>
+        </p:nvGraphicFramePr>
+        <p:xfrm>
+          <a:off x="1076325" y="2538413"/>
+          <a:ext cx="1870075" cy="723900"/>
+        </p:xfrm>
+        <a:graphic>
+          <a:graphicData uri="http://schemas.openxmlformats.org/presentationml/2006/ole">
+            <mc:AlternateContent xmlns:mc="http://schemas.openxmlformats.org/markup-compatibility/2006">
+              <mc:Choice xmlns:v="urn:schemas-microsoft-com:vml" Requires="v">
+                <p:oleObj name="Equation" r:id="rId2" imgW="914400" imgH="355320" progId="Equation.3">
+                  <p:embed/>
+                </p:oleObj>
+              </mc:Choice>
+              <mc:Fallback>
+                <p:oleObj name="Equation" r:id="rId2" imgW="914400" imgH="355320" progId="Equation.3">
+                  <p:embed/>
+                  <p:pic>
+                    <p:nvPicPr>
+                      <p:cNvPr id="292865" name="Object 1"/>
+                      <p:cNvPicPr>
+                        <a:picLocks noChangeAspect="1" noChangeArrowheads="1"/>
+                      </p:cNvPicPr>
+                      <p:nvPr/>
+                    </p:nvPicPr>
+                    <p:blipFill>
+                      <a:blip r:embed="rId3"/>
+                      <a:srcRect/>
+                      <a:stretch>
+                        <a:fillRect/>
+                      </a:stretch>
+                    </p:blipFill>
+                    <p:spPr bwMode="auto">
+                      <a:xfrm>
+                        <a:off x="1076325" y="2538413"/>
+                        <a:ext cx="1870075" cy="723900"/>
+                      </a:xfrm>
+                      <a:prstGeom prst="rect">
+                        <a:avLst/>
+                      </a:prstGeom>
+                      <a:noFill/>
+                      <a:extLst>
+                        <a:ext uri="{909E8E84-426E-40DD-AFC4-6F175D3DCCD1}">
+                          <a14:hiddenFill xmlns:a14="http://schemas.microsoft.com/office/drawing/2010/main">
+                            <a:solidFill>
+                              <a:srgbClr val="FFFFFF"/>
+                            </a:solidFill>
+                          </a14:hiddenFill>
+                        </a:ext>
+                      </a:extLst>
+                    </p:spPr>
+                  </p:pic>
+                </p:oleObj>
+              </mc:Fallback>
+            </mc:AlternateContent>
+          </a:graphicData>
+        </a:graphic>
+      </p:graphicFrame>
+    </p:spTree>
+    <p:extLst>
+      <p:ext uri="{BB962C8B-B14F-4D97-AF65-F5344CB8AC3E}">
+        <p14:creationId xmlns:p14="http://schemas.microsoft.com/office/powerpoint/2010/main" val="3821452460"/>
+      </p:ext>
+    </p:extLst>
+  </p:cSld>
+  <p:clrMapOvr>
+    <a:masterClrMapping/>
+  </p:clrMapOvr>
+</p:sld>
+</file>
+
+<file path=ppt/slides/slide30.xml><?xml version="1.0" encoding="utf-8"?>
 <p:sld xmlns:a="http://schemas.openxmlformats.org/drawingml/2006/main" xmlns:r="http://schemas.openxmlformats.org/officeDocument/2006/relationships" xmlns:p="http://schemas.openxmlformats.org/presentationml/2006/main">
   <p:cSld>
     <p:spTree>
@@ -21097,355 +22754,7 @@
 </p:sld>
 </file>
 
-<file path=ppt/slides/slide3.xml><?xml version="1.0" encoding="utf-8"?>
-<p:sld xmlns:a="http://schemas.openxmlformats.org/drawingml/2006/main" xmlns:r="http://schemas.openxmlformats.org/officeDocument/2006/relationships" xmlns:p="http://schemas.openxmlformats.org/presentationml/2006/main">
-  <p:cSld>
-    <p:spTree>
-      <p:nvGrpSpPr>
-        <p:cNvPr id="1" name=""/>
-        <p:cNvGrpSpPr/>
-        <p:nvPr/>
-      </p:nvGrpSpPr>
-      <p:grpSpPr>
-        <a:xfrm>
-          <a:off x="0" y="0"/>
-          <a:ext cx="0" cy="0"/>
-          <a:chOff x="0" y="0"/>
-          <a:chExt cx="0" cy="0"/>
-        </a:xfrm>
-      </p:grpSpPr>
-      <p:sp>
-        <p:nvSpPr>
-          <p:cNvPr id="2" name="Title 1"/>
-          <p:cNvSpPr>
-            <a:spLocks noGrp="1"/>
-          </p:cNvSpPr>
-          <p:nvPr>
-            <p:ph type="title"/>
-          </p:nvPr>
-        </p:nvSpPr>
-        <p:spPr/>
-        <p:txBody>
-          <a:bodyPr/>
-          <a:lstStyle/>
-          <a:p>
-            <a:r>
-              <a:rPr lang="en-US" dirty="0"/>
-              <a:t>Question 123.10.2</a:t>
-            </a:r>
-          </a:p>
-        </p:txBody>
-      </p:sp>
-      <p:sp>
-        <p:nvSpPr>
-          <p:cNvPr id="3" name="Content Placeholder 2"/>
-          <p:cNvSpPr>
-            <a:spLocks noGrp="1"/>
-          </p:cNvSpPr>
-          <p:nvPr>
-            <p:ph idx="1"/>
-          </p:nvPr>
-        </p:nvSpPr>
-        <p:spPr>
-          <a:xfrm>
-            <a:off x="471714" y="1179285"/>
-            <a:ext cx="8229600" cy="4525963"/>
-          </a:xfrm>
-        </p:spPr>
-        <p:txBody>
-          <a:bodyPr>
-            <a:normAutofit fontScale="77500" lnSpcReduction="20000"/>
-          </a:bodyPr>
-          <a:lstStyle/>
-          <a:p>
-            <a:pPr>
-              <a:buNone/>
-            </a:pPr>
-            <a:r>
-              <a:rPr lang="en-US" dirty="0"/>
-              <a:t>Mechanical work is defined as …</a:t>
-            </a:r>
-            <a:endParaRPr lang="en-US" dirty="0">
-              <a:sym typeface="Symbol"/>
-            </a:endParaRPr>
-          </a:p>
-          <a:p>
-            <a:pPr>
-              <a:buNone/>
-            </a:pPr>
-            <a:endParaRPr lang="en-US" dirty="0">
-              <a:sym typeface="Symbol"/>
-            </a:endParaRPr>
-          </a:p>
-          <a:p>
-            <a:pPr marL="514350" indent="-514350">
-              <a:buFont typeface="+mj-lt"/>
-              <a:buAutoNum type="alphaLcParenR"/>
-            </a:pPr>
-            <a:r>
-              <a:rPr lang="en-US" dirty="0">
-                <a:sym typeface="Symbol"/>
-              </a:rPr>
-              <a:t> F/A</a:t>
-            </a:r>
-          </a:p>
-          <a:p>
-            <a:pPr marL="514350" indent="-514350">
-              <a:buFont typeface="+mj-lt"/>
-              <a:buAutoNum type="alphaLcParenR"/>
-            </a:pPr>
-            <a:endParaRPr lang="en-US" dirty="0">
-              <a:sym typeface="Symbol"/>
-            </a:endParaRPr>
-          </a:p>
-          <a:p>
-            <a:pPr marL="514350" indent="-514350">
-              <a:buFont typeface="+mj-lt"/>
-              <a:buAutoNum type="alphaLcParenR"/>
-            </a:pPr>
-            <a:r>
-              <a:rPr lang="en-US" dirty="0">
-                <a:sym typeface="Symbol"/>
-              </a:rPr>
-              <a:t> </a:t>
-            </a:r>
-          </a:p>
-          <a:p>
-            <a:pPr marL="514350" indent="-514350">
-              <a:buFont typeface="+mj-lt"/>
-              <a:buAutoNum type="alphaLcParenR"/>
-            </a:pPr>
-            <a:endParaRPr lang="en-US" dirty="0">
-              <a:sym typeface="Symbol"/>
-            </a:endParaRPr>
-          </a:p>
-          <a:p>
-            <a:pPr marL="514350" indent="-514350">
-              <a:buFont typeface="+mj-lt"/>
-              <a:buAutoNum type="alphaLcParenR"/>
-            </a:pPr>
-            <a:r>
-              <a:rPr lang="en-US" dirty="0">
-                <a:sym typeface="Symbol"/>
-              </a:rPr>
-              <a:t>  0.5mv</a:t>
-            </a:r>
-            <a:r>
-              <a:rPr lang="en-US" baseline="30000" dirty="0">
-                <a:sym typeface="Symbol"/>
-              </a:rPr>
-              <a:t>2</a:t>
-            </a:r>
-            <a:endParaRPr lang="en-US" dirty="0">
-              <a:sym typeface="Symbol"/>
-            </a:endParaRPr>
-          </a:p>
-          <a:p>
-            <a:pPr marL="514350" indent="-514350">
-              <a:buFont typeface="+mj-lt"/>
-              <a:buAutoNum type="alphaLcParenR"/>
-            </a:pPr>
-            <a:endParaRPr lang="en-US" dirty="0">
-              <a:sym typeface="Symbol"/>
-            </a:endParaRPr>
-          </a:p>
-          <a:p>
-            <a:pPr marL="514350" indent="-514350">
-              <a:buFont typeface="+mj-lt"/>
-              <a:buAutoNum type="alphaLcParenR"/>
-            </a:pPr>
-            <a:r>
-              <a:rPr lang="en-US" dirty="0">
-                <a:sym typeface="Symbol"/>
-              </a:rPr>
-              <a:t>  PH 123</a:t>
-            </a:r>
-          </a:p>
-          <a:p>
-            <a:pPr marL="514350" indent="-514350">
-              <a:buNone/>
-            </a:pPr>
-            <a:r>
-              <a:rPr lang="en-US" dirty="0">
-                <a:sym typeface="Symbol"/>
-              </a:rPr>
-              <a:t> </a:t>
-            </a:r>
-          </a:p>
-          <a:p>
-            <a:pPr marL="514350" indent="-514350">
-              <a:buNone/>
-            </a:pPr>
-            <a:r>
-              <a:rPr lang="en-US" dirty="0">
-                <a:sym typeface="Symbol"/>
-              </a:rPr>
-              <a:t> </a:t>
-            </a:r>
-          </a:p>
-          <a:p>
-            <a:pPr marL="514350" indent="-514350">
-              <a:buFont typeface="+mj-lt"/>
-              <a:buAutoNum type="alphaLcParenR"/>
-            </a:pPr>
-            <a:endParaRPr lang="en-US" dirty="0">
-              <a:sym typeface="Symbol"/>
-            </a:endParaRPr>
-          </a:p>
-          <a:p>
-            <a:pPr marL="514350" indent="-514350">
-              <a:buFont typeface="+mj-lt"/>
-              <a:buAutoNum type="alphaLcParenR"/>
-            </a:pPr>
-            <a:endParaRPr lang="en-US" baseline="30000" dirty="0"/>
-          </a:p>
-        </p:txBody>
-      </p:sp>
-      <p:sp>
-        <p:nvSpPr>
-          <p:cNvPr id="4" name="Slide Number Placeholder 3"/>
-          <p:cNvSpPr>
-            <a:spLocks noGrp="1"/>
-          </p:cNvSpPr>
-          <p:nvPr>
-            <p:ph type="sldNum" sz="quarter" idx="12"/>
-          </p:nvPr>
-        </p:nvSpPr>
-        <p:spPr/>
-        <p:txBody>
-          <a:bodyPr/>
-          <a:lstStyle/>
-          <a:p>
-            <a:pPr>
-              <a:defRPr/>
-            </a:pPr>
-            <a:fld id="{4E87D1FB-7ED3-4D53-B026-4508F19EE3B8}" type="slidenum">
-              <a:rPr lang="en-US" smtClean="0"/>
-              <a:pPr>
-                <a:defRPr/>
-              </a:pPr>
-              <a:t>3</a:t>
-            </a:fld>
-            <a:endParaRPr lang="en-US"/>
-          </a:p>
-        </p:txBody>
-      </p:sp>
-      <p:sp>
-        <p:nvSpPr>
-          <p:cNvPr id="292866" name="Rectangle 2"/>
-          <p:cNvSpPr>
-            <a:spLocks noChangeArrowheads="1"/>
-          </p:cNvSpPr>
-          <p:nvPr/>
-        </p:nvSpPr>
-        <p:spPr bwMode="auto">
-          <a:xfrm>
-            <a:off x="0" y="0"/>
-            <a:ext cx="9144000" cy="0"/>
-          </a:xfrm>
-          <a:prstGeom prst="rect">
-            <a:avLst/>
-          </a:prstGeom>
-          <a:noFill/>
-          <a:ln w="9525">
-            <a:noFill/>
-            <a:miter lim="800000"/>
-            <a:headEnd/>
-            <a:tailEnd/>
-          </a:ln>
-          <a:effectLst/>
-        </p:spPr>
-        <p:txBody>
-          <a:bodyPr vert="horz" wrap="none" lIns="91440" tIns="45720" rIns="91440" bIns="45720" numCol="1" anchor="ctr" anchorCtr="0" compatLnSpc="1">
-            <a:prstTxWarp prst="textNoShape">
-              <a:avLst/>
-            </a:prstTxWarp>
-            <a:spAutoFit/>
-          </a:bodyPr>
-          <a:lstStyle/>
-          <a:p>
-            <a:endParaRPr lang="en-US"/>
-          </a:p>
-        </p:txBody>
-      </p:sp>
-      <p:graphicFrame>
-        <p:nvGraphicFramePr>
-          <p:cNvPr id="292865" name="Object 1"/>
-          <p:cNvGraphicFramePr>
-            <a:graphicFrameLocks noChangeAspect="1"/>
-          </p:cNvGraphicFramePr>
-          <p:nvPr/>
-        </p:nvGraphicFramePr>
-        <p:xfrm>
-          <a:off x="1076325" y="2538413"/>
-          <a:ext cx="1870075" cy="723900"/>
-        </p:xfrm>
-        <a:graphic>
-          <a:graphicData uri="http://schemas.openxmlformats.org/presentationml/2006/ole">
-            <mc:AlternateContent xmlns:mc="http://schemas.openxmlformats.org/markup-compatibility/2006">
-              <mc:Choice xmlns:v="urn:schemas-microsoft-com:vml" Requires="v">
-                <p:oleObj name="Equation" r:id="rId2" imgW="914400" imgH="355320" progId="Equation.3">
-                  <p:embed/>
-                </p:oleObj>
-              </mc:Choice>
-              <mc:Fallback>
-                <p:oleObj name="Equation" r:id="rId2" imgW="914400" imgH="355320" progId="Equation.3">
-                  <p:embed/>
-                  <p:pic>
-                    <p:nvPicPr>
-                      <p:cNvPr id="292865" name="Object 1"/>
-                      <p:cNvPicPr>
-                        <a:picLocks noChangeAspect="1" noChangeArrowheads="1"/>
-                      </p:cNvPicPr>
-                      <p:nvPr/>
-                    </p:nvPicPr>
-                    <p:blipFill>
-                      <a:blip r:embed="rId3"/>
-                      <a:srcRect/>
-                      <a:stretch>
-                        <a:fillRect/>
-                      </a:stretch>
-                    </p:blipFill>
-                    <p:spPr bwMode="auto">
-                      <a:xfrm>
-                        <a:off x="1076325" y="2538413"/>
-                        <a:ext cx="1870075" cy="723900"/>
-                      </a:xfrm>
-                      <a:prstGeom prst="rect">
-                        <a:avLst/>
-                      </a:prstGeom>
-                      <a:noFill/>
-                      <a:extLst>
-                        <a:ext uri="{909E8E84-426E-40DD-AFC4-6F175D3DCCD1}">
-                          <a14:hiddenFill xmlns:a14="http://schemas.microsoft.com/office/drawing/2010/main">
-                            <a:solidFill>
-                              <a:srgbClr val="FFFFFF"/>
-                            </a:solidFill>
-                          </a14:hiddenFill>
-                        </a:ext>
-                      </a:extLst>
-                    </p:spPr>
-                  </p:pic>
-                </p:oleObj>
-              </mc:Fallback>
-            </mc:AlternateContent>
-          </a:graphicData>
-        </a:graphic>
-      </p:graphicFrame>
-    </p:spTree>
-    <p:extLst>
-      <p:ext uri="{BB962C8B-B14F-4D97-AF65-F5344CB8AC3E}">
-        <p14:creationId xmlns:p14="http://schemas.microsoft.com/office/powerpoint/2010/main" val="3821452460"/>
-      </p:ext>
-    </p:extLst>
-  </p:cSld>
-  <p:clrMapOvr>
-    <a:masterClrMapping/>
-  </p:clrMapOvr>
-</p:sld>
-</file>
-
-<file path=ppt/slides/slide30.xml><?xml version="1.0" encoding="utf-8"?>
+<file path=ppt/slides/slide31.xml><?xml version="1.0" encoding="utf-8"?>
 <p:sld xmlns:a="http://schemas.openxmlformats.org/drawingml/2006/main" xmlns:r="http://schemas.openxmlformats.org/officeDocument/2006/relationships" xmlns:p="http://schemas.openxmlformats.org/presentationml/2006/main">
   <p:cSld>
     <p:spTree>
@@ -21763,7 +23072,7 @@
 </p:sld>
 </file>
 
-<file path=ppt/slides/slide31.xml><?xml version="1.0" encoding="utf-8"?>
+<file path=ppt/slides/slide32.xml><?xml version="1.0" encoding="utf-8"?>
 <p:sld xmlns:a="http://schemas.openxmlformats.org/drawingml/2006/main" xmlns:r="http://schemas.openxmlformats.org/officeDocument/2006/relationships" xmlns:p="http://schemas.openxmlformats.org/presentationml/2006/main">
   <p:cSld>
     <p:spTree>
@@ -22117,7 +23426,7 @@
 </p:sld>
 </file>
 
-<file path=ppt/slides/slide32.xml><?xml version="1.0" encoding="utf-8"?>
+<file path=ppt/slides/slide33.xml><?xml version="1.0" encoding="utf-8"?>
 <p:sld xmlns:a="http://schemas.openxmlformats.org/drawingml/2006/main" xmlns:r="http://schemas.openxmlformats.org/officeDocument/2006/relationships" xmlns:p="http://schemas.openxmlformats.org/presentationml/2006/main">
   <p:cSld>
     <p:spTree>
@@ -22501,7 +23810,7 @@
 </p:sld>
 </file>
 
-<file path=ppt/slides/slide33.xml><?xml version="1.0" encoding="utf-8"?>
+<file path=ppt/slides/slide34.xml><?xml version="1.0" encoding="utf-8"?>
 <p:sld xmlns:a="http://schemas.openxmlformats.org/drawingml/2006/main" xmlns:r="http://schemas.openxmlformats.org/officeDocument/2006/relationships" xmlns:p="http://schemas.openxmlformats.org/presentationml/2006/main">
   <p:cSld>
     <p:spTree>
@@ -22915,7 +24224,7 @@
 </p:sld>
 </file>
 
-<file path=ppt/slides/slide34.xml><?xml version="1.0" encoding="utf-8"?>
+<file path=ppt/slides/slide35.xml><?xml version="1.0" encoding="utf-8"?>
 <p:sld xmlns:a="http://schemas.openxmlformats.org/drawingml/2006/main" xmlns:r="http://schemas.openxmlformats.org/officeDocument/2006/relationships" xmlns:p="http://schemas.openxmlformats.org/presentationml/2006/main">
   <p:cSld>
     <p:spTree>
@@ -23393,7 +24702,7 @@
 </p:sld>
 </file>
 
-<file path=ppt/slides/slide35.xml><?xml version="1.0" encoding="utf-8"?>
+<file path=ppt/slides/slide36.xml><?xml version="1.0" encoding="utf-8"?>
 <p:sld xmlns:a="http://schemas.openxmlformats.org/drawingml/2006/main" xmlns:r="http://schemas.openxmlformats.org/officeDocument/2006/relationships" xmlns:p="http://schemas.openxmlformats.org/presentationml/2006/main">
   <p:cSld>
     <p:spTree>
@@ -24479,7 +25788,7 @@
 </p:sld>
 </file>
 
-<file path=ppt/slides/slide36.xml><?xml version="1.0" encoding="utf-8"?>
+<file path=ppt/slides/slide37.xml><?xml version="1.0" encoding="utf-8"?>
 <p:sld xmlns:a="http://schemas.openxmlformats.org/drawingml/2006/main" xmlns:r="http://schemas.openxmlformats.org/officeDocument/2006/relationships" xmlns:p="http://schemas.openxmlformats.org/presentationml/2006/main">
   <p:cSld>
     <p:spTree>
@@ -24845,7 +26154,7 @@
 </p:sld>
 </file>
 
-<file path=ppt/slides/slide37.xml><?xml version="1.0" encoding="utf-8"?>
+<file path=ppt/slides/slide38.xml><?xml version="1.0" encoding="utf-8"?>
 <p:sld xmlns:a="http://schemas.openxmlformats.org/drawingml/2006/main" xmlns:r="http://schemas.openxmlformats.org/officeDocument/2006/relationships" xmlns:p="http://schemas.openxmlformats.org/presentationml/2006/main">
   <p:cSld>
     <p:spTree>
@@ -25196,7 +26505,7 @@
 </p:sld>
 </file>
 
-<file path=ppt/slides/slide38.xml><?xml version="1.0" encoding="utf-8"?>
+<file path=ppt/slides/slide39.xml><?xml version="1.0" encoding="utf-8"?>
 <p:sld xmlns:a="http://schemas.openxmlformats.org/drawingml/2006/main" xmlns:r="http://schemas.openxmlformats.org/officeDocument/2006/relationships" xmlns:p="http://schemas.openxmlformats.org/presentationml/2006/main">
   <p:cSld>
     <p:spTree>
@@ -25634,7 +26943,7 @@
               <a:rPr lang="en-US" dirty="0">
                 <a:sym typeface="Symbol"/>
               </a:rPr>
-              <a:t>-W</a:t>
+              <a:t>-w</a:t>
             </a:r>
           </a:p>
           <a:p>

</xml_diff>

<commit_message>
end of semester update Spring 2026
</commit_message>
<xml_diff>
--- a/Lecture_Slides/PH 123 Lecture 34.pptx
+++ b/Lecture_Slides/PH 123 Lecture 34.pptx
@@ -167,160 +167,43 @@
 </p:presentation>
 </file>
 
-<file path=ppt/revisionInfo.xml><?xml version="1.0" encoding="utf-8"?>
-<p1510:revInfo xmlns:a="http://schemas.openxmlformats.org/drawingml/2006/main" xmlns:r="http://schemas.openxmlformats.org/officeDocument/2006/relationships" xmlns:p1510="http://schemas.microsoft.com/office/powerpoint/2015/10/main">
-  <p1510:revLst>
-    <p1510:client id="{6B8C0E98-5862-4A50-AFB8-D3185DEA5BD2}" v="1" dt="2026-03-26T16:52:37.484"/>
-  </p1510:revLst>
-</p1510:revInfo>
-</file>
-
 <file path=ppt/changesInfos/changesInfo1.xml><?xml version="1.0" encoding="utf-8"?>
 <pc:chgInfo xmlns:a="http://schemas.openxmlformats.org/drawingml/2006/main" xmlns:r="http://schemas.openxmlformats.org/officeDocument/2006/relationships" xmlns:ac="http://schemas.microsoft.com/office/drawing/2013/main/command" xmlns:pc="http://schemas.microsoft.com/office/powerpoint/2013/main/command">
   <pc:docChgLst>
     <pc:chgData name="Lines, Todd" userId="afaf7c3a-e8aa-4568-882a-02ad8f9e19b0" providerId="ADAL" clId="{5FF5AC1B-ABA9-43D7-A1E3-2D92732CD6E2}"/>
     <pc:docChg chg="custSel addSld modSld sldOrd">
-      <pc:chgData name="Lines, Todd" userId="afaf7c3a-e8aa-4568-882a-02ad8f9e19b0" providerId="ADAL" clId="{5FF5AC1B-ABA9-43D7-A1E3-2D92732CD6E2}" dt="2026-03-30T16:49:19.057" v="21" actId="20577"/>
+      <pc:chgData name="Lines, Todd" userId="afaf7c3a-e8aa-4568-882a-02ad8f9e19b0" providerId="ADAL" clId="{5FF5AC1B-ABA9-43D7-A1E3-2D92732CD6E2}" dt="2026-07-06T17:34:18.327" v="32" actId="21"/>
       <pc:docMkLst>
         <pc:docMk/>
       </pc:docMkLst>
-      <pc:sldChg chg="modSp mod ord">
-        <pc:chgData name="Lines, Todd" userId="afaf7c3a-e8aa-4568-882a-02ad8f9e19b0" providerId="ADAL" clId="{5FF5AC1B-ABA9-43D7-A1E3-2D92732CD6E2}" dt="2026-03-30T16:49:19.057" v="21" actId="20577"/>
+      <pc:sldChg chg="addSp delSp modSp mod">
+        <pc:chgData name="Lines, Todd" userId="afaf7c3a-e8aa-4568-882a-02ad8f9e19b0" providerId="ADAL" clId="{5FF5AC1B-ABA9-43D7-A1E3-2D92732CD6E2}" dt="2026-07-06T17:34:18.327" v="32" actId="21"/>
         <pc:sldMkLst>
           <pc:docMk/>
-          <pc:sldMk cId="1876980714" sldId="268"/>
+          <pc:sldMk cId="4146382728" sldId="295"/>
         </pc:sldMkLst>
         <pc:spChg chg="mod">
-          <ac:chgData name="Lines, Todd" userId="afaf7c3a-e8aa-4568-882a-02ad8f9e19b0" providerId="ADAL" clId="{5FF5AC1B-ABA9-43D7-A1E3-2D92732CD6E2}" dt="2026-03-30T16:49:15.257" v="19" actId="20577"/>
+          <ac:chgData name="Lines, Todd" userId="afaf7c3a-e8aa-4568-882a-02ad8f9e19b0" providerId="ADAL" clId="{5FF5AC1B-ABA9-43D7-A1E3-2D92732CD6E2}" dt="2026-07-06T17:34:03.404" v="29" actId="20577"/>
           <ac:spMkLst>
             <pc:docMk/>
-            <pc:sldMk cId="1876980714" sldId="268"/>
-            <ac:spMk id="21" creationId="{00000000-0000-0000-0000-000000000000}"/>
+            <pc:sldMk cId="4146382728" sldId="295"/>
+            <ac:spMk id="28" creationId="{AC98FFE5-4161-9776-2984-D5FFEDCC11B1}"/>
           </ac:spMkLst>
         </pc:spChg>
         <pc:spChg chg="mod">
-          <ac:chgData name="Lines, Todd" userId="afaf7c3a-e8aa-4568-882a-02ad8f9e19b0" providerId="ADAL" clId="{5FF5AC1B-ABA9-43D7-A1E3-2D92732CD6E2}" dt="2026-03-30T16:49:19.057" v="21" actId="20577"/>
+          <ac:chgData name="Lines, Todd" userId="afaf7c3a-e8aa-4568-882a-02ad8f9e19b0" providerId="ADAL" clId="{5FF5AC1B-ABA9-43D7-A1E3-2D92732CD6E2}" dt="2026-07-06T17:33:56.975" v="25" actId="20577"/>
           <ac:spMkLst>
             <pc:docMk/>
-            <pc:sldMk cId="1876980714" sldId="268"/>
-            <ac:spMk id="22" creationId="{00000000-0000-0000-0000-000000000000}"/>
+            <pc:sldMk cId="4146382728" sldId="295"/>
+            <ac:spMk id="29" creationId="{CFD7752F-5AD7-EDCD-307F-AEFEAEE7A794}"/>
           </ac:spMkLst>
         </pc:spChg>
-      </pc:sldChg>
-      <pc:sldChg chg="addSp delSp modSp new mod">
-        <pc:chgData name="Lines, Todd" userId="afaf7c3a-e8aa-4568-882a-02ad8f9e19b0" providerId="ADAL" clId="{5FF5AC1B-ABA9-43D7-A1E3-2D92732CD6E2}" dt="2026-03-26T16:52:48.172" v="5" actId="1076"/>
-        <pc:sldMkLst>
-          <pc:docMk/>
-          <pc:sldMk cId="3438312871" sldId="296"/>
-        </pc:sldMkLst>
-        <pc:spChg chg="add mod">
-          <ac:chgData name="Lines, Todd" userId="afaf7c3a-e8aa-4568-882a-02ad8f9e19b0" providerId="ADAL" clId="{5FF5AC1B-ABA9-43D7-A1E3-2D92732CD6E2}" dt="2026-03-26T16:52:48.172" v="5" actId="1076"/>
-          <ac:spMkLst>
-            <pc:docMk/>
-            <pc:sldMk cId="3438312871" sldId="296"/>
-            <ac:spMk id="6" creationId="{5D750AFF-282F-856C-EF2B-9F0A68F42D5F}"/>
-          </ac:spMkLst>
-        </pc:spChg>
-        <pc:spChg chg="add mod">
-          <ac:chgData name="Lines, Todd" userId="afaf7c3a-e8aa-4568-882a-02ad8f9e19b0" providerId="ADAL" clId="{5FF5AC1B-ABA9-43D7-A1E3-2D92732CD6E2}" dt="2026-03-26T16:52:48.172" v="5" actId="1076"/>
-          <ac:spMkLst>
-            <pc:docMk/>
-            <pc:sldMk cId="3438312871" sldId="296"/>
-            <ac:spMk id="7" creationId="{170D7E5A-71C2-8DAE-9C61-2C47F1430FFC}"/>
-          </ac:spMkLst>
-        </pc:spChg>
-        <pc:spChg chg="add mod">
-          <ac:chgData name="Lines, Todd" userId="afaf7c3a-e8aa-4568-882a-02ad8f9e19b0" providerId="ADAL" clId="{5FF5AC1B-ABA9-43D7-A1E3-2D92732CD6E2}" dt="2026-03-26T16:52:48.172" v="5" actId="1076"/>
-          <ac:spMkLst>
-            <pc:docMk/>
-            <pc:sldMk cId="3438312871" sldId="296"/>
-            <ac:spMk id="8" creationId="{3CEDCA72-E717-2F4E-E7F7-B88B886F3FB9}"/>
-          </ac:spMkLst>
-        </pc:spChg>
-        <pc:spChg chg="add mod">
-          <ac:chgData name="Lines, Todd" userId="afaf7c3a-e8aa-4568-882a-02ad8f9e19b0" providerId="ADAL" clId="{5FF5AC1B-ABA9-43D7-A1E3-2D92732CD6E2}" dt="2026-03-26T16:52:48.172" v="5" actId="1076"/>
-          <ac:spMkLst>
-            <pc:docMk/>
-            <pc:sldMk cId="3438312871" sldId="296"/>
-            <ac:spMk id="9" creationId="{D21E0977-2F7F-99F0-2437-5CF278580594}"/>
-          </ac:spMkLst>
-        </pc:spChg>
-        <pc:spChg chg="add mod">
-          <ac:chgData name="Lines, Todd" userId="afaf7c3a-e8aa-4568-882a-02ad8f9e19b0" providerId="ADAL" clId="{5FF5AC1B-ABA9-43D7-A1E3-2D92732CD6E2}" dt="2026-03-26T16:52:48.172" v="5" actId="1076"/>
-          <ac:spMkLst>
-            <pc:docMk/>
-            <pc:sldMk cId="3438312871" sldId="296"/>
-            <ac:spMk id="10" creationId="{DE91A885-E709-0F7C-D0F6-44C6F8038306}"/>
-          </ac:spMkLst>
-        </pc:spChg>
-        <pc:spChg chg="add mod">
-          <ac:chgData name="Lines, Todd" userId="afaf7c3a-e8aa-4568-882a-02ad8f9e19b0" providerId="ADAL" clId="{5FF5AC1B-ABA9-43D7-A1E3-2D92732CD6E2}" dt="2026-03-26T16:52:48.172" v="5" actId="1076"/>
-          <ac:spMkLst>
-            <pc:docMk/>
-            <pc:sldMk cId="3438312871" sldId="296"/>
-            <ac:spMk id="11" creationId="{921E28DE-0FBC-3ACC-B597-126D613EB4E8}"/>
-          </ac:spMkLst>
-        </pc:spChg>
-        <pc:spChg chg="add mod">
-          <ac:chgData name="Lines, Todd" userId="afaf7c3a-e8aa-4568-882a-02ad8f9e19b0" providerId="ADAL" clId="{5FF5AC1B-ABA9-43D7-A1E3-2D92732CD6E2}" dt="2026-03-26T16:52:48.172" v="5" actId="1076"/>
-          <ac:spMkLst>
-            <pc:docMk/>
-            <pc:sldMk cId="3438312871" sldId="296"/>
-            <ac:spMk id="12" creationId="{FBE76A14-D75F-EEFF-3BBF-B68EF43F5675}"/>
-          </ac:spMkLst>
-        </pc:spChg>
-        <pc:spChg chg="add mod">
-          <ac:chgData name="Lines, Todd" userId="afaf7c3a-e8aa-4568-882a-02ad8f9e19b0" providerId="ADAL" clId="{5FF5AC1B-ABA9-43D7-A1E3-2D92732CD6E2}" dt="2026-03-26T16:52:48.172" v="5" actId="1076"/>
-          <ac:spMkLst>
-            <pc:docMk/>
-            <pc:sldMk cId="3438312871" sldId="296"/>
-            <ac:spMk id="13" creationId="{0A1FE6C6-5882-D8BE-D042-C3D5AE120993}"/>
-          </ac:spMkLst>
-        </pc:spChg>
-        <pc:spChg chg="add mod">
-          <ac:chgData name="Lines, Todd" userId="afaf7c3a-e8aa-4568-882a-02ad8f9e19b0" providerId="ADAL" clId="{5FF5AC1B-ABA9-43D7-A1E3-2D92732CD6E2}" dt="2026-03-26T16:52:48.172" v="5" actId="1076"/>
-          <ac:spMkLst>
-            <pc:docMk/>
-            <pc:sldMk cId="3438312871" sldId="296"/>
-            <ac:spMk id="14" creationId="{AB3E82C6-5DEE-80D1-C171-DD52B62A0D6A}"/>
-          </ac:spMkLst>
-        </pc:spChg>
-        <pc:picChg chg="add mod">
-          <ac:chgData name="Lines, Todd" userId="afaf7c3a-e8aa-4568-882a-02ad8f9e19b0" providerId="ADAL" clId="{5FF5AC1B-ABA9-43D7-A1E3-2D92732CD6E2}" dt="2026-03-26T16:52:26.434" v="3" actId="1076"/>
+        <pc:picChg chg="add del mod">
+          <ac:chgData name="Lines, Todd" userId="afaf7c3a-e8aa-4568-882a-02ad8f9e19b0" providerId="ADAL" clId="{5FF5AC1B-ABA9-43D7-A1E3-2D92732CD6E2}" dt="2026-07-06T17:34:18.327" v="32" actId="21"/>
           <ac:picMkLst>
             <pc:docMk/>
-            <pc:sldMk cId="3438312871" sldId="296"/>
-            <ac:picMk id="5" creationId="{4999E9A0-0951-3B3E-D532-FA3315C6F192}"/>
-          </ac:picMkLst>
-        </pc:picChg>
-      </pc:sldChg>
-      <pc:sldChg chg="addSp modSp new mod">
-        <pc:chgData name="Lines, Todd" userId="afaf7c3a-e8aa-4568-882a-02ad8f9e19b0" providerId="ADAL" clId="{5FF5AC1B-ABA9-43D7-A1E3-2D92732CD6E2}" dt="2026-03-26T17:11:56.278" v="12" actId="1076"/>
-        <pc:sldMkLst>
-          <pc:docMk/>
-          <pc:sldMk cId="3659068121" sldId="297"/>
-        </pc:sldMkLst>
-        <pc:picChg chg="add mod">
-          <ac:chgData name="Lines, Todd" userId="afaf7c3a-e8aa-4568-882a-02ad8f9e19b0" providerId="ADAL" clId="{5FF5AC1B-ABA9-43D7-A1E3-2D92732CD6E2}" dt="2026-03-26T17:11:56.278" v="12" actId="1076"/>
-          <ac:picMkLst>
-            <pc:docMk/>
-            <pc:sldMk cId="3659068121" sldId="297"/>
-            <ac:picMk id="5" creationId="{F602D4F0-5A96-E6DD-9CBF-69F40026FBBB}"/>
-          </ac:picMkLst>
-        </pc:picChg>
-      </pc:sldChg>
-      <pc:sldChg chg="addSp modSp new mod">
-        <pc:chgData name="Lines, Todd" userId="afaf7c3a-e8aa-4568-882a-02ad8f9e19b0" providerId="ADAL" clId="{5FF5AC1B-ABA9-43D7-A1E3-2D92732CD6E2}" dt="2026-03-26T17:12:15.459" v="17" actId="1076"/>
-        <pc:sldMkLst>
-          <pc:docMk/>
-          <pc:sldMk cId="3840982716" sldId="298"/>
-        </pc:sldMkLst>
-        <pc:picChg chg="add mod">
-          <ac:chgData name="Lines, Todd" userId="afaf7c3a-e8aa-4568-882a-02ad8f9e19b0" providerId="ADAL" clId="{5FF5AC1B-ABA9-43D7-A1E3-2D92732CD6E2}" dt="2026-03-26T17:12:15.459" v="17" actId="1076"/>
-          <ac:picMkLst>
-            <pc:docMk/>
-            <pc:sldMk cId="3840982716" sldId="298"/>
-            <ac:picMk id="5" creationId="{1F26DA58-8EE4-2338-11A4-B7DB88A33224}"/>
+            <pc:sldMk cId="4146382728" sldId="295"/>
+            <ac:picMk id="3" creationId="{9BCD4178-181A-E5A9-EB47-1B9E3F4595B3}"/>
           </ac:picMkLst>
         </pc:picChg>
       </pc:sldChg>
@@ -411,7 +294,7 @@
           <a:p>
             <a:fld id="{A3DEF62A-1412-4CF8-867F-5D706F932E44}" type="datetimeFigureOut">
               <a:rPr lang="en-US" smtClean="0"/>
-              <a:t>3/30/2026</a:t>
+              <a:t>7/6/2026</a:t>
             </a:fld>
             <a:endParaRPr lang="en-US"/>
           </a:p>
@@ -1051,7 +934,7 @@
             <a:fld id="{84F61AEA-5DA7-4883-91E9-49E96185C8F3}" type="datetimeFigureOut">
               <a:rPr lang="en-US" smtClean="0"/>
               <a:pPr/>
-              <a:t>3/30/2026</a:t>
+              <a:t>7/6/2026</a:t>
             </a:fld>
             <a:endParaRPr lang="en-US"/>
           </a:p>
@@ -1216,7 +1099,7 @@
             <a:fld id="{84F61AEA-5DA7-4883-91E9-49E96185C8F3}" type="datetimeFigureOut">
               <a:rPr lang="en-US" smtClean="0"/>
               <a:pPr/>
-              <a:t>3/30/2026</a:t>
+              <a:t>7/6/2026</a:t>
             </a:fld>
             <a:endParaRPr lang="en-US"/>
           </a:p>
@@ -1391,7 +1274,7 @@
             <a:fld id="{84F61AEA-5DA7-4883-91E9-49E96185C8F3}" type="datetimeFigureOut">
               <a:rPr lang="en-US" smtClean="0"/>
               <a:pPr/>
-              <a:t>3/30/2026</a:t>
+              <a:t>7/6/2026</a:t>
             </a:fld>
             <a:endParaRPr lang="en-US"/>
           </a:p>
@@ -1556,7 +1439,7 @@
             <a:fld id="{84F61AEA-5DA7-4883-91E9-49E96185C8F3}" type="datetimeFigureOut">
               <a:rPr lang="en-US" smtClean="0"/>
               <a:pPr/>
-              <a:t>3/30/2026</a:t>
+              <a:t>7/6/2026</a:t>
             </a:fld>
             <a:endParaRPr lang="en-US"/>
           </a:p>
@@ -1798,7 +1681,7 @@
             <a:fld id="{84F61AEA-5DA7-4883-91E9-49E96185C8F3}" type="datetimeFigureOut">
               <a:rPr lang="en-US" smtClean="0"/>
               <a:pPr/>
-              <a:t>3/30/2026</a:t>
+              <a:t>7/6/2026</a:t>
             </a:fld>
             <a:endParaRPr lang="en-US"/>
           </a:p>
@@ -2080,7 +1963,7 @@
             <a:fld id="{84F61AEA-5DA7-4883-91E9-49E96185C8F3}" type="datetimeFigureOut">
               <a:rPr lang="en-US" smtClean="0"/>
               <a:pPr/>
-              <a:t>3/30/2026</a:t>
+              <a:t>7/6/2026</a:t>
             </a:fld>
             <a:endParaRPr lang="en-US"/>
           </a:p>
@@ -2496,7 +2379,7 @@
             <a:fld id="{84F61AEA-5DA7-4883-91E9-49E96185C8F3}" type="datetimeFigureOut">
               <a:rPr lang="en-US" smtClean="0"/>
               <a:pPr/>
-              <a:t>3/30/2026</a:t>
+              <a:t>7/6/2026</a:t>
             </a:fld>
             <a:endParaRPr lang="en-US"/>
           </a:p>
@@ -2610,7 +2493,7 @@
             <a:fld id="{84F61AEA-5DA7-4883-91E9-49E96185C8F3}" type="datetimeFigureOut">
               <a:rPr lang="en-US" smtClean="0"/>
               <a:pPr/>
-              <a:t>3/30/2026</a:t>
+              <a:t>7/6/2026</a:t>
             </a:fld>
             <a:endParaRPr lang="en-US"/>
           </a:p>
@@ -2702,7 +2585,7 @@
             <a:fld id="{84F61AEA-5DA7-4883-91E9-49E96185C8F3}" type="datetimeFigureOut">
               <a:rPr lang="en-US" smtClean="0"/>
               <a:pPr/>
-              <a:t>3/30/2026</a:t>
+              <a:t>7/6/2026</a:t>
             </a:fld>
             <a:endParaRPr lang="en-US"/>
           </a:p>
@@ -2974,7 +2857,7 @@
             <a:fld id="{84F61AEA-5DA7-4883-91E9-49E96185C8F3}" type="datetimeFigureOut">
               <a:rPr lang="en-US" smtClean="0"/>
               <a:pPr/>
-              <a:t>3/30/2026</a:t>
+              <a:t>7/6/2026</a:t>
             </a:fld>
             <a:endParaRPr lang="en-US"/>
           </a:p>
@@ -3223,7 +3106,7 @@
             <a:fld id="{84F61AEA-5DA7-4883-91E9-49E96185C8F3}" type="datetimeFigureOut">
               <a:rPr lang="en-US" smtClean="0"/>
               <a:pPr/>
-              <a:t>3/30/2026</a:t>
+              <a:t>7/6/2026</a:t>
             </a:fld>
             <a:endParaRPr lang="en-US"/>
           </a:p>
@@ -3431,7 +3314,7 @@
             <a:fld id="{84F61AEA-5DA7-4883-91E9-49E96185C8F3}" type="datetimeFigureOut">
               <a:rPr lang="en-US" smtClean="0"/>
               <a:pPr/>
-              <a:t>3/30/2026</a:t>
+              <a:t>7/6/2026</a:t>
             </a:fld>
             <a:endParaRPr lang="en-US"/>
           </a:p>
@@ -6234,7 +6117,7 @@
         <p:spPr>
           <a:xfrm>
             <a:off x="2513208" y="4172484"/>
-            <a:ext cx="1125629" cy="584775"/>
+            <a:ext cx="1169744" cy="584775"/>
           </a:xfrm>
           <a:prstGeom prst="rect">
             <a:avLst/>
@@ -6248,21 +6131,26 @@
           <a:lstStyle/>
           <a:p>
             <a:r>
-              <a:rPr lang="en-US" sz="3200" dirty="0"/>
+              <a:rPr lang="en-US" sz="3200" dirty="0" err="1"/>
               <a:t>P</a:t>
             </a:r>
             <a:r>
-              <a:rPr lang="en-US" sz="3200" baseline="-25000" dirty="0"/>
-              <a:t>i</a:t>
+              <a:rPr lang="en-US" sz="3200" baseline="-25000" dirty="0" err="1"/>
+              <a:t>f</a:t>
             </a:r>
             <a:r>
               <a:rPr lang="en-US" sz="3200" dirty="0"/>
-              <a:t>    V</a:t>
+              <a:t>    </a:t>
             </a:r>
             <a:r>
-              <a:rPr lang="en-US" sz="3200" baseline="-25000" dirty="0"/>
-              <a:t>i</a:t>
+              <a:rPr lang="en-US" sz="3200" dirty="0" err="1"/>
+              <a:t>V</a:t>
             </a:r>
+            <a:r>
+              <a:rPr lang="en-US" sz="3200" baseline="-25000" dirty="0" err="1"/>
+              <a:t>f</a:t>
+            </a:r>
+            <a:endParaRPr lang="en-US" sz="3200" baseline="-25000" dirty="0"/>
           </a:p>
         </p:txBody>
       </p:sp>
@@ -6281,7 +6169,7 @@
         <p:spPr>
           <a:xfrm>
             <a:off x="2562862" y="1246554"/>
-            <a:ext cx="1076770" cy="584775"/>
+            <a:ext cx="1032655" cy="584775"/>
           </a:xfrm>
           <a:prstGeom prst="rect">
             <a:avLst/>
@@ -6300,21 +6188,16 @@
             </a:r>
             <a:r>
               <a:rPr lang="en-US" sz="3200" baseline="-25000" dirty="0"/>
-              <a:t>f</a:t>
+              <a:t>i</a:t>
             </a:r>
             <a:r>
               <a:rPr lang="en-US" sz="3200" dirty="0"/>
-              <a:t>   </a:t>
+              <a:t>   V</a:t>
             </a:r>
             <a:r>
-              <a:rPr lang="en-US" sz="3200" dirty="0" err="1"/>
-              <a:t>V</a:t>
+              <a:rPr lang="en-US" sz="3200" baseline="-25000" dirty="0"/>
+              <a:t>i</a:t>
             </a:r>
-            <a:r>
-              <a:rPr lang="en-US" sz="3200" baseline="-25000" dirty="0" err="1"/>
-              <a:t>f</a:t>
-            </a:r>
-            <a:endParaRPr lang="en-US" sz="3200" baseline="-25000" dirty="0"/>
           </a:p>
         </p:txBody>
       </p:sp>

</xml_diff>